<commit_message>
Add original article figures to presentation
</commit_message>
<xml_diff>
--- a/heart-failure-older-adult.pptx
+++ b/heart-failure-older-adult.pptx
@@ -2,27 +2,27 @@
 <file path=ppt/presentation.xml><?xml version="1.0" encoding="utf-8"?>
 <p:presentation xmlns:p="http://schemas.openxmlformats.org/presentationml/2006/main">
   <p:sldMasterIdLst>
-    <p:sldMasterId xmlns:r="http://schemas.openxmlformats.org/officeDocument/2006/relationships" id="2147483648" r:id="R5e7588b87ad2499e"/>
+    <p:sldMasterId xmlns:r="http://schemas.openxmlformats.org/officeDocument/2006/relationships" id="2147483648" r:id="Rd9d6539b53e14a47"/>
   </p:sldMasterIdLst>
   <p:notesMasterIdLst>
-    <p:notesMasterId xmlns:r="http://schemas.openxmlformats.org/officeDocument/2006/relationships" r:id="R34df4f168a924198"/>
+    <p:notesMasterId xmlns:r="http://schemas.openxmlformats.org/officeDocument/2006/relationships" r:id="Rd1a5dfbdeeba40e0"/>
   </p:notesMasterIdLst>
   <p:sldIdLst>
-    <p:sldId xmlns:r="http://schemas.openxmlformats.org/officeDocument/2006/relationships" id="256" r:id="Ra90ab317b08046fa"/>
-    <p:sldId xmlns:r="http://schemas.openxmlformats.org/officeDocument/2006/relationships" id="257" r:id="R61a0c9a6dcd64f5d"/>
-    <p:sldId xmlns:r="http://schemas.openxmlformats.org/officeDocument/2006/relationships" id="258" r:id="Rea81256af73b49b9"/>
-    <p:sldId xmlns:r="http://schemas.openxmlformats.org/officeDocument/2006/relationships" id="259" r:id="R1ea6f51540ad4cfc"/>
-    <p:sldId xmlns:r="http://schemas.openxmlformats.org/officeDocument/2006/relationships" id="260" r:id="Rd9fdc2a2be3542b3"/>
-    <p:sldId xmlns:r="http://schemas.openxmlformats.org/officeDocument/2006/relationships" id="261" r:id="Rdd4ed2b878ec4ada"/>
-    <p:sldId xmlns:r="http://schemas.openxmlformats.org/officeDocument/2006/relationships" id="262" r:id="R124bf90593704f66"/>
-    <p:sldId xmlns:r="http://schemas.openxmlformats.org/officeDocument/2006/relationships" id="263" r:id="Rc4fc0e4c9ddb4135"/>
-    <p:sldId xmlns:r="http://schemas.openxmlformats.org/officeDocument/2006/relationships" id="264" r:id="Rdfb6c3055654475f"/>
-    <p:sldId xmlns:r="http://schemas.openxmlformats.org/officeDocument/2006/relationships" id="265" r:id="R2cd89cefef1f4c2c"/>
-    <p:sldId xmlns:r="http://schemas.openxmlformats.org/officeDocument/2006/relationships" id="266" r:id="Ra5de500cad2540df"/>
-    <p:sldId xmlns:r="http://schemas.openxmlformats.org/officeDocument/2006/relationships" id="267" r:id="R176dc46e521449d9"/>
-    <p:sldId xmlns:r="http://schemas.openxmlformats.org/officeDocument/2006/relationships" id="268" r:id="Rbdf9081d8dc144a3"/>
-    <p:sldId xmlns:r="http://schemas.openxmlformats.org/officeDocument/2006/relationships" id="269" r:id="R562e1862ec6f4a76"/>
-    <p:sldId xmlns:r="http://schemas.openxmlformats.org/officeDocument/2006/relationships" id="270" r:id="R8b1ae3a7b5734f51"/>
+    <p:sldId xmlns:r="http://schemas.openxmlformats.org/officeDocument/2006/relationships" id="256" r:id="R638230e4a9d345e8"/>
+    <p:sldId xmlns:r="http://schemas.openxmlformats.org/officeDocument/2006/relationships" id="257" r:id="R3e889768486042c2"/>
+    <p:sldId xmlns:r="http://schemas.openxmlformats.org/officeDocument/2006/relationships" id="258" r:id="R7ac9a576ab224192"/>
+    <p:sldId xmlns:r="http://schemas.openxmlformats.org/officeDocument/2006/relationships" id="259" r:id="R1798cdec936148ef"/>
+    <p:sldId xmlns:r="http://schemas.openxmlformats.org/officeDocument/2006/relationships" id="260" r:id="R1b4773d229314d2a"/>
+    <p:sldId xmlns:r="http://schemas.openxmlformats.org/officeDocument/2006/relationships" id="261" r:id="Rda0b8da6157b49ec"/>
+    <p:sldId xmlns:r="http://schemas.openxmlformats.org/officeDocument/2006/relationships" id="262" r:id="R8c2ecae922794daa"/>
+    <p:sldId xmlns:r="http://schemas.openxmlformats.org/officeDocument/2006/relationships" id="263" r:id="Rf6c3e5be76354ced"/>
+    <p:sldId xmlns:r="http://schemas.openxmlformats.org/officeDocument/2006/relationships" id="264" r:id="R7db83dc414e34c17"/>
+    <p:sldId xmlns:r="http://schemas.openxmlformats.org/officeDocument/2006/relationships" id="265" r:id="Rc01fcb397628472a"/>
+    <p:sldId xmlns:r="http://schemas.openxmlformats.org/officeDocument/2006/relationships" id="266" r:id="R85e969a5bd004659"/>
+    <p:sldId xmlns:r="http://schemas.openxmlformats.org/officeDocument/2006/relationships" id="267" r:id="R752b984d1cde4248"/>
+    <p:sldId xmlns:r="http://schemas.openxmlformats.org/officeDocument/2006/relationships" id="268" r:id="Ra4db7e318c804f7f"/>
+    <p:sldId xmlns:r="http://schemas.openxmlformats.org/officeDocument/2006/relationships" id="269" r:id="Ra1cf1090a9d94654"/>
+    <p:sldId xmlns:r="http://schemas.openxmlformats.org/officeDocument/2006/relationships" id="270" r:id="R63ec37f1e3014863"/>
   </p:sldIdLst>
   <p:sldSz cx="12192000" cy="6858000"/>
   <p:notesSz cx="6858000" cy="9144000"/>
@@ -1539,7 +1539,7 @@
   </p:cSld>
   <p:clrMap bg1="lt1" tx1="dk1" bg2="lt2" tx2="dk2" accent1="accent1" accent2="accent2" accent3="accent3" accent4="accent4" accent5="accent5" accent6="accent6" hlink="hlink" folHlink="folHlink"/>
   <p:sldLayoutIdLst>
-    <p:sldLayoutId xmlns:r="http://schemas.openxmlformats.org/officeDocument/2006/relationships" id="2147483649" r:id="R1c5d03ca5d9348d0"/>
+    <p:sldLayoutId xmlns:r="http://schemas.openxmlformats.org/officeDocument/2006/relationships" id="2147483649" r:id="R4ed4b2f9f7bc456b"/>
   </p:sldLayoutIdLst>
   <p:txStyles>
     <p:titleStyle>
@@ -2090,7 +2090,7 @@
           <p:cNvPr id="1" name="">
             <a:extLst xmlns:a="http://schemas.openxmlformats.org/drawingml/2006/main">
               <a:ext uri="{FF2B5EF4-FFF2-40B4-BE49-F238E27FC236}">
-                <a16:creationId xmlns:a16="http://schemas.microsoft.com/office/drawing/2014/main" id="{D11FB6D6-92C1-4359-B592-BACB46906B56}"/>
+                <a16:creationId xmlns:a16="http://schemas.microsoft.com/office/drawing/2014/main" id="{2D2CBFBF-1744-478A-B9E9-34C6477E97D4}"/>
               </a:ext>
             </a:extLst>
           </p:cNvPr>
@@ -2121,7 +2121,7 @@
           <p:cNvPr id="2" name="">
             <a:extLst xmlns:a="http://schemas.openxmlformats.org/drawingml/2006/main">
               <a:ext uri="{FF2B5EF4-FFF2-40B4-BE49-F238E27FC236}">
-                <a16:creationId xmlns:a16="http://schemas.microsoft.com/office/drawing/2014/main" id="{DE3B3C9C-9518-4383-9423-7C08F078137A}"/>
+                <a16:creationId xmlns:a16="http://schemas.microsoft.com/office/drawing/2014/main" id="{CCD1CC55-ECB5-4D9D-ABF7-7E5E6F047C9C}"/>
               </a:ext>
             </a:extLst>
           </p:cNvPr>
@@ -2152,7 +2152,7 @@
           <p:cNvPr id="3" name="">
             <a:extLst xmlns:a="http://schemas.openxmlformats.org/drawingml/2006/main">
               <a:ext uri="{FF2B5EF4-FFF2-40B4-BE49-F238E27FC236}">
-                <a16:creationId xmlns:a16="http://schemas.microsoft.com/office/drawing/2014/main" id="{116B85BC-264E-4CB2-B0E6-79B4B3468871}"/>
+                <a16:creationId xmlns:a16="http://schemas.microsoft.com/office/drawing/2014/main" id="{8B7D370A-CF30-4262-921C-3DE9A439E82A}"/>
               </a:ext>
             </a:extLst>
           </p:cNvPr>
@@ -2202,7 +2202,7 @@
           <p:cNvPr id="4" name="">
             <a:extLst xmlns:a="http://schemas.openxmlformats.org/drawingml/2006/main">
               <a:ext uri="{FF2B5EF4-FFF2-40B4-BE49-F238E27FC236}">
-                <a16:creationId xmlns:a16="http://schemas.microsoft.com/office/drawing/2014/main" id="{BDC8E75F-1DAC-493A-8F97-5A698B7EF274}"/>
+                <a16:creationId xmlns:a16="http://schemas.microsoft.com/office/drawing/2014/main" id="{6C118768-D7C3-4C68-B5EE-80C6F0906EE0}"/>
               </a:ext>
             </a:extLst>
           </p:cNvPr>
@@ -2252,7 +2252,7 @@
           <p:cNvPr id="5" name="">
             <a:extLst xmlns:a="http://schemas.openxmlformats.org/drawingml/2006/main">
               <a:ext uri="{FF2B5EF4-FFF2-40B4-BE49-F238E27FC236}">
-                <a16:creationId xmlns:a16="http://schemas.microsoft.com/office/drawing/2014/main" id="{2039C406-53FE-416A-8F0C-5B499585C976}"/>
+                <a16:creationId xmlns:a16="http://schemas.microsoft.com/office/drawing/2014/main" id="{C2D5A1F4-AC09-4B35-BA72-356D6E857FED}"/>
               </a:ext>
             </a:extLst>
           </p:cNvPr>
@@ -2302,7 +2302,7 @@
           <p:cNvPr id="6" name="">
             <a:extLst xmlns:a="http://schemas.openxmlformats.org/drawingml/2006/main">
               <a:ext uri="{FF2B5EF4-FFF2-40B4-BE49-F238E27FC236}">
-                <a16:creationId xmlns:a16="http://schemas.microsoft.com/office/drawing/2014/main" id="{B16D2057-3FD4-490D-80A1-920F21F7981F}"/>
+                <a16:creationId xmlns:a16="http://schemas.microsoft.com/office/drawing/2014/main" id="{8AB1EF52-6A72-4F1A-80F7-B29729F0AD00}"/>
               </a:ext>
             </a:extLst>
           </p:cNvPr>
@@ -2337,7 +2337,7 @@
           <p:cNvPr id="7" name="">
             <a:extLst xmlns:a="http://schemas.openxmlformats.org/drawingml/2006/main">
               <a:ext uri="{FF2B5EF4-FFF2-40B4-BE49-F238E27FC236}">
-                <a16:creationId xmlns:a16="http://schemas.microsoft.com/office/drawing/2014/main" id="{734B23F6-3711-42F6-96C1-ECE1F8025227}"/>
+                <a16:creationId xmlns:a16="http://schemas.microsoft.com/office/drawing/2014/main" id="{DF631418-E7E9-451B-8175-867B4F49F457}"/>
               </a:ext>
             </a:extLst>
           </p:cNvPr>
@@ -2387,7 +2387,7 @@
           <p:cNvPr id="8" name="">
             <a:extLst xmlns:a="http://schemas.openxmlformats.org/drawingml/2006/main">
               <a:ext uri="{FF2B5EF4-FFF2-40B4-BE49-F238E27FC236}">
-                <a16:creationId xmlns:a16="http://schemas.microsoft.com/office/drawing/2014/main" id="{9792643B-522B-4E43-AB40-81BFCF97D5C6}"/>
+                <a16:creationId xmlns:a16="http://schemas.microsoft.com/office/drawing/2014/main" id="{BC6DCDBE-053B-4876-8264-6A1A0A8D11A7}"/>
               </a:ext>
             </a:extLst>
           </p:cNvPr>
@@ -2437,7 +2437,7 @@
           <p:cNvPr id="9" name="">
             <a:extLst xmlns:a="http://schemas.openxmlformats.org/drawingml/2006/main">
               <a:ext uri="{FF2B5EF4-FFF2-40B4-BE49-F238E27FC236}">
-                <a16:creationId xmlns:a16="http://schemas.microsoft.com/office/drawing/2014/main" id="{3102270E-FC46-4500-981F-7E96EC9B586E}"/>
+                <a16:creationId xmlns:a16="http://schemas.microsoft.com/office/drawing/2014/main" id="{D7FBA3BD-E726-469C-9859-D8991043B506}"/>
               </a:ext>
             </a:extLst>
           </p:cNvPr>
@@ -2472,7 +2472,7 @@
           <p:cNvPr id="10" name="">
             <a:extLst xmlns:a="http://schemas.openxmlformats.org/drawingml/2006/main">
               <a:ext uri="{FF2B5EF4-FFF2-40B4-BE49-F238E27FC236}">
-                <a16:creationId xmlns:a16="http://schemas.microsoft.com/office/drawing/2014/main" id="{7B50FC07-A1B7-4609-9647-BA7A771B5131}"/>
+                <a16:creationId xmlns:a16="http://schemas.microsoft.com/office/drawing/2014/main" id="{9380C29A-A869-47AE-83D5-64CEF3BC124C}"/>
               </a:ext>
             </a:extLst>
           </p:cNvPr>
@@ -2522,7 +2522,7 @@
           <p:cNvPr id="11" name="">
             <a:extLst xmlns:a="http://schemas.openxmlformats.org/drawingml/2006/main">
               <a:ext uri="{FF2B5EF4-FFF2-40B4-BE49-F238E27FC236}">
-                <a16:creationId xmlns:a16="http://schemas.microsoft.com/office/drawing/2014/main" id="{1C320847-8D63-4ACD-9E0D-96C4E85DC070}"/>
+                <a16:creationId xmlns:a16="http://schemas.microsoft.com/office/drawing/2014/main" id="{DFBC5846-2C7C-42AE-BBAB-80A748349EA8}"/>
               </a:ext>
             </a:extLst>
           </p:cNvPr>
@@ -2572,7 +2572,7 @@
           <p:cNvPr id="12" name="">
             <a:extLst xmlns:a="http://schemas.openxmlformats.org/drawingml/2006/main">
               <a:ext uri="{FF2B5EF4-FFF2-40B4-BE49-F238E27FC236}">
-                <a16:creationId xmlns:a16="http://schemas.microsoft.com/office/drawing/2014/main" id="{BDF2810C-A619-41B9-ABF2-78B9C3F25CF9}"/>
+                <a16:creationId xmlns:a16="http://schemas.microsoft.com/office/drawing/2014/main" id="{6EE82A2F-7E6D-4889-8DB3-828E388D6B44}"/>
               </a:ext>
             </a:extLst>
           </p:cNvPr>
@@ -2622,7 +2622,7 @@
           <p:cNvPr id="13" name="">
             <a:extLst xmlns:a="http://schemas.openxmlformats.org/drawingml/2006/main">
               <a:ext uri="{FF2B5EF4-FFF2-40B4-BE49-F238E27FC236}">
-                <a16:creationId xmlns:a16="http://schemas.microsoft.com/office/drawing/2014/main" id="{AD6BAA2B-F9AB-43E1-B50F-B2CD048B8D7B}"/>
+                <a16:creationId xmlns:a16="http://schemas.microsoft.com/office/drawing/2014/main" id="{A18DD725-207E-4408-9BE6-A39280A512C4}"/>
               </a:ext>
             </a:extLst>
           </p:cNvPr>
@@ -2672,7 +2672,7 @@
           <p:cNvPr id="14" name="">
             <a:extLst xmlns:a="http://schemas.openxmlformats.org/drawingml/2006/main">
               <a:ext uri="{FF2B5EF4-FFF2-40B4-BE49-F238E27FC236}">
-                <a16:creationId xmlns:a16="http://schemas.microsoft.com/office/drawing/2014/main" id="{E191436D-5CD3-4BE1-9BCC-99B05E3CE794}"/>
+                <a16:creationId xmlns:a16="http://schemas.microsoft.com/office/drawing/2014/main" id="{569CE476-3655-426E-9073-056A63F3B806}"/>
               </a:ext>
             </a:extLst>
           </p:cNvPr>
@@ -2722,7 +2722,7 @@
           <p:cNvPr id="15" name="">
             <a:extLst xmlns:a="http://schemas.openxmlformats.org/drawingml/2006/main">
               <a:ext uri="{FF2B5EF4-FFF2-40B4-BE49-F238E27FC236}">
-                <a16:creationId xmlns:a16="http://schemas.microsoft.com/office/drawing/2014/main" id="{95AA9655-76DF-433D-AD89-97AB0BEFDD63}"/>
+                <a16:creationId xmlns:a16="http://schemas.microsoft.com/office/drawing/2014/main" id="{F876788C-7BE7-4782-B862-7FE14B28E5B5}"/>
               </a:ext>
             </a:extLst>
           </p:cNvPr>
@@ -2759,7 +2759,7 @@
           <p:cNvPr id="16" name="">
             <a:extLst xmlns:a="http://schemas.openxmlformats.org/drawingml/2006/main">
               <a:ext uri="{FF2B5EF4-FFF2-40B4-BE49-F238E27FC236}">
-                <a16:creationId xmlns:a16="http://schemas.microsoft.com/office/drawing/2014/main" id="{922D6DFF-7454-4043-8ED6-D1B88FE67B26}"/>
+                <a16:creationId xmlns:a16="http://schemas.microsoft.com/office/drawing/2014/main" id="{B42760F7-49CD-4EAC-A2B3-9E889F498D7F}"/>
               </a:ext>
             </a:extLst>
           </p:cNvPr>
@@ -2807,7 +2807,7 @@
     </p:spTree>
     <p:extLst>
       <p:ext uri="{BB962C8B-B14F-4D97-AF65-F5344CB8AC3E}">
-        <p14:creationId xmlns:p14="http://schemas.microsoft.com/office/powerpoint/2010/main" val="1250668040"/>
+        <p14:creationId xmlns:p14="http://schemas.microsoft.com/office/powerpoint/2010/main" val="1384956650"/>
       </p:ext>
     </p:extLst>
   </p:cSld>
@@ -2838,7 +2838,7 @@
           <p:cNvPr id="1" name="">
             <a:extLst xmlns:a="http://schemas.openxmlformats.org/drawingml/2006/main">
               <a:ext uri="{FF2B5EF4-FFF2-40B4-BE49-F238E27FC236}">
-                <a16:creationId xmlns:a16="http://schemas.microsoft.com/office/drawing/2014/main" id="{8A050ABD-B304-4956-85CA-6A95B0A9E973}"/>
+                <a16:creationId xmlns:a16="http://schemas.microsoft.com/office/drawing/2014/main" id="{E6741F9C-01DA-4D2E-9214-FB630136D131}"/>
               </a:ext>
             </a:extLst>
           </p:cNvPr>
@@ -2888,7 +2888,7 @@
           <p:cNvPr id="2" name="">
             <a:extLst xmlns:a="http://schemas.openxmlformats.org/drawingml/2006/main">
               <a:ext uri="{FF2B5EF4-FFF2-40B4-BE49-F238E27FC236}">
-                <a16:creationId xmlns:a16="http://schemas.microsoft.com/office/drawing/2014/main" id="{C974D493-7903-4700-8262-83B90B0C738E}"/>
+                <a16:creationId xmlns:a16="http://schemas.microsoft.com/office/drawing/2014/main" id="{231D6EC3-5292-4942-BD87-6A07446534D3}"/>
               </a:ext>
             </a:extLst>
           </p:cNvPr>
@@ -2938,7 +2938,7 @@
           <p:cNvPr id="3" name="">
             <a:extLst xmlns:a="http://schemas.openxmlformats.org/drawingml/2006/main">
               <a:ext uri="{FF2B5EF4-FFF2-40B4-BE49-F238E27FC236}">
-                <a16:creationId xmlns:a16="http://schemas.microsoft.com/office/drawing/2014/main" id="{2A58A2F8-30E7-493A-BB1B-ACED2F3B6D54}"/>
+                <a16:creationId xmlns:a16="http://schemas.microsoft.com/office/drawing/2014/main" id="{57FCB0D1-F866-4172-AFCC-62B9629137E1}"/>
               </a:ext>
             </a:extLst>
           </p:cNvPr>
@@ -2969,7 +2969,7 @@
           <p:cNvPr id="4" name="">
             <a:extLst xmlns:a="http://schemas.openxmlformats.org/drawingml/2006/main">
               <a:ext uri="{FF2B5EF4-FFF2-40B4-BE49-F238E27FC236}">
-                <a16:creationId xmlns:a16="http://schemas.microsoft.com/office/drawing/2014/main" id="{B266C17D-C059-492C-A6E2-FF680E9ECC45}"/>
+                <a16:creationId xmlns:a16="http://schemas.microsoft.com/office/drawing/2014/main" id="{C0048821-2CBB-4EF6-B7B1-ED99C7DEB1E8}"/>
               </a:ext>
             </a:extLst>
           </p:cNvPr>
@@ -3019,7 +3019,7 @@
           <p:cNvPr id="5" name="">
             <a:extLst xmlns:a="http://schemas.openxmlformats.org/drawingml/2006/main">
               <a:ext uri="{FF2B5EF4-FFF2-40B4-BE49-F238E27FC236}">
-                <a16:creationId xmlns:a16="http://schemas.microsoft.com/office/drawing/2014/main" id="{7281749F-04B8-4473-AF6F-6FE6CE360BF3}"/>
+                <a16:creationId xmlns:a16="http://schemas.microsoft.com/office/drawing/2014/main" id="{A4C830D1-0298-4C7D-9C89-3E1D8F990F5B}"/>
               </a:ext>
             </a:extLst>
           </p:cNvPr>
@@ -3069,7 +3069,7 @@
           <p:cNvPr id="6" name="">
             <a:extLst xmlns:a="http://schemas.openxmlformats.org/drawingml/2006/main">
               <a:ext uri="{FF2B5EF4-FFF2-40B4-BE49-F238E27FC236}">
-                <a16:creationId xmlns:a16="http://schemas.microsoft.com/office/drawing/2014/main" id="{A5AF148A-9A95-49A4-B05E-45B0DD3A3ABF}"/>
+                <a16:creationId xmlns:a16="http://schemas.microsoft.com/office/drawing/2014/main" id="{22F95B1C-5A70-41CA-BF52-1A7DBD1AE101}"/>
               </a:ext>
             </a:extLst>
           </p:cNvPr>
@@ -3119,7 +3119,7 @@
           <p:cNvPr id="7" name="">
             <a:extLst xmlns:a="http://schemas.openxmlformats.org/drawingml/2006/main">
               <a:ext uri="{FF2B5EF4-FFF2-40B4-BE49-F238E27FC236}">
-                <a16:creationId xmlns:a16="http://schemas.microsoft.com/office/drawing/2014/main" id="{7F31D442-08A0-48B1-BE05-BFE41E74925B}"/>
+                <a16:creationId xmlns:a16="http://schemas.microsoft.com/office/drawing/2014/main" id="{0ED01CDB-7695-4302-ADE8-176EF0733730}"/>
               </a:ext>
             </a:extLst>
           </p:cNvPr>
@@ -3169,7 +3169,7 @@
           <p:cNvPr id="8" name="">
             <a:extLst xmlns:a="http://schemas.openxmlformats.org/drawingml/2006/main">
               <a:ext uri="{FF2B5EF4-FFF2-40B4-BE49-F238E27FC236}">
-                <a16:creationId xmlns:a16="http://schemas.microsoft.com/office/drawing/2014/main" id="{FF7F8A3E-822F-46A2-9B04-413D29FF9332}"/>
+                <a16:creationId xmlns:a16="http://schemas.microsoft.com/office/drawing/2014/main" id="{A83BFF00-FB61-4243-9069-B6AD56565560}"/>
               </a:ext>
             </a:extLst>
           </p:cNvPr>
@@ -3219,7 +3219,7 @@
           <p:cNvPr id="9" name="">
             <a:extLst xmlns:a="http://schemas.openxmlformats.org/drawingml/2006/main">
               <a:ext uri="{FF2B5EF4-FFF2-40B4-BE49-F238E27FC236}">
-                <a16:creationId xmlns:a16="http://schemas.microsoft.com/office/drawing/2014/main" id="{FA39C504-5D4A-413E-B7AE-5E83D4A10878}"/>
+                <a16:creationId xmlns:a16="http://schemas.microsoft.com/office/drawing/2014/main" id="{6BBAC961-EDE0-4BE5-93BD-91EB555A287B}"/>
               </a:ext>
             </a:extLst>
           </p:cNvPr>
@@ -3269,7 +3269,7 @@
           <p:cNvPr id="10" name="">
             <a:extLst xmlns:a="http://schemas.openxmlformats.org/drawingml/2006/main">
               <a:ext uri="{FF2B5EF4-FFF2-40B4-BE49-F238E27FC236}">
-                <a16:creationId xmlns:a16="http://schemas.microsoft.com/office/drawing/2014/main" id="{812B114C-51A9-41D1-9833-84FF424A27CC}"/>
+                <a16:creationId xmlns:a16="http://schemas.microsoft.com/office/drawing/2014/main" id="{4B45A1CF-20FD-4FFD-A5D7-F2CD111ADD03}"/>
               </a:ext>
             </a:extLst>
           </p:cNvPr>
@@ -3304,7 +3304,7 @@
           <p:cNvPr id="11" name="">
             <a:extLst xmlns:a="http://schemas.openxmlformats.org/drawingml/2006/main">
               <a:ext uri="{FF2B5EF4-FFF2-40B4-BE49-F238E27FC236}">
-                <a16:creationId xmlns:a16="http://schemas.microsoft.com/office/drawing/2014/main" id="{1F140B15-EE64-4B1A-A0BC-304781408547}"/>
+                <a16:creationId xmlns:a16="http://schemas.microsoft.com/office/drawing/2014/main" id="{9F696AEE-F683-4C1F-92CD-B96B8BDFF3F6}"/>
               </a:ext>
             </a:extLst>
           </p:cNvPr>
@@ -3354,7 +3354,7 @@
           <p:cNvPr id="12" name="">
             <a:extLst xmlns:a="http://schemas.openxmlformats.org/drawingml/2006/main">
               <a:ext uri="{FF2B5EF4-FFF2-40B4-BE49-F238E27FC236}">
-                <a16:creationId xmlns:a16="http://schemas.microsoft.com/office/drawing/2014/main" id="{A0A8D034-52E4-462F-A5F0-330ED7EC1F2D}"/>
+                <a16:creationId xmlns:a16="http://schemas.microsoft.com/office/drawing/2014/main" id="{DDC7BDC4-F8B7-4B53-A3CD-9B090EF56E97}"/>
               </a:ext>
             </a:extLst>
           </p:cNvPr>
@@ -3404,7 +3404,7 @@
           <p:cNvPr id="13" name="">
             <a:extLst xmlns:a="http://schemas.openxmlformats.org/drawingml/2006/main">
               <a:ext uri="{FF2B5EF4-FFF2-40B4-BE49-F238E27FC236}">
-                <a16:creationId xmlns:a16="http://schemas.microsoft.com/office/drawing/2014/main" id="{30301877-EE5B-40EB-9BB4-F7C30840F1C3}"/>
+                <a16:creationId xmlns:a16="http://schemas.microsoft.com/office/drawing/2014/main" id="{AFA0B3A2-01B3-4DBB-BF59-A9B51A70A618}"/>
               </a:ext>
             </a:extLst>
           </p:cNvPr>
@@ -3454,7 +3454,7 @@
           <p:cNvPr id="14" name="">
             <a:extLst xmlns:a="http://schemas.openxmlformats.org/drawingml/2006/main">
               <a:ext uri="{FF2B5EF4-FFF2-40B4-BE49-F238E27FC236}">
-                <a16:creationId xmlns:a16="http://schemas.microsoft.com/office/drawing/2014/main" id="{62D77139-DC1A-4091-B967-DCCCB2AA96F9}"/>
+                <a16:creationId xmlns:a16="http://schemas.microsoft.com/office/drawing/2014/main" id="{9BBA6E37-D3DA-4715-8055-3D37FDABE7B4}"/>
               </a:ext>
             </a:extLst>
           </p:cNvPr>
@@ -3491,7 +3491,7 @@
           <p:cNvPr id="15" name="">
             <a:extLst xmlns:a="http://schemas.openxmlformats.org/drawingml/2006/main">
               <a:ext uri="{FF2B5EF4-FFF2-40B4-BE49-F238E27FC236}">
-                <a16:creationId xmlns:a16="http://schemas.microsoft.com/office/drawing/2014/main" id="{DDC76ADB-1C21-45EE-94A1-58971605886F}"/>
+                <a16:creationId xmlns:a16="http://schemas.microsoft.com/office/drawing/2014/main" id="{4B8AF5B6-D2A9-486F-8024-EA8476AD682E}"/>
               </a:ext>
             </a:extLst>
           </p:cNvPr>
@@ -3539,7 +3539,7 @@
     </p:spTree>
     <p:extLst>
       <p:ext uri="{BB962C8B-B14F-4D97-AF65-F5344CB8AC3E}">
-        <p14:creationId xmlns:p14="http://schemas.microsoft.com/office/powerpoint/2010/main" val="219964409"/>
+        <p14:creationId xmlns:p14="http://schemas.microsoft.com/office/powerpoint/2010/main" val="1190650104"/>
       </p:ext>
     </p:extLst>
   </p:cSld>
@@ -3570,7 +3570,7 @@
           <p:cNvPr id="1" name="">
             <a:extLst xmlns:a="http://schemas.openxmlformats.org/drawingml/2006/main">
               <a:ext uri="{FF2B5EF4-FFF2-40B4-BE49-F238E27FC236}">
-                <a16:creationId xmlns:a16="http://schemas.microsoft.com/office/drawing/2014/main" id="{A2CBD1C0-8901-4B0A-9537-B1B596394B53}"/>
+                <a16:creationId xmlns:a16="http://schemas.microsoft.com/office/drawing/2014/main" id="{7336DC42-7ABD-4E0F-B1C1-EC24EE186691}"/>
               </a:ext>
             </a:extLst>
           </p:cNvPr>
@@ -3620,7 +3620,7 @@
           <p:cNvPr id="2" name="">
             <a:extLst xmlns:a="http://schemas.openxmlformats.org/drawingml/2006/main">
               <a:ext uri="{FF2B5EF4-FFF2-40B4-BE49-F238E27FC236}">
-                <a16:creationId xmlns:a16="http://schemas.microsoft.com/office/drawing/2014/main" id="{9B629B75-E1B0-4019-A967-406121886820}"/>
+                <a16:creationId xmlns:a16="http://schemas.microsoft.com/office/drawing/2014/main" id="{697E0ED1-C853-4C6E-BC5D-91EE170C4654}"/>
               </a:ext>
             </a:extLst>
           </p:cNvPr>
@@ -3670,7 +3670,7 @@
           <p:cNvPr id="3" name="">
             <a:extLst xmlns:a="http://schemas.openxmlformats.org/drawingml/2006/main">
               <a:ext uri="{FF2B5EF4-FFF2-40B4-BE49-F238E27FC236}">
-                <a16:creationId xmlns:a16="http://schemas.microsoft.com/office/drawing/2014/main" id="{DD95874F-F4AE-4693-B31F-5A4F3634DE20}"/>
+                <a16:creationId xmlns:a16="http://schemas.microsoft.com/office/drawing/2014/main" id="{DABB8C71-DD31-4AC1-8EBE-519F790D5878}"/>
               </a:ext>
             </a:extLst>
           </p:cNvPr>
@@ -3701,7 +3701,7 @@
           <p:cNvPr id="4" name="">
             <a:extLst xmlns:a="http://schemas.openxmlformats.org/drawingml/2006/main">
               <a:ext uri="{FF2B5EF4-FFF2-40B4-BE49-F238E27FC236}">
-                <a16:creationId xmlns:a16="http://schemas.microsoft.com/office/drawing/2014/main" id="{76133D21-F2AF-493F-978F-5C2D3AA0D391}"/>
+                <a16:creationId xmlns:a16="http://schemas.microsoft.com/office/drawing/2014/main" id="{F0CD216D-119B-44C6-9CFC-DE8A9EA71552}"/>
               </a:ext>
             </a:extLst>
           </p:cNvPr>
@@ -3751,7 +3751,7 @@
           <p:cNvPr id="5" name="">
             <a:extLst xmlns:a="http://schemas.openxmlformats.org/drawingml/2006/main">
               <a:ext uri="{FF2B5EF4-FFF2-40B4-BE49-F238E27FC236}">
-                <a16:creationId xmlns:a16="http://schemas.microsoft.com/office/drawing/2014/main" id="{B750BDF8-328D-4187-BB59-98DC41BE3DFD}"/>
+                <a16:creationId xmlns:a16="http://schemas.microsoft.com/office/drawing/2014/main" id="{5A0D3A5F-0712-40A3-B648-ACFAA957B382}"/>
               </a:ext>
             </a:extLst>
           </p:cNvPr>
@@ -3801,7 +3801,7 @@
           <p:cNvPr id="6" name="">
             <a:extLst xmlns:a="http://schemas.openxmlformats.org/drawingml/2006/main">
               <a:ext uri="{FF2B5EF4-FFF2-40B4-BE49-F238E27FC236}">
-                <a16:creationId xmlns:a16="http://schemas.microsoft.com/office/drawing/2014/main" id="{5715EB4C-02B4-4CA1-8523-448E4058CE34}"/>
+                <a16:creationId xmlns:a16="http://schemas.microsoft.com/office/drawing/2014/main" id="{7A97B9CD-F5C5-471F-B7FB-400C9D175E2C}"/>
               </a:ext>
             </a:extLst>
           </p:cNvPr>
@@ -3851,7 +3851,7 @@
           <p:cNvPr id="7" name="">
             <a:extLst xmlns:a="http://schemas.openxmlformats.org/drawingml/2006/main">
               <a:ext uri="{FF2B5EF4-FFF2-40B4-BE49-F238E27FC236}">
-                <a16:creationId xmlns:a16="http://schemas.microsoft.com/office/drawing/2014/main" id="{0410651E-7ACE-46AA-BF4C-075DD2F059F3}"/>
+                <a16:creationId xmlns:a16="http://schemas.microsoft.com/office/drawing/2014/main" id="{505E9AAE-156E-43C6-886C-62A4FC806E6F}"/>
               </a:ext>
             </a:extLst>
           </p:cNvPr>
@@ -3901,7 +3901,7 @@
           <p:cNvPr id="8" name="">
             <a:extLst xmlns:a="http://schemas.openxmlformats.org/drawingml/2006/main">
               <a:ext uri="{FF2B5EF4-FFF2-40B4-BE49-F238E27FC236}">
-                <a16:creationId xmlns:a16="http://schemas.microsoft.com/office/drawing/2014/main" id="{39A09FF4-DC9F-45D0-9557-764B0F677124}"/>
+                <a16:creationId xmlns:a16="http://schemas.microsoft.com/office/drawing/2014/main" id="{4D330FA7-7790-41A5-9D1F-04F6828F5275}"/>
               </a:ext>
             </a:extLst>
           </p:cNvPr>
@@ -3951,7 +3951,7 @@
           <p:cNvPr id="9" name="">
             <a:extLst xmlns:a="http://schemas.openxmlformats.org/drawingml/2006/main">
               <a:ext uri="{FF2B5EF4-FFF2-40B4-BE49-F238E27FC236}">
-                <a16:creationId xmlns:a16="http://schemas.microsoft.com/office/drawing/2014/main" id="{0FF15A7A-B3A4-4BA3-BE92-49C3BA749FE7}"/>
+                <a16:creationId xmlns:a16="http://schemas.microsoft.com/office/drawing/2014/main" id="{5F38086C-3C64-4D78-819A-8F0E0DD14B83}"/>
               </a:ext>
             </a:extLst>
           </p:cNvPr>
@@ -4001,7 +4001,7 @@
           <p:cNvPr id="10" name="">
             <a:extLst xmlns:a="http://schemas.openxmlformats.org/drawingml/2006/main">
               <a:ext uri="{FF2B5EF4-FFF2-40B4-BE49-F238E27FC236}">
-                <a16:creationId xmlns:a16="http://schemas.microsoft.com/office/drawing/2014/main" id="{6AEA9EEB-DC68-49B0-B0F5-504D275CF26C}"/>
+                <a16:creationId xmlns:a16="http://schemas.microsoft.com/office/drawing/2014/main" id="{61BE873F-D749-458F-8BDD-0AF60B40DB1B}"/>
               </a:ext>
             </a:extLst>
           </p:cNvPr>
@@ -4036,7 +4036,7 @@
           <p:cNvPr id="11" name="">
             <a:extLst xmlns:a="http://schemas.openxmlformats.org/drawingml/2006/main">
               <a:ext uri="{FF2B5EF4-FFF2-40B4-BE49-F238E27FC236}">
-                <a16:creationId xmlns:a16="http://schemas.microsoft.com/office/drawing/2014/main" id="{8F33137A-A2B4-438A-803F-8A2B197B15B6}"/>
+                <a16:creationId xmlns:a16="http://schemas.microsoft.com/office/drawing/2014/main" id="{CED3030C-0C43-447B-A735-903C7DAD2E4C}"/>
               </a:ext>
             </a:extLst>
           </p:cNvPr>
@@ -4086,7 +4086,7 @@
           <p:cNvPr id="12" name="">
             <a:extLst xmlns:a="http://schemas.openxmlformats.org/drawingml/2006/main">
               <a:ext uri="{FF2B5EF4-FFF2-40B4-BE49-F238E27FC236}">
-                <a16:creationId xmlns:a16="http://schemas.microsoft.com/office/drawing/2014/main" id="{30B6BCBE-BF18-482C-9920-CD662F70A1EB}"/>
+                <a16:creationId xmlns:a16="http://schemas.microsoft.com/office/drawing/2014/main" id="{ECE962A5-FA58-4B5A-8E48-4C21EA42F7CF}"/>
               </a:ext>
             </a:extLst>
           </p:cNvPr>
@@ -4136,7 +4136,7 @@
           <p:cNvPr id="13" name="">
             <a:extLst xmlns:a="http://schemas.openxmlformats.org/drawingml/2006/main">
               <a:ext uri="{FF2B5EF4-FFF2-40B4-BE49-F238E27FC236}">
-                <a16:creationId xmlns:a16="http://schemas.microsoft.com/office/drawing/2014/main" id="{944A32F7-C4C8-41CC-9A8E-70425DFB2936}"/>
+                <a16:creationId xmlns:a16="http://schemas.microsoft.com/office/drawing/2014/main" id="{7E9EA976-1F0F-4CC3-AB9F-D9E0BCC01009}"/>
               </a:ext>
             </a:extLst>
           </p:cNvPr>
@@ -4186,7 +4186,7 @@
           <p:cNvPr id="14" name="">
             <a:extLst xmlns:a="http://schemas.openxmlformats.org/drawingml/2006/main">
               <a:ext uri="{FF2B5EF4-FFF2-40B4-BE49-F238E27FC236}">
-                <a16:creationId xmlns:a16="http://schemas.microsoft.com/office/drawing/2014/main" id="{963C3F40-8811-4522-BBC7-3BA140B04FF0}"/>
+                <a16:creationId xmlns:a16="http://schemas.microsoft.com/office/drawing/2014/main" id="{E8C3AA37-960D-490B-B7D6-1AB46E292429}"/>
               </a:ext>
             </a:extLst>
           </p:cNvPr>
@@ -4223,7 +4223,7 @@
           <p:cNvPr id="15" name="">
             <a:extLst xmlns:a="http://schemas.openxmlformats.org/drawingml/2006/main">
               <a:ext uri="{FF2B5EF4-FFF2-40B4-BE49-F238E27FC236}">
-                <a16:creationId xmlns:a16="http://schemas.microsoft.com/office/drawing/2014/main" id="{C987988A-998D-450D-91C8-6734878F777B}"/>
+                <a16:creationId xmlns:a16="http://schemas.microsoft.com/office/drawing/2014/main" id="{BE67CC2F-5F3C-46FD-A216-0238D83A2408}"/>
               </a:ext>
             </a:extLst>
           </p:cNvPr>
@@ -4271,7 +4271,7 @@
     </p:spTree>
     <p:extLst>
       <p:ext uri="{BB962C8B-B14F-4D97-AF65-F5344CB8AC3E}">
-        <p14:creationId xmlns:p14="http://schemas.microsoft.com/office/powerpoint/2010/main" val="970708956"/>
+        <p14:creationId xmlns:p14="http://schemas.microsoft.com/office/powerpoint/2010/main" val="185796843"/>
       </p:ext>
     </p:extLst>
   </p:cSld>
@@ -4302,7 +4302,7 @@
           <p:cNvPr id="1" name="">
             <a:extLst xmlns:a="http://schemas.openxmlformats.org/drawingml/2006/main">
               <a:ext uri="{FF2B5EF4-FFF2-40B4-BE49-F238E27FC236}">
-                <a16:creationId xmlns:a16="http://schemas.microsoft.com/office/drawing/2014/main" id="{283900D3-2B97-48A2-BF92-097F96F55588}"/>
+                <a16:creationId xmlns:a16="http://schemas.microsoft.com/office/drawing/2014/main" id="{5F6A0BFF-A8EA-4B6C-8450-DCF3E646D7D4}"/>
               </a:ext>
             </a:extLst>
           </p:cNvPr>
@@ -4352,7 +4352,7 @@
           <p:cNvPr id="2" name="">
             <a:extLst xmlns:a="http://schemas.openxmlformats.org/drawingml/2006/main">
               <a:ext uri="{FF2B5EF4-FFF2-40B4-BE49-F238E27FC236}">
-                <a16:creationId xmlns:a16="http://schemas.microsoft.com/office/drawing/2014/main" id="{83A0150F-4511-499C-A283-111E28B4CA57}"/>
+                <a16:creationId xmlns:a16="http://schemas.microsoft.com/office/drawing/2014/main" id="{CA933D4D-8DB3-4339-9902-4749F9F4BAB3}"/>
               </a:ext>
             </a:extLst>
           </p:cNvPr>
@@ -4402,7 +4402,7 @@
           <p:cNvPr id="3" name="">
             <a:extLst xmlns:a="http://schemas.openxmlformats.org/drawingml/2006/main">
               <a:ext uri="{FF2B5EF4-FFF2-40B4-BE49-F238E27FC236}">
-                <a16:creationId xmlns:a16="http://schemas.microsoft.com/office/drawing/2014/main" id="{F53C05C4-5A8A-4177-B390-F2628A4E3D53}"/>
+                <a16:creationId xmlns:a16="http://schemas.microsoft.com/office/drawing/2014/main" id="{01AFE1DB-30FB-4DF8-9DC6-62182190CB36}"/>
               </a:ext>
             </a:extLst>
           </p:cNvPr>
@@ -4433,7 +4433,7 @@
           <p:cNvPr id="4" name="">
             <a:extLst xmlns:a="http://schemas.openxmlformats.org/drawingml/2006/main">
               <a:ext uri="{FF2B5EF4-FFF2-40B4-BE49-F238E27FC236}">
-                <a16:creationId xmlns:a16="http://schemas.microsoft.com/office/drawing/2014/main" id="{90AAF8AC-4EB6-4605-842B-807FCEF1431B}"/>
+                <a16:creationId xmlns:a16="http://schemas.microsoft.com/office/drawing/2014/main" id="{1375475B-3CEC-41A1-9C0D-C3CEA9BDBA85}"/>
               </a:ext>
             </a:extLst>
           </p:cNvPr>
@@ -4468,7 +4468,7 @@
           <p:cNvPr id="5" name="">
             <a:extLst xmlns:a="http://schemas.openxmlformats.org/drawingml/2006/main">
               <a:ext uri="{FF2B5EF4-FFF2-40B4-BE49-F238E27FC236}">
-                <a16:creationId xmlns:a16="http://schemas.microsoft.com/office/drawing/2014/main" id="{F9A885DC-044C-4BDC-8B2A-0E96A95BF23B}"/>
+                <a16:creationId xmlns:a16="http://schemas.microsoft.com/office/drawing/2014/main" id="{C26BB4A1-87FE-43E7-9C7D-E6D16ADD28D4}"/>
               </a:ext>
             </a:extLst>
           </p:cNvPr>
@@ -4501,7 +4501,7 @@
           <p:cNvPr id="6" name="">
             <a:extLst xmlns:a="http://schemas.openxmlformats.org/drawingml/2006/main">
               <a:ext uri="{FF2B5EF4-FFF2-40B4-BE49-F238E27FC236}">
-                <a16:creationId xmlns:a16="http://schemas.microsoft.com/office/drawing/2014/main" id="{3C778BBD-A4E8-4043-A335-3131567E1C0B}"/>
+                <a16:creationId xmlns:a16="http://schemas.microsoft.com/office/drawing/2014/main" id="{59EC1FD9-7CA6-49AA-80BD-CD8469E99F61}"/>
               </a:ext>
             </a:extLst>
           </p:cNvPr>
@@ -4551,7 +4551,7 @@
           <p:cNvPr id="7" name="">
             <a:extLst xmlns:a="http://schemas.openxmlformats.org/drawingml/2006/main">
               <a:ext uri="{FF2B5EF4-FFF2-40B4-BE49-F238E27FC236}">
-                <a16:creationId xmlns:a16="http://schemas.microsoft.com/office/drawing/2014/main" id="{61D30596-2EE9-4B50-ABCE-A0131A642FF9}"/>
+                <a16:creationId xmlns:a16="http://schemas.microsoft.com/office/drawing/2014/main" id="{AAA160B8-4A61-463D-B5A9-7B0ED7FDBF4C}"/>
               </a:ext>
             </a:extLst>
           </p:cNvPr>
@@ -4601,7 +4601,7 @@
           <p:cNvPr id="8" name="">
             <a:extLst xmlns:a="http://schemas.openxmlformats.org/drawingml/2006/main">
               <a:ext uri="{FF2B5EF4-FFF2-40B4-BE49-F238E27FC236}">
-                <a16:creationId xmlns:a16="http://schemas.microsoft.com/office/drawing/2014/main" id="{8791BE4A-0F71-40BE-869C-410E428C9108}"/>
+                <a16:creationId xmlns:a16="http://schemas.microsoft.com/office/drawing/2014/main" id="{9A535B93-2B15-4421-894A-56A4255615EC}"/>
               </a:ext>
             </a:extLst>
           </p:cNvPr>
@@ -4651,7 +4651,7 @@
           <p:cNvPr id="9" name="">
             <a:extLst xmlns:a="http://schemas.openxmlformats.org/drawingml/2006/main">
               <a:ext uri="{FF2B5EF4-FFF2-40B4-BE49-F238E27FC236}">
-                <a16:creationId xmlns:a16="http://schemas.microsoft.com/office/drawing/2014/main" id="{1BDB668B-09B3-444D-A6AD-B838249E8DCE}"/>
+                <a16:creationId xmlns:a16="http://schemas.microsoft.com/office/drawing/2014/main" id="{66219989-08E8-4FE7-A502-EFC0BC61F5E3}"/>
               </a:ext>
             </a:extLst>
           </p:cNvPr>
@@ -4682,7 +4682,7 @@
           <p:cNvPr id="10" name="">
             <a:extLst xmlns:a="http://schemas.openxmlformats.org/drawingml/2006/main">
               <a:ext uri="{FF2B5EF4-FFF2-40B4-BE49-F238E27FC236}">
-                <a16:creationId xmlns:a16="http://schemas.microsoft.com/office/drawing/2014/main" id="{EFABC462-6D32-4093-85DD-E2139D2CDC1B}"/>
+                <a16:creationId xmlns:a16="http://schemas.microsoft.com/office/drawing/2014/main" id="{B2D6EC50-61C8-4CA5-ADE6-F60E72A41A02}"/>
               </a:ext>
             </a:extLst>
           </p:cNvPr>
@@ -4717,7 +4717,7 @@
           <p:cNvPr id="11" name="">
             <a:extLst xmlns:a="http://schemas.openxmlformats.org/drawingml/2006/main">
               <a:ext uri="{FF2B5EF4-FFF2-40B4-BE49-F238E27FC236}">
-                <a16:creationId xmlns:a16="http://schemas.microsoft.com/office/drawing/2014/main" id="{D3A2DC01-0FF2-4ACC-998C-ACF5125687CA}"/>
+                <a16:creationId xmlns:a16="http://schemas.microsoft.com/office/drawing/2014/main" id="{1CF73567-0FEA-44F7-B488-973C4C0F2236}"/>
               </a:ext>
             </a:extLst>
           </p:cNvPr>
@@ -4750,7 +4750,7 @@
           <p:cNvPr id="12" name="">
             <a:extLst xmlns:a="http://schemas.openxmlformats.org/drawingml/2006/main">
               <a:ext uri="{FF2B5EF4-FFF2-40B4-BE49-F238E27FC236}">
-                <a16:creationId xmlns:a16="http://schemas.microsoft.com/office/drawing/2014/main" id="{DA2EBA58-E30C-4A0E-BD80-ACD0F316279B}"/>
+                <a16:creationId xmlns:a16="http://schemas.microsoft.com/office/drawing/2014/main" id="{A4AD8630-34A5-4C39-AA88-3656200D82FE}"/>
               </a:ext>
             </a:extLst>
           </p:cNvPr>
@@ -4800,7 +4800,7 @@
           <p:cNvPr id="13" name="">
             <a:extLst xmlns:a="http://schemas.openxmlformats.org/drawingml/2006/main">
               <a:ext uri="{FF2B5EF4-FFF2-40B4-BE49-F238E27FC236}">
-                <a16:creationId xmlns:a16="http://schemas.microsoft.com/office/drawing/2014/main" id="{4019D89E-84AA-4C7C-BC10-480CF02F3166}"/>
+                <a16:creationId xmlns:a16="http://schemas.microsoft.com/office/drawing/2014/main" id="{1546C2E8-F311-4023-8863-9B82CF0D4F3A}"/>
               </a:ext>
             </a:extLst>
           </p:cNvPr>
@@ -4850,7 +4850,7 @@
           <p:cNvPr id="14" name="">
             <a:extLst xmlns:a="http://schemas.openxmlformats.org/drawingml/2006/main">
               <a:ext uri="{FF2B5EF4-FFF2-40B4-BE49-F238E27FC236}">
-                <a16:creationId xmlns:a16="http://schemas.microsoft.com/office/drawing/2014/main" id="{4F4EA077-CA2B-4268-8A27-3A58E3E224EE}"/>
+                <a16:creationId xmlns:a16="http://schemas.microsoft.com/office/drawing/2014/main" id="{E1FC5F95-A678-4580-ADAB-36C53DCBD2FD}"/>
               </a:ext>
             </a:extLst>
           </p:cNvPr>
@@ -4900,7 +4900,7 @@
           <p:cNvPr id="15" name="">
             <a:extLst xmlns:a="http://schemas.openxmlformats.org/drawingml/2006/main">
               <a:ext uri="{FF2B5EF4-FFF2-40B4-BE49-F238E27FC236}">
-                <a16:creationId xmlns:a16="http://schemas.microsoft.com/office/drawing/2014/main" id="{2405BDF0-5751-4392-9B0B-6C525FA88F57}"/>
+                <a16:creationId xmlns:a16="http://schemas.microsoft.com/office/drawing/2014/main" id="{D5DAB5DF-8D03-4913-99D0-64C58326868D}"/>
               </a:ext>
             </a:extLst>
           </p:cNvPr>
@@ -4931,7 +4931,7 @@
           <p:cNvPr id="16" name="">
             <a:extLst xmlns:a="http://schemas.openxmlformats.org/drawingml/2006/main">
               <a:ext uri="{FF2B5EF4-FFF2-40B4-BE49-F238E27FC236}">
-                <a16:creationId xmlns:a16="http://schemas.microsoft.com/office/drawing/2014/main" id="{8D975A46-6D4B-45FF-8708-A8B2EE63A290}"/>
+                <a16:creationId xmlns:a16="http://schemas.microsoft.com/office/drawing/2014/main" id="{79C6A24E-57C9-4C5F-B098-D6552F6729A3}"/>
               </a:ext>
             </a:extLst>
           </p:cNvPr>
@@ -4966,7 +4966,7 @@
           <p:cNvPr id="17" name="">
             <a:extLst xmlns:a="http://schemas.openxmlformats.org/drawingml/2006/main">
               <a:ext uri="{FF2B5EF4-FFF2-40B4-BE49-F238E27FC236}">
-                <a16:creationId xmlns:a16="http://schemas.microsoft.com/office/drawing/2014/main" id="{0F8B1708-80F5-4959-9EF3-8A6D2EDF11A0}"/>
+                <a16:creationId xmlns:a16="http://schemas.microsoft.com/office/drawing/2014/main" id="{9BC8F993-F17B-4125-8345-7F41D6917073}"/>
               </a:ext>
             </a:extLst>
           </p:cNvPr>
@@ -4999,7 +4999,7 @@
           <p:cNvPr id="18" name="">
             <a:extLst xmlns:a="http://schemas.openxmlformats.org/drawingml/2006/main">
               <a:ext uri="{FF2B5EF4-FFF2-40B4-BE49-F238E27FC236}">
-                <a16:creationId xmlns:a16="http://schemas.microsoft.com/office/drawing/2014/main" id="{63F20409-1AD9-4985-95D8-69B062F1276A}"/>
+                <a16:creationId xmlns:a16="http://schemas.microsoft.com/office/drawing/2014/main" id="{D0405F09-B448-4704-9E67-646E0AC89FFD}"/>
               </a:ext>
             </a:extLst>
           </p:cNvPr>
@@ -5049,7 +5049,7 @@
           <p:cNvPr id="19" name="">
             <a:extLst xmlns:a="http://schemas.openxmlformats.org/drawingml/2006/main">
               <a:ext uri="{FF2B5EF4-FFF2-40B4-BE49-F238E27FC236}">
-                <a16:creationId xmlns:a16="http://schemas.microsoft.com/office/drawing/2014/main" id="{88A877F6-3EBC-4405-A3C1-6581135C7372}"/>
+                <a16:creationId xmlns:a16="http://schemas.microsoft.com/office/drawing/2014/main" id="{F292D734-F564-438A-A739-546F22343238}"/>
               </a:ext>
             </a:extLst>
           </p:cNvPr>
@@ -5099,7 +5099,7 @@
           <p:cNvPr id="20" name="">
             <a:extLst xmlns:a="http://schemas.openxmlformats.org/drawingml/2006/main">
               <a:ext uri="{FF2B5EF4-FFF2-40B4-BE49-F238E27FC236}">
-                <a16:creationId xmlns:a16="http://schemas.microsoft.com/office/drawing/2014/main" id="{44C806D0-FE71-4ABD-B9E0-D3C500C433B2}"/>
+                <a16:creationId xmlns:a16="http://schemas.microsoft.com/office/drawing/2014/main" id="{173F557F-D1D1-4EAE-BAF4-3A631AA7DBD4}"/>
               </a:ext>
             </a:extLst>
           </p:cNvPr>
@@ -5149,7 +5149,7 @@
           <p:cNvPr id="21" name="">
             <a:extLst xmlns:a="http://schemas.openxmlformats.org/drawingml/2006/main">
               <a:ext uri="{FF2B5EF4-FFF2-40B4-BE49-F238E27FC236}">
-                <a16:creationId xmlns:a16="http://schemas.microsoft.com/office/drawing/2014/main" id="{57CEFB2D-A627-4A5C-9592-07F8A1D112D9}"/>
+                <a16:creationId xmlns:a16="http://schemas.microsoft.com/office/drawing/2014/main" id="{D4002303-E001-4639-841E-4AD753168FF4}"/>
               </a:ext>
             </a:extLst>
           </p:cNvPr>
@@ -5180,7 +5180,7 @@
           <p:cNvPr id="22" name="">
             <a:extLst xmlns:a="http://schemas.openxmlformats.org/drawingml/2006/main">
               <a:ext uri="{FF2B5EF4-FFF2-40B4-BE49-F238E27FC236}">
-                <a16:creationId xmlns:a16="http://schemas.microsoft.com/office/drawing/2014/main" id="{72D8D244-F991-410B-A88D-7753CB8DDE75}"/>
+                <a16:creationId xmlns:a16="http://schemas.microsoft.com/office/drawing/2014/main" id="{0FC6CBD6-E931-4233-96AE-AE77AE258FDE}"/>
               </a:ext>
             </a:extLst>
           </p:cNvPr>
@@ -5215,7 +5215,7 @@
           <p:cNvPr id="23" name="">
             <a:extLst xmlns:a="http://schemas.openxmlformats.org/drawingml/2006/main">
               <a:ext uri="{FF2B5EF4-FFF2-40B4-BE49-F238E27FC236}">
-                <a16:creationId xmlns:a16="http://schemas.microsoft.com/office/drawing/2014/main" id="{90AE6A56-BB02-4C17-B7C4-E2A78D6AA4BA}"/>
+                <a16:creationId xmlns:a16="http://schemas.microsoft.com/office/drawing/2014/main" id="{E08BDA54-BAE1-4ED5-89A7-B3D641018244}"/>
               </a:ext>
             </a:extLst>
           </p:cNvPr>
@@ -5248,7 +5248,7 @@
           <p:cNvPr id="24" name="">
             <a:extLst xmlns:a="http://schemas.openxmlformats.org/drawingml/2006/main">
               <a:ext uri="{FF2B5EF4-FFF2-40B4-BE49-F238E27FC236}">
-                <a16:creationId xmlns:a16="http://schemas.microsoft.com/office/drawing/2014/main" id="{D3DFFD40-3268-40C5-806D-617450E650C3}"/>
+                <a16:creationId xmlns:a16="http://schemas.microsoft.com/office/drawing/2014/main" id="{5AFA96BE-6A1D-46CC-A7B0-E6B80928D8DA}"/>
               </a:ext>
             </a:extLst>
           </p:cNvPr>
@@ -5298,7 +5298,7 @@
           <p:cNvPr id="25" name="">
             <a:extLst xmlns:a="http://schemas.openxmlformats.org/drawingml/2006/main">
               <a:ext uri="{FF2B5EF4-FFF2-40B4-BE49-F238E27FC236}">
-                <a16:creationId xmlns:a16="http://schemas.microsoft.com/office/drawing/2014/main" id="{2F3B3A47-44B8-49D8-B876-0E4A22BA203E}"/>
+                <a16:creationId xmlns:a16="http://schemas.microsoft.com/office/drawing/2014/main" id="{E9E785A7-19E5-43C1-BEDD-376CF194FBDA}"/>
               </a:ext>
             </a:extLst>
           </p:cNvPr>
@@ -5348,7 +5348,7 @@
           <p:cNvPr id="26" name="">
             <a:extLst xmlns:a="http://schemas.openxmlformats.org/drawingml/2006/main">
               <a:ext uri="{FF2B5EF4-FFF2-40B4-BE49-F238E27FC236}">
-                <a16:creationId xmlns:a16="http://schemas.microsoft.com/office/drawing/2014/main" id="{4E623F76-68D4-4CD4-B9D8-EB93EF33A916}"/>
+                <a16:creationId xmlns:a16="http://schemas.microsoft.com/office/drawing/2014/main" id="{54BC7B56-22BF-4779-8B76-A8C4357EEC0F}"/>
               </a:ext>
             </a:extLst>
           </p:cNvPr>
@@ -5398,7 +5398,7 @@
           <p:cNvPr id="27" name="">
             <a:extLst xmlns:a="http://schemas.openxmlformats.org/drawingml/2006/main">
               <a:ext uri="{FF2B5EF4-FFF2-40B4-BE49-F238E27FC236}">
-                <a16:creationId xmlns:a16="http://schemas.microsoft.com/office/drawing/2014/main" id="{2714CBA7-35D2-4ED3-B55B-A3633CA5FDE7}"/>
+                <a16:creationId xmlns:a16="http://schemas.microsoft.com/office/drawing/2014/main" id="{EFAA10DD-1103-4879-8EF5-9F964FBC9BDB}"/>
               </a:ext>
             </a:extLst>
           </p:cNvPr>
@@ -5429,7 +5429,7 @@
           <p:cNvPr id="28" name="">
             <a:extLst xmlns:a="http://schemas.openxmlformats.org/drawingml/2006/main">
               <a:ext uri="{FF2B5EF4-FFF2-40B4-BE49-F238E27FC236}">
-                <a16:creationId xmlns:a16="http://schemas.microsoft.com/office/drawing/2014/main" id="{9D16B69D-B3FB-41FB-A040-BBC004970DDA}"/>
+                <a16:creationId xmlns:a16="http://schemas.microsoft.com/office/drawing/2014/main" id="{2FDE0633-0323-47A7-872E-EA7B960DA267}"/>
               </a:ext>
             </a:extLst>
           </p:cNvPr>
@@ -5464,7 +5464,7 @@
           <p:cNvPr id="29" name="">
             <a:extLst xmlns:a="http://schemas.openxmlformats.org/drawingml/2006/main">
               <a:ext uri="{FF2B5EF4-FFF2-40B4-BE49-F238E27FC236}">
-                <a16:creationId xmlns:a16="http://schemas.microsoft.com/office/drawing/2014/main" id="{57866AF5-F49E-4D27-B9AD-BB02EB2F1D25}"/>
+                <a16:creationId xmlns:a16="http://schemas.microsoft.com/office/drawing/2014/main" id="{968637BB-8DDC-4511-B485-5F6246675AE8}"/>
               </a:ext>
             </a:extLst>
           </p:cNvPr>
@@ -5497,7 +5497,7 @@
           <p:cNvPr id="30" name="">
             <a:extLst xmlns:a="http://schemas.openxmlformats.org/drawingml/2006/main">
               <a:ext uri="{FF2B5EF4-FFF2-40B4-BE49-F238E27FC236}">
-                <a16:creationId xmlns:a16="http://schemas.microsoft.com/office/drawing/2014/main" id="{EE6B93EF-AF02-4069-99D7-6502CFC21C89}"/>
+                <a16:creationId xmlns:a16="http://schemas.microsoft.com/office/drawing/2014/main" id="{C27AA2C9-5AD5-41C5-81B8-71986CC0F054}"/>
               </a:ext>
             </a:extLst>
           </p:cNvPr>
@@ -5547,7 +5547,7 @@
           <p:cNvPr id="31" name="">
             <a:extLst xmlns:a="http://schemas.openxmlformats.org/drawingml/2006/main">
               <a:ext uri="{FF2B5EF4-FFF2-40B4-BE49-F238E27FC236}">
-                <a16:creationId xmlns:a16="http://schemas.microsoft.com/office/drawing/2014/main" id="{AB18279F-A618-4086-845E-93E789A2108C}"/>
+                <a16:creationId xmlns:a16="http://schemas.microsoft.com/office/drawing/2014/main" id="{9DE67E41-1C9D-4D4D-8148-77D94722B7B5}"/>
               </a:ext>
             </a:extLst>
           </p:cNvPr>
@@ -5597,7 +5597,7 @@
           <p:cNvPr id="32" name="">
             <a:extLst xmlns:a="http://schemas.openxmlformats.org/drawingml/2006/main">
               <a:ext uri="{FF2B5EF4-FFF2-40B4-BE49-F238E27FC236}">
-                <a16:creationId xmlns:a16="http://schemas.microsoft.com/office/drawing/2014/main" id="{5E0FE7CC-9A10-4ABD-B388-03D7E48EF870}"/>
+                <a16:creationId xmlns:a16="http://schemas.microsoft.com/office/drawing/2014/main" id="{E6875004-A74F-4B61-ADB0-0094B9040AA7}"/>
               </a:ext>
             </a:extLst>
           </p:cNvPr>
@@ -5647,7 +5647,7 @@
           <p:cNvPr id="33" name="">
             <a:extLst xmlns:a="http://schemas.openxmlformats.org/drawingml/2006/main">
               <a:ext uri="{FF2B5EF4-FFF2-40B4-BE49-F238E27FC236}">
-                <a16:creationId xmlns:a16="http://schemas.microsoft.com/office/drawing/2014/main" id="{F22F44BE-98C1-4B34-9B29-83A5518BB919}"/>
+                <a16:creationId xmlns:a16="http://schemas.microsoft.com/office/drawing/2014/main" id="{012DCFA9-82EB-47A2-A6CB-77EA3EC2F22F}"/>
               </a:ext>
             </a:extLst>
           </p:cNvPr>
@@ -5697,7 +5697,7 @@
           <p:cNvPr id="34" name="">
             <a:extLst xmlns:a="http://schemas.openxmlformats.org/drawingml/2006/main">
               <a:ext uri="{FF2B5EF4-FFF2-40B4-BE49-F238E27FC236}">
-                <a16:creationId xmlns:a16="http://schemas.microsoft.com/office/drawing/2014/main" id="{75BAF317-9CD2-42FE-A5AE-B1001CA254E2}"/>
+                <a16:creationId xmlns:a16="http://schemas.microsoft.com/office/drawing/2014/main" id="{1F139407-2244-4CA0-816C-AA1D95F9DE1C}"/>
               </a:ext>
             </a:extLst>
           </p:cNvPr>
@@ -5747,7 +5747,7 @@
           <p:cNvPr id="35" name="">
             <a:extLst xmlns:a="http://schemas.openxmlformats.org/drawingml/2006/main">
               <a:ext uri="{FF2B5EF4-FFF2-40B4-BE49-F238E27FC236}">
-                <a16:creationId xmlns:a16="http://schemas.microsoft.com/office/drawing/2014/main" id="{45EFDD62-33AC-4F25-A801-585FA5D1CA68}"/>
+                <a16:creationId xmlns:a16="http://schemas.microsoft.com/office/drawing/2014/main" id="{887169D2-F853-4D38-9553-7103750810FD}"/>
               </a:ext>
             </a:extLst>
           </p:cNvPr>
@@ -5784,7 +5784,7 @@
           <p:cNvPr id="36" name="">
             <a:extLst xmlns:a="http://schemas.openxmlformats.org/drawingml/2006/main">
               <a:ext uri="{FF2B5EF4-FFF2-40B4-BE49-F238E27FC236}">
-                <a16:creationId xmlns:a16="http://schemas.microsoft.com/office/drawing/2014/main" id="{B67E2645-C0CD-4A15-B1D2-81151AA94B55}"/>
+                <a16:creationId xmlns:a16="http://schemas.microsoft.com/office/drawing/2014/main" id="{15DF4B2B-37A8-4A3B-B5D2-1A97339334B5}"/>
               </a:ext>
             </a:extLst>
           </p:cNvPr>
@@ -5832,7 +5832,7 @@
     </p:spTree>
     <p:extLst>
       <p:ext uri="{BB962C8B-B14F-4D97-AF65-F5344CB8AC3E}">
-        <p14:creationId xmlns:p14="http://schemas.microsoft.com/office/powerpoint/2010/main" val="900797442"/>
+        <p14:creationId xmlns:p14="http://schemas.microsoft.com/office/powerpoint/2010/main" val="402463412"/>
       </p:ext>
     </p:extLst>
   </p:cSld>
@@ -5863,7 +5863,7 @@
           <p:cNvPr id="1" name="">
             <a:extLst xmlns:a="http://schemas.openxmlformats.org/drawingml/2006/main">
               <a:ext uri="{FF2B5EF4-FFF2-40B4-BE49-F238E27FC236}">
-                <a16:creationId xmlns:a16="http://schemas.microsoft.com/office/drawing/2014/main" id="{525243D6-F219-4F9A-B459-C1072CC9AF61}"/>
+                <a16:creationId xmlns:a16="http://schemas.microsoft.com/office/drawing/2014/main" id="{FF46C650-7D56-4D0B-830A-85336F013575}"/>
               </a:ext>
             </a:extLst>
           </p:cNvPr>
@@ -5913,7 +5913,7 @@
           <p:cNvPr id="2" name="">
             <a:extLst xmlns:a="http://schemas.openxmlformats.org/drawingml/2006/main">
               <a:ext uri="{FF2B5EF4-FFF2-40B4-BE49-F238E27FC236}">
-                <a16:creationId xmlns:a16="http://schemas.microsoft.com/office/drawing/2014/main" id="{0A2C2C49-408B-4AEA-86C1-81BD96CE8E2A}"/>
+                <a16:creationId xmlns:a16="http://schemas.microsoft.com/office/drawing/2014/main" id="{0327295B-68CD-45E8-9E13-3EE4C4AE26A0}"/>
               </a:ext>
             </a:extLst>
           </p:cNvPr>
@@ -5963,7 +5963,7 @@
           <p:cNvPr id="3" name="">
             <a:extLst xmlns:a="http://schemas.openxmlformats.org/drawingml/2006/main">
               <a:ext uri="{FF2B5EF4-FFF2-40B4-BE49-F238E27FC236}">
-                <a16:creationId xmlns:a16="http://schemas.microsoft.com/office/drawing/2014/main" id="{D5096C22-ED9E-4C04-B818-28E99053F740}"/>
+                <a16:creationId xmlns:a16="http://schemas.microsoft.com/office/drawing/2014/main" id="{2B39E712-BA41-4ED3-AE39-58DECBFEBB4B}"/>
               </a:ext>
             </a:extLst>
           </p:cNvPr>
@@ -5994,7 +5994,7 @@
           <p:cNvPr id="4" name="">
             <a:extLst xmlns:a="http://schemas.openxmlformats.org/drawingml/2006/main">
               <a:ext uri="{FF2B5EF4-FFF2-40B4-BE49-F238E27FC236}">
-                <a16:creationId xmlns:a16="http://schemas.microsoft.com/office/drawing/2014/main" id="{6B6262BA-C887-4A75-9E38-CA3C4EB4DF8F}"/>
+                <a16:creationId xmlns:a16="http://schemas.microsoft.com/office/drawing/2014/main" id="{118B03F2-25B8-47EA-BF33-42C3DE0D8139}"/>
               </a:ext>
             </a:extLst>
           </p:cNvPr>
@@ -6044,7 +6044,7 @@
           <p:cNvPr id="5" name="">
             <a:extLst xmlns:a="http://schemas.openxmlformats.org/drawingml/2006/main">
               <a:ext uri="{FF2B5EF4-FFF2-40B4-BE49-F238E27FC236}">
-                <a16:creationId xmlns:a16="http://schemas.microsoft.com/office/drawing/2014/main" id="{8BCDB632-8A09-4A31-96A8-A46F21DA59A5}"/>
+                <a16:creationId xmlns:a16="http://schemas.microsoft.com/office/drawing/2014/main" id="{E85F6D44-7150-4A4A-A037-93E7DB911AC4}"/>
               </a:ext>
             </a:extLst>
           </p:cNvPr>
@@ -6094,7 +6094,7 @@
           <p:cNvPr id="6" name="">
             <a:extLst xmlns:a="http://schemas.openxmlformats.org/drawingml/2006/main">
               <a:ext uri="{FF2B5EF4-FFF2-40B4-BE49-F238E27FC236}">
-                <a16:creationId xmlns:a16="http://schemas.microsoft.com/office/drawing/2014/main" id="{EFC985DF-2FA6-4C4C-8E16-A5B87B53D3F3}"/>
+                <a16:creationId xmlns:a16="http://schemas.microsoft.com/office/drawing/2014/main" id="{20DAF0CB-689D-473F-8BF7-B5A2B3DDBD44}"/>
               </a:ext>
             </a:extLst>
           </p:cNvPr>
@@ -6144,7 +6144,7 @@
           <p:cNvPr id="7" name="">
             <a:extLst xmlns:a="http://schemas.openxmlformats.org/drawingml/2006/main">
               <a:ext uri="{FF2B5EF4-FFF2-40B4-BE49-F238E27FC236}">
-                <a16:creationId xmlns:a16="http://schemas.microsoft.com/office/drawing/2014/main" id="{46803CAA-36CD-4DCD-9165-8068922330D5}"/>
+                <a16:creationId xmlns:a16="http://schemas.microsoft.com/office/drawing/2014/main" id="{C5F3CCF1-8BB1-4070-8946-A6AD0FBCE87E}"/>
               </a:ext>
             </a:extLst>
           </p:cNvPr>
@@ -6194,7 +6194,7 @@
           <p:cNvPr id="8" name="">
             <a:extLst xmlns:a="http://schemas.openxmlformats.org/drawingml/2006/main">
               <a:ext uri="{FF2B5EF4-FFF2-40B4-BE49-F238E27FC236}">
-                <a16:creationId xmlns:a16="http://schemas.microsoft.com/office/drawing/2014/main" id="{EF5E8294-B1D7-4CE4-ACAE-E82C9499B175}"/>
+                <a16:creationId xmlns:a16="http://schemas.microsoft.com/office/drawing/2014/main" id="{44732508-9C0E-406F-B2FA-DE9A78C1A162}"/>
               </a:ext>
             </a:extLst>
           </p:cNvPr>
@@ -6244,7 +6244,7 @@
           <p:cNvPr id="9" name="">
             <a:extLst xmlns:a="http://schemas.openxmlformats.org/drawingml/2006/main">
               <a:ext uri="{FF2B5EF4-FFF2-40B4-BE49-F238E27FC236}">
-                <a16:creationId xmlns:a16="http://schemas.microsoft.com/office/drawing/2014/main" id="{731D4DEA-6AD9-40E3-A179-E2B53842D7E0}"/>
+                <a16:creationId xmlns:a16="http://schemas.microsoft.com/office/drawing/2014/main" id="{76FA9DDF-7271-4F85-B4C7-316D248F43CF}"/>
               </a:ext>
             </a:extLst>
           </p:cNvPr>
@@ -6294,7 +6294,7 @@
           <p:cNvPr id="10" name="">
             <a:extLst xmlns:a="http://schemas.openxmlformats.org/drawingml/2006/main">
               <a:ext uri="{FF2B5EF4-FFF2-40B4-BE49-F238E27FC236}">
-                <a16:creationId xmlns:a16="http://schemas.microsoft.com/office/drawing/2014/main" id="{3F3A2411-E59D-4441-B3E3-927DD97A5364}"/>
+                <a16:creationId xmlns:a16="http://schemas.microsoft.com/office/drawing/2014/main" id="{4E5D01EA-0AB2-44C3-9E60-D089181CA7C1}"/>
               </a:ext>
             </a:extLst>
           </p:cNvPr>
@@ -6329,7 +6329,7 @@
           <p:cNvPr id="11" name="">
             <a:extLst xmlns:a="http://schemas.openxmlformats.org/drawingml/2006/main">
               <a:ext uri="{FF2B5EF4-FFF2-40B4-BE49-F238E27FC236}">
-                <a16:creationId xmlns:a16="http://schemas.microsoft.com/office/drawing/2014/main" id="{ABAC6984-4B55-427E-A3AB-1DEC697A5AA1}"/>
+                <a16:creationId xmlns:a16="http://schemas.microsoft.com/office/drawing/2014/main" id="{E5076F95-7E8E-4B46-950B-68FCA303B790}"/>
               </a:ext>
             </a:extLst>
           </p:cNvPr>
@@ -6379,7 +6379,7 @@
           <p:cNvPr id="12" name="">
             <a:extLst xmlns:a="http://schemas.openxmlformats.org/drawingml/2006/main">
               <a:ext uri="{FF2B5EF4-FFF2-40B4-BE49-F238E27FC236}">
-                <a16:creationId xmlns:a16="http://schemas.microsoft.com/office/drawing/2014/main" id="{6175BA55-8635-4F54-BB91-A05C75B264E6}"/>
+                <a16:creationId xmlns:a16="http://schemas.microsoft.com/office/drawing/2014/main" id="{8583976B-E3B1-48B0-8128-F114CBB30564}"/>
               </a:ext>
             </a:extLst>
           </p:cNvPr>
@@ -6429,7 +6429,7 @@
           <p:cNvPr id="13" name="">
             <a:extLst xmlns:a="http://schemas.openxmlformats.org/drawingml/2006/main">
               <a:ext uri="{FF2B5EF4-FFF2-40B4-BE49-F238E27FC236}">
-                <a16:creationId xmlns:a16="http://schemas.microsoft.com/office/drawing/2014/main" id="{54437D16-014D-4145-B2AF-30DA66BBE28C}"/>
+                <a16:creationId xmlns:a16="http://schemas.microsoft.com/office/drawing/2014/main" id="{C6D7ED6D-0E86-447A-9BC4-888C5F53AA44}"/>
               </a:ext>
             </a:extLst>
           </p:cNvPr>
@@ -6479,7 +6479,7 @@
           <p:cNvPr id="14" name="">
             <a:extLst xmlns:a="http://schemas.openxmlformats.org/drawingml/2006/main">
               <a:ext uri="{FF2B5EF4-FFF2-40B4-BE49-F238E27FC236}">
-                <a16:creationId xmlns:a16="http://schemas.microsoft.com/office/drawing/2014/main" id="{65A92900-953E-48C8-B811-42D99071CAAC}"/>
+                <a16:creationId xmlns:a16="http://schemas.microsoft.com/office/drawing/2014/main" id="{958A1285-32C3-46B4-B4B7-DC3C9B6F32D6}"/>
               </a:ext>
             </a:extLst>
           </p:cNvPr>
@@ -6516,7 +6516,7 @@
           <p:cNvPr id="15" name="">
             <a:extLst xmlns:a="http://schemas.openxmlformats.org/drawingml/2006/main">
               <a:ext uri="{FF2B5EF4-FFF2-40B4-BE49-F238E27FC236}">
-                <a16:creationId xmlns:a16="http://schemas.microsoft.com/office/drawing/2014/main" id="{126CF23C-0D87-4746-A00B-DCA46ACC35C4}"/>
+                <a16:creationId xmlns:a16="http://schemas.microsoft.com/office/drawing/2014/main" id="{0B065A86-E14D-4E46-A609-116F0D5112B1}"/>
               </a:ext>
             </a:extLst>
           </p:cNvPr>
@@ -6564,7 +6564,7 @@
     </p:spTree>
     <p:extLst>
       <p:ext uri="{BB962C8B-B14F-4D97-AF65-F5344CB8AC3E}">
-        <p14:creationId xmlns:p14="http://schemas.microsoft.com/office/powerpoint/2010/main" val="540139096"/>
+        <p14:creationId xmlns:p14="http://schemas.microsoft.com/office/powerpoint/2010/main" val="843892060"/>
       </p:ext>
     </p:extLst>
   </p:cSld>
@@ -6595,7 +6595,7 @@
           <p:cNvPr id="1" name="">
             <a:extLst xmlns:a="http://schemas.openxmlformats.org/drawingml/2006/main">
               <a:ext uri="{FF2B5EF4-FFF2-40B4-BE49-F238E27FC236}">
-                <a16:creationId xmlns:a16="http://schemas.microsoft.com/office/drawing/2014/main" id="{163955D6-D92D-412D-B742-18401E05017D}"/>
+                <a16:creationId xmlns:a16="http://schemas.microsoft.com/office/drawing/2014/main" id="{15AF50F1-05E0-4961-9CC8-BD6CD298E0A7}"/>
               </a:ext>
             </a:extLst>
           </p:cNvPr>
@@ -6645,7 +6645,7 @@
           <p:cNvPr id="2" name="">
             <a:extLst xmlns:a="http://schemas.openxmlformats.org/drawingml/2006/main">
               <a:ext uri="{FF2B5EF4-FFF2-40B4-BE49-F238E27FC236}">
-                <a16:creationId xmlns:a16="http://schemas.microsoft.com/office/drawing/2014/main" id="{8F08A649-4E00-43A3-AEE3-22F1D7B2729F}"/>
+                <a16:creationId xmlns:a16="http://schemas.microsoft.com/office/drawing/2014/main" id="{DCC64BD8-F8E8-4C9F-97FE-ECCEFEFEE033}"/>
               </a:ext>
             </a:extLst>
           </p:cNvPr>
@@ -6695,7 +6695,7 @@
           <p:cNvPr id="3" name="">
             <a:extLst xmlns:a="http://schemas.openxmlformats.org/drawingml/2006/main">
               <a:ext uri="{FF2B5EF4-FFF2-40B4-BE49-F238E27FC236}">
-                <a16:creationId xmlns:a16="http://schemas.microsoft.com/office/drawing/2014/main" id="{899F1FFC-1AD0-4A4A-9A25-586E83AE7749}"/>
+                <a16:creationId xmlns:a16="http://schemas.microsoft.com/office/drawing/2014/main" id="{2F8C592B-8DAE-477F-9CEE-74FFE26FE9AD}"/>
               </a:ext>
             </a:extLst>
           </p:cNvPr>
@@ -6726,7 +6726,7 @@
           <p:cNvPr id="4" name="">
             <a:extLst xmlns:a="http://schemas.openxmlformats.org/drawingml/2006/main">
               <a:ext uri="{FF2B5EF4-FFF2-40B4-BE49-F238E27FC236}">
-                <a16:creationId xmlns:a16="http://schemas.microsoft.com/office/drawing/2014/main" id="{BB32B86E-4DD9-41AE-A18A-2E5D4563CACC}"/>
+                <a16:creationId xmlns:a16="http://schemas.microsoft.com/office/drawing/2014/main" id="{DCFE5531-A80C-4430-81E9-9B55A6DF533A}"/>
               </a:ext>
             </a:extLst>
           </p:cNvPr>
@@ -6776,7 +6776,7 @@
           <p:cNvPr id="5" name="">
             <a:extLst xmlns:a="http://schemas.openxmlformats.org/drawingml/2006/main">
               <a:ext uri="{FF2B5EF4-FFF2-40B4-BE49-F238E27FC236}">
-                <a16:creationId xmlns:a16="http://schemas.microsoft.com/office/drawing/2014/main" id="{1B61CDCF-5AF0-41BD-9207-E12BBFB53F96}"/>
+                <a16:creationId xmlns:a16="http://schemas.microsoft.com/office/drawing/2014/main" id="{C10C3A13-D781-402F-BB08-2F50B52EC7C2}"/>
               </a:ext>
             </a:extLst>
           </p:cNvPr>
@@ -6826,7 +6826,7 @@
           <p:cNvPr id="6" name="">
             <a:extLst xmlns:a="http://schemas.openxmlformats.org/drawingml/2006/main">
               <a:ext uri="{FF2B5EF4-FFF2-40B4-BE49-F238E27FC236}">
-                <a16:creationId xmlns:a16="http://schemas.microsoft.com/office/drawing/2014/main" id="{AA3E1975-A0CB-45EC-B3BE-EDB257B99139}"/>
+                <a16:creationId xmlns:a16="http://schemas.microsoft.com/office/drawing/2014/main" id="{835391FB-EEA9-49E7-A5F8-0636527D4436}"/>
               </a:ext>
             </a:extLst>
           </p:cNvPr>
@@ -6876,7 +6876,7 @@
           <p:cNvPr id="7" name="">
             <a:extLst xmlns:a="http://schemas.openxmlformats.org/drawingml/2006/main">
               <a:ext uri="{FF2B5EF4-FFF2-40B4-BE49-F238E27FC236}">
-                <a16:creationId xmlns:a16="http://schemas.microsoft.com/office/drawing/2014/main" id="{55468C32-C465-4413-A7EC-310E28BBE1B7}"/>
+                <a16:creationId xmlns:a16="http://schemas.microsoft.com/office/drawing/2014/main" id="{4D96B916-1446-4E65-93CD-35EE535B09C0}"/>
               </a:ext>
             </a:extLst>
           </p:cNvPr>
@@ -6926,7 +6926,7 @@
           <p:cNvPr id="8" name="">
             <a:extLst xmlns:a="http://schemas.openxmlformats.org/drawingml/2006/main">
               <a:ext uri="{FF2B5EF4-FFF2-40B4-BE49-F238E27FC236}">
-                <a16:creationId xmlns:a16="http://schemas.microsoft.com/office/drawing/2014/main" id="{C2E1EB14-E950-4A29-AF3E-4D2CD573EB33}"/>
+                <a16:creationId xmlns:a16="http://schemas.microsoft.com/office/drawing/2014/main" id="{CE4F94D9-58A4-45B4-A7E6-840DBA81D3FF}"/>
               </a:ext>
             </a:extLst>
           </p:cNvPr>
@@ -6976,7 +6976,7 @@
           <p:cNvPr id="9" name="">
             <a:extLst xmlns:a="http://schemas.openxmlformats.org/drawingml/2006/main">
               <a:ext uri="{FF2B5EF4-FFF2-40B4-BE49-F238E27FC236}">
-                <a16:creationId xmlns:a16="http://schemas.microsoft.com/office/drawing/2014/main" id="{2A7A7519-481A-4FB8-98FA-81B18EA48EEA}"/>
+                <a16:creationId xmlns:a16="http://schemas.microsoft.com/office/drawing/2014/main" id="{A66A4357-06FB-4DC4-BF6A-A1222CDEDB3D}"/>
               </a:ext>
             </a:extLst>
           </p:cNvPr>
@@ -7026,7 +7026,7 @@
           <p:cNvPr id="10" name="">
             <a:extLst xmlns:a="http://schemas.openxmlformats.org/drawingml/2006/main">
               <a:ext uri="{FF2B5EF4-FFF2-40B4-BE49-F238E27FC236}">
-                <a16:creationId xmlns:a16="http://schemas.microsoft.com/office/drawing/2014/main" id="{7DF3A82A-CE58-42B6-8E77-7401D086443D}"/>
+                <a16:creationId xmlns:a16="http://schemas.microsoft.com/office/drawing/2014/main" id="{7E835A35-8FC6-4CC8-973A-620201CF2574}"/>
               </a:ext>
             </a:extLst>
           </p:cNvPr>
@@ -7076,7 +7076,7 @@
           <p:cNvPr id="11" name="">
             <a:extLst xmlns:a="http://schemas.openxmlformats.org/drawingml/2006/main">
               <a:ext uri="{FF2B5EF4-FFF2-40B4-BE49-F238E27FC236}">
-                <a16:creationId xmlns:a16="http://schemas.microsoft.com/office/drawing/2014/main" id="{6A61D7F5-9F76-4363-921D-D8FF35BFFCF3}"/>
+                <a16:creationId xmlns:a16="http://schemas.microsoft.com/office/drawing/2014/main" id="{50A2E1DC-918D-4A1B-90DF-6D36D9399511}"/>
               </a:ext>
             </a:extLst>
           </p:cNvPr>
@@ -7126,7 +7126,7 @@
           <p:cNvPr id="12" name="">
             <a:extLst xmlns:a="http://schemas.openxmlformats.org/drawingml/2006/main">
               <a:ext uri="{FF2B5EF4-FFF2-40B4-BE49-F238E27FC236}">
-                <a16:creationId xmlns:a16="http://schemas.microsoft.com/office/drawing/2014/main" id="{C63AAB45-5431-4914-B9E4-7F41B25E62E1}"/>
+                <a16:creationId xmlns:a16="http://schemas.microsoft.com/office/drawing/2014/main" id="{8D014797-FE7A-4D21-AD93-A9F82A16CE06}"/>
               </a:ext>
             </a:extLst>
           </p:cNvPr>
@@ -7161,7 +7161,7 @@
           <p:cNvPr id="13" name="">
             <a:extLst xmlns:a="http://schemas.openxmlformats.org/drawingml/2006/main">
               <a:ext uri="{FF2B5EF4-FFF2-40B4-BE49-F238E27FC236}">
-                <a16:creationId xmlns:a16="http://schemas.microsoft.com/office/drawing/2014/main" id="{813BE279-F3BE-4F13-9D79-C9A6534EC245}"/>
+                <a16:creationId xmlns:a16="http://schemas.microsoft.com/office/drawing/2014/main" id="{E4B861F8-A6B0-46A8-B37C-E7F9F0B2BCCB}"/>
               </a:ext>
             </a:extLst>
           </p:cNvPr>
@@ -7211,7 +7211,7 @@
           <p:cNvPr id="14" name="">
             <a:extLst xmlns:a="http://schemas.openxmlformats.org/drawingml/2006/main">
               <a:ext uri="{FF2B5EF4-FFF2-40B4-BE49-F238E27FC236}">
-                <a16:creationId xmlns:a16="http://schemas.microsoft.com/office/drawing/2014/main" id="{37ABA7FD-7D39-4386-AB6F-A16A8DDF0B62}"/>
+                <a16:creationId xmlns:a16="http://schemas.microsoft.com/office/drawing/2014/main" id="{6169CED9-0359-4154-8F4E-7E135594E799}"/>
               </a:ext>
             </a:extLst>
           </p:cNvPr>
@@ -7261,7 +7261,7 @@
           <p:cNvPr id="15" name="">
             <a:extLst xmlns:a="http://schemas.openxmlformats.org/drawingml/2006/main">
               <a:ext uri="{FF2B5EF4-FFF2-40B4-BE49-F238E27FC236}">
-                <a16:creationId xmlns:a16="http://schemas.microsoft.com/office/drawing/2014/main" id="{E7CE35D9-D996-4F51-A496-39FFD786D17B}"/>
+                <a16:creationId xmlns:a16="http://schemas.microsoft.com/office/drawing/2014/main" id="{5C320787-A2F9-477B-9A90-AEEC9554EBEF}"/>
               </a:ext>
             </a:extLst>
           </p:cNvPr>
@@ -7311,7 +7311,7 @@
           <p:cNvPr id="16" name="">
             <a:extLst xmlns:a="http://schemas.openxmlformats.org/drawingml/2006/main">
               <a:ext uri="{FF2B5EF4-FFF2-40B4-BE49-F238E27FC236}">
-                <a16:creationId xmlns:a16="http://schemas.microsoft.com/office/drawing/2014/main" id="{A8A07C79-D8B5-4D2C-828E-39BD2D79E873}"/>
+                <a16:creationId xmlns:a16="http://schemas.microsoft.com/office/drawing/2014/main" id="{9E1CB26D-7B19-45FD-83EF-CF2FCB5F045B}"/>
               </a:ext>
             </a:extLst>
           </p:cNvPr>
@@ -7348,7 +7348,7 @@
           <p:cNvPr id="17" name="">
             <a:extLst xmlns:a="http://schemas.openxmlformats.org/drawingml/2006/main">
               <a:ext uri="{FF2B5EF4-FFF2-40B4-BE49-F238E27FC236}">
-                <a16:creationId xmlns:a16="http://schemas.microsoft.com/office/drawing/2014/main" id="{5AD15216-9758-498B-8D12-BD1D3103C99B}"/>
+                <a16:creationId xmlns:a16="http://schemas.microsoft.com/office/drawing/2014/main" id="{898CA0B8-4149-4633-9507-E6229AAD0378}"/>
               </a:ext>
             </a:extLst>
           </p:cNvPr>
@@ -7396,7 +7396,7 @@
     </p:spTree>
     <p:extLst>
       <p:ext uri="{BB962C8B-B14F-4D97-AF65-F5344CB8AC3E}">
-        <p14:creationId xmlns:p14="http://schemas.microsoft.com/office/powerpoint/2010/main" val="94543392"/>
+        <p14:creationId xmlns:p14="http://schemas.microsoft.com/office/powerpoint/2010/main" val="1569970159"/>
       </p:ext>
     </p:extLst>
   </p:cSld>
@@ -7427,7 +7427,7 @@
           <p:cNvPr id="1" name="">
             <a:extLst xmlns:a="http://schemas.openxmlformats.org/drawingml/2006/main">
               <a:ext uri="{FF2B5EF4-FFF2-40B4-BE49-F238E27FC236}">
-                <a16:creationId xmlns:a16="http://schemas.microsoft.com/office/drawing/2014/main" id="{64DDB974-2786-4AF4-8960-DC1CBFAA8FC8}"/>
+                <a16:creationId xmlns:a16="http://schemas.microsoft.com/office/drawing/2014/main" id="{33B6894A-16D7-4355-B287-FFFCC4F23958}"/>
               </a:ext>
             </a:extLst>
           </p:cNvPr>
@@ -7477,7 +7477,7 @@
           <p:cNvPr id="2" name="">
             <a:extLst xmlns:a="http://schemas.openxmlformats.org/drawingml/2006/main">
               <a:ext uri="{FF2B5EF4-FFF2-40B4-BE49-F238E27FC236}">
-                <a16:creationId xmlns:a16="http://schemas.microsoft.com/office/drawing/2014/main" id="{201367AF-A2D0-4D34-849F-EDBDF4264CBD}"/>
+                <a16:creationId xmlns:a16="http://schemas.microsoft.com/office/drawing/2014/main" id="{84B5CF4D-C5BD-4B4E-95E7-E393584450B4}"/>
               </a:ext>
             </a:extLst>
           </p:cNvPr>
@@ -7527,7 +7527,7 @@
           <p:cNvPr id="3" name="">
             <a:extLst xmlns:a="http://schemas.openxmlformats.org/drawingml/2006/main">
               <a:ext uri="{FF2B5EF4-FFF2-40B4-BE49-F238E27FC236}">
-                <a16:creationId xmlns:a16="http://schemas.microsoft.com/office/drawing/2014/main" id="{0132AEE3-2564-4373-93D7-1DC59BB539DF}"/>
+                <a16:creationId xmlns:a16="http://schemas.microsoft.com/office/drawing/2014/main" id="{7C09EA87-3250-4CCA-8B5C-DDE5A471B3BA}"/>
               </a:ext>
             </a:extLst>
           </p:cNvPr>
@@ -7558,7 +7558,7 @@
           <p:cNvPr id="4" name="">
             <a:extLst xmlns:a="http://schemas.openxmlformats.org/drawingml/2006/main">
               <a:ext uri="{FF2B5EF4-FFF2-40B4-BE49-F238E27FC236}">
-                <a16:creationId xmlns:a16="http://schemas.microsoft.com/office/drawing/2014/main" id="{23FF1CC2-4DFD-4499-8EA0-D97DD4166475}"/>
+                <a16:creationId xmlns:a16="http://schemas.microsoft.com/office/drawing/2014/main" id="{757E432A-EB80-4F17-A9C5-8E5FD7B6490D}"/>
               </a:ext>
             </a:extLst>
           </p:cNvPr>
@@ -7608,7 +7608,7 @@
           <p:cNvPr id="5" name="">
             <a:extLst xmlns:a="http://schemas.openxmlformats.org/drawingml/2006/main">
               <a:ext uri="{FF2B5EF4-FFF2-40B4-BE49-F238E27FC236}">
-                <a16:creationId xmlns:a16="http://schemas.microsoft.com/office/drawing/2014/main" id="{0BA6747C-F81F-42BA-9D71-AABB5C7EB886}"/>
+                <a16:creationId xmlns:a16="http://schemas.microsoft.com/office/drawing/2014/main" id="{B9559F94-73D7-4A68-9E9C-6CE33DBE4D48}"/>
               </a:ext>
             </a:extLst>
           </p:cNvPr>
@@ -7658,7 +7658,7 @@
           <p:cNvPr id="6" name="">
             <a:extLst xmlns:a="http://schemas.openxmlformats.org/drawingml/2006/main">
               <a:ext uri="{FF2B5EF4-FFF2-40B4-BE49-F238E27FC236}">
-                <a16:creationId xmlns:a16="http://schemas.microsoft.com/office/drawing/2014/main" id="{1308541D-642F-4A32-8D4A-DD1B84C0657C}"/>
+                <a16:creationId xmlns:a16="http://schemas.microsoft.com/office/drawing/2014/main" id="{919BB66A-6182-4DCE-B352-8B206901695D}"/>
               </a:ext>
             </a:extLst>
           </p:cNvPr>
@@ -7708,7 +7708,7 @@
           <p:cNvPr id="7" name="">
             <a:extLst xmlns:a="http://schemas.openxmlformats.org/drawingml/2006/main">
               <a:ext uri="{FF2B5EF4-FFF2-40B4-BE49-F238E27FC236}">
-                <a16:creationId xmlns:a16="http://schemas.microsoft.com/office/drawing/2014/main" id="{C37AABF0-119F-42B4-BFB1-3FB4D1654D91}"/>
+                <a16:creationId xmlns:a16="http://schemas.microsoft.com/office/drawing/2014/main" id="{02A55D62-0E00-4C8F-B7FF-E0407229ACE2}"/>
               </a:ext>
             </a:extLst>
           </p:cNvPr>
@@ -7758,7 +7758,7 @@
           <p:cNvPr id="8" name="">
             <a:extLst xmlns:a="http://schemas.openxmlformats.org/drawingml/2006/main">
               <a:ext uri="{FF2B5EF4-FFF2-40B4-BE49-F238E27FC236}">
-                <a16:creationId xmlns:a16="http://schemas.microsoft.com/office/drawing/2014/main" id="{60229D75-78B8-4170-9CDF-95BCF0A5E2DA}"/>
+                <a16:creationId xmlns:a16="http://schemas.microsoft.com/office/drawing/2014/main" id="{F23A1727-95CB-459B-9EB8-53B8635AF4FA}"/>
               </a:ext>
             </a:extLst>
           </p:cNvPr>
@@ -7808,7 +7808,7 @@
           <p:cNvPr id="9" name="">
             <a:extLst xmlns:a="http://schemas.openxmlformats.org/drawingml/2006/main">
               <a:ext uri="{FF2B5EF4-FFF2-40B4-BE49-F238E27FC236}">
-                <a16:creationId xmlns:a16="http://schemas.microsoft.com/office/drawing/2014/main" id="{E868FD42-7D03-47D6-8BDD-E118757DCFA7}"/>
+                <a16:creationId xmlns:a16="http://schemas.microsoft.com/office/drawing/2014/main" id="{84257123-6A3E-4F86-9FDB-4E0E576F39E4}"/>
               </a:ext>
             </a:extLst>
           </p:cNvPr>
@@ -7858,7 +7858,7 @@
           <p:cNvPr id="10" name="">
             <a:extLst xmlns:a="http://schemas.openxmlformats.org/drawingml/2006/main">
               <a:ext uri="{FF2B5EF4-FFF2-40B4-BE49-F238E27FC236}">
-                <a16:creationId xmlns:a16="http://schemas.microsoft.com/office/drawing/2014/main" id="{47622B6A-76C0-4CF2-B025-9A91F686D586}"/>
+                <a16:creationId xmlns:a16="http://schemas.microsoft.com/office/drawing/2014/main" id="{84A69F4D-41C7-4355-B314-1216E595ABD9}"/>
               </a:ext>
             </a:extLst>
           </p:cNvPr>
@@ -7908,7 +7908,7 @@
           <p:cNvPr id="11" name="">
             <a:extLst xmlns:a="http://schemas.openxmlformats.org/drawingml/2006/main">
               <a:ext uri="{FF2B5EF4-FFF2-40B4-BE49-F238E27FC236}">
-                <a16:creationId xmlns:a16="http://schemas.microsoft.com/office/drawing/2014/main" id="{F581CE4D-4E11-4EAF-B7E5-BE608EA20CED}"/>
+                <a16:creationId xmlns:a16="http://schemas.microsoft.com/office/drawing/2014/main" id="{6CF5E908-EA81-4B64-8351-9F3BED950454}"/>
               </a:ext>
             </a:extLst>
           </p:cNvPr>
@@ -7958,7 +7958,7 @@
           <p:cNvPr id="12" name="">
             <a:extLst xmlns:a="http://schemas.openxmlformats.org/drawingml/2006/main">
               <a:ext uri="{FF2B5EF4-FFF2-40B4-BE49-F238E27FC236}">
-                <a16:creationId xmlns:a16="http://schemas.microsoft.com/office/drawing/2014/main" id="{68AF2FDE-2DE3-4FA1-BC82-6B0D53CCD46D}"/>
+                <a16:creationId xmlns:a16="http://schemas.microsoft.com/office/drawing/2014/main" id="{3236DA38-62EE-40D5-959E-6243B6EDB793}"/>
               </a:ext>
             </a:extLst>
           </p:cNvPr>
@@ -7993,7 +7993,7 @@
           <p:cNvPr id="13" name="">
             <a:extLst xmlns:a="http://schemas.openxmlformats.org/drawingml/2006/main">
               <a:ext uri="{FF2B5EF4-FFF2-40B4-BE49-F238E27FC236}">
-                <a16:creationId xmlns:a16="http://schemas.microsoft.com/office/drawing/2014/main" id="{859C5759-B6A2-4BC1-8BEE-7B8AD1C424D4}"/>
+                <a16:creationId xmlns:a16="http://schemas.microsoft.com/office/drawing/2014/main" id="{3CC4CCE6-E869-47F1-A7DE-623FFEE02173}"/>
               </a:ext>
             </a:extLst>
           </p:cNvPr>
@@ -8043,7 +8043,7 @@
           <p:cNvPr id="14" name="">
             <a:extLst xmlns:a="http://schemas.openxmlformats.org/drawingml/2006/main">
               <a:ext uri="{FF2B5EF4-FFF2-40B4-BE49-F238E27FC236}">
-                <a16:creationId xmlns:a16="http://schemas.microsoft.com/office/drawing/2014/main" id="{CE0E1FDC-7F9C-4E07-912A-57201E89F2A6}"/>
+                <a16:creationId xmlns:a16="http://schemas.microsoft.com/office/drawing/2014/main" id="{2B459555-A549-4358-87C6-12D7F534D7A4}"/>
               </a:ext>
             </a:extLst>
           </p:cNvPr>
@@ -8093,7 +8093,7 @@
           <p:cNvPr id="15" name="">
             <a:extLst xmlns:a="http://schemas.openxmlformats.org/drawingml/2006/main">
               <a:ext uri="{FF2B5EF4-FFF2-40B4-BE49-F238E27FC236}">
-                <a16:creationId xmlns:a16="http://schemas.microsoft.com/office/drawing/2014/main" id="{7D9CB478-2DEF-44A3-BAE9-F3AA1D36AFCF}"/>
+                <a16:creationId xmlns:a16="http://schemas.microsoft.com/office/drawing/2014/main" id="{59751E5A-30FA-4E6F-A8D8-AFB479791862}"/>
               </a:ext>
             </a:extLst>
           </p:cNvPr>
@@ -8143,7 +8143,7 @@
           <p:cNvPr id="16" name="">
             <a:extLst xmlns:a="http://schemas.openxmlformats.org/drawingml/2006/main">
               <a:ext uri="{FF2B5EF4-FFF2-40B4-BE49-F238E27FC236}">
-                <a16:creationId xmlns:a16="http://schemas.microsoft.com/office/drawing/2014/main" id="{214BD7A6-01A1-4EA2-8FE9-FA69BF0F4588}"/>
+                <a16:creationId xmlns:a16="http://schemas.microsoft.com/office/drawing/2014/main" id="{EF5C581F-5150-416B-9796-46AFB9F6FD64}"/>
               </a:ext>
             </a:extLst>
           </p:cNvPr>
@@ -8180,7 +8180,7 @@
           <p:cNvPr id="17" name="">
             <a:extLst xmlns:a="http://schemas.openxmlformats.org/drawingml/2006/main">
               <a:ext uri="{FF2B5EF4-FFF2-40B4-BE49-F238E27FC236}">
-                <a16:creationId xmlns:a16="http://schemas.microsoft.com/office/drawing/2014/main" id="{E8050164-18C9-44D8-8F28-4762EB6D20FC}"/>
+                <a16:creationId xmlns:a16="http://schemas.microsoft.com/office/drawing/2014/main" id="{8471B202-C197-49A4-972E-36F56A98EFDB}"/>
               </a:ext>
             </a:extLst>
           </p:cNvPr>
@@ -8228,7 +8228,7 @@
     </p:spTree>
     <p:extLst>
       <p:ext uri="{BB962C8B-B14F-4D97-AF65-F5344CB8AC3E}">
-        <p14:creationId xmlns:p14="http://schemas.microsoft.com/office/powerpoint/2010/main" val="528164981"/>
+        <p14:creationId xmlns:p14="http://schemas.microsoft.com/office/powerpoint/2010/main" val="1515432298"/>
       </p:ext>
     </p:extLst>
   </p:cSld>
@@ -8259,7 +8259,7 @@
           <p:cNvPr id="1" name="">
             <a:extLst xmlns:a="http://schemas.openxmlformats.org/drawingml/2006/main">
               <a:ext uri="{FF2B5EF4-FFF2-40B4-BE49-F238E27FC236}">
-                <a16:creationId xmlns:a16="http://schemas.microsoft.com/office/drawing/2014/main" id="{2574408E-07E1-4CE7-86DD-95E0AA101969}"/>
+                <a16:creationId xmlns:a16="http://schemas.microsoft.com/office/drawing/2014/main" id="{9D3A3AC1-35C0-491E-ABA8-81E5D091F118}"/>
               </a:ext>
             </a:extLst>
           </p:cNvPr>
@@ -8309,7 +8309,7 @@
           <p:cNvPr id="2" name="">
             <a:extLst xmlns:a="http://schemas.openxmlformats.org/drawingml/2006/main">
               <a:ext uri="{FF2B5EF4-FFF2-40B4-BE49-F238E27FC236}">
-                <a16:creationId xmlns:a16="http://schemas.microsoft.com/office/drawing/2014/main" id="{5ADE1763-C96A-43AF-A0EB-807F67291D57}"/>
+                <a16:creationId xmlns:a16="http://schemas.microsoft.com/office/drawing/2014/main" id="{6B78751B-C05C-4329-8699-06515C432A23}"/>
               </a:ext>
             </a:extLst>
           </p:cNvPr>
@@ -8359,7 +8359,7 @@
           <p:cNvPr id="3" name="">
             <a:extLst xmlns:a="http://schemas.openxmlformats.org/drawingml/2006/main">
               <a:ext uri="{FF2B5EF4-FFF2-40B4-BE49-F238E27FC236}">
-                <a16:creationId xmlns:a16="http://schemas.microsoft.com/office/drawing/2014/main" id="{06D769CE-500F-425A-8269-E6CFF29BAF95}"/>
+                <a16:creationId xmlns:a16="http://schemas.microsoft.com/office/drawing/2014/main" id="{EE78CD4A-91C8-4BE5-8D3C-7F87121DFA11}"/>
               </a:ext>
             </a:extLst>
           </p:cNvPr>
@@ -8390,7 +8390,7 @@
           <p:cNvPr id="4" name="">
             <a:extLst xmlns:a="http://schemas.openxmlformats.org/drawingml/2006/main">
               <a:ext uri="{FF2B5EF4-FFF2-40B4-BE49-F238E27FC236}">
-                <a16:creationId xmlns:a16="http://schemas.microsoft.com/office/drawing/2014/main" id="{1A8A8346-070B-4412-9D45-7772C3DC3B84}"/>
+                <a16:creationId xmlns:a16="http://schemas.microsoft.com/office/drawing/2014/main" id="{3DB857E4-6818-4E0C-A2AF-E7B91836350B}"/>
               </a:ext>
             </a:extLst>
           </p:cNvPr>
@@ -8440,7 +8440,7 @@
           <p:cNvPr id="5" name="">
             <a:extLst xmlns:a="http://schemas.openxmlformats.org/drawingml/2006/main">
               <a:ext uri="{FF2B5EF4-FFF2-40B4-BE49-F238E27FC236}">
-                <a16:creationId xmlns:a16="http://schemas.microsoft.com/office/drawing/2014/main" id="{B8E673AB-AB89-4565-9BC7-11CE47F9C678}"/>
+                <a16:creationId xmlns:a16="http://schemas.microsoft.com/office/drawing/2014/main" id="{D346B49E-3E0C-48E8-93DF-C76279A26AD5}"/>
               </a:ext>
             </a:extLst>
           </p:cNvPr>
@@ -8490,7 +8490,7 @@
           <p:cNvPr id="6" name="">
             <a:extLst xmlns:a="http://schemas.openxmlformats.org/drawingml/2006/main">
               <a:ext uri="{FF2B5EF4-FFF2-40B4-BE49-F238E27FC236}">
-                <a16:creationId xmlns:a16="http://schemas.microsoft.com/office/drawing/2014/main" id="{661B569E-8858-4A8B-9AD8-DB4FFBEE8433}"/>
+                <a16:creationId xmlns:a16="http://schemas.microsoft.com/office/drawing/2014/main" id="{EE721844-1C04-4698-AD81-704C5D9B8B07}"/>
               </a:ext>
             </a:extLst>
           </p:cNvPr>
@@ -8540,7 +8540,7 @@
           <p:cNvPr id="7" name="">
             <a:extLst xmlns:a="http://schemas.openxmlformats.org/drawingml/2006/main">
               <a:ext uri="{FF2B5EF4-FFF2-40B4-BE49-F238E27FC236}">
-                <a16:creationId xmlns:a16="http://schemas.microsoft.com/office/drawing/2014/main" id="{EA2CD267-9F5A-4AAF-89CB-71BB33C58CCA}"/>
+                <a16:creationId xmlns:a16="http://schemas.microsoft.com/office/drawing/2014/main" id="{1B5CEB4A-EACF-428C-9D1B-0D8114867573}"/>
               </a:ext>
             </a:extLst>
           </p:cNvPr>
@@ -8590,7 +8590,7 @@
           <p:cNvPr id="8" name="">
             <a:extLst xmlns:a="http://schemas.openxmlformats.org/drawingml/2006/main">
               <a:ext uri="{FF2B5EF4-FFF2-40B4-BE49-F238E27FC236}">
-                <a16:creationId xmlns:a16="http://schemas.microsoft.com/office/drawing/2014/main" id="{F707AB01-1087-4814-B982-8512B69CC97A}"/>
+                <a16:creationId xmlns:a16="http://schemas.microsoft.com/office/drawing/2014/main" id="{2A93F01E-8DCB-46F4-BEF6-09A54991726C}"/>
               </a:ext>
             </a:extLst>
           </p:cNvPr>
@@ -8640,7 +8640,7 @@
           <p:cNvPr id="9" name="">
             <a:extLst xmlns:a="http://schemas.openxmlformats.org/drawingml/2006/main">
               <a:ext uri="{FF2B5EF4-FFF2-40B4-BE49-F238E27FC236}">
-                <a16:creationId xmlns:a16="http://schemas.microsoft.com/office/drawing/2014/main" id="{46BB4541-45FC-45CF-9446-C6798614CFCF}"/>
+                <a16:creationId xmlns:a16="http://schemas.microsoft.com/office/drawing/2014/main" id="{B35832F1-3F27-47F0-8B29-344C584320B3}"/>
               </a:ext>
             </a:extLst>
           </p:cNvPr>
@@ -8690,7 +8690,7 @@
           <p:cNvPr id="10" name="">
             <a:extLst xmlns:a="http://schemas.openxmlformats.org/drawingml/2006/main">
               <a:ext uri="{FF2B5EF4-FFF2-40B4-BE49-F238E27FC236}">
-                <a16:creationId xmlns:a16="http://schemas.microsoft.com/office/drawing/2014/main" id="{3D65A1AE-DE94-42E4-A4A4-B7306EFB1354}"/>
+                <a16:creationId xmlns:a16="http://schemas.microsoft.com/office/drawing/2014/main" id="{0EC20C9F-D095-43BA-A212-DBF789B1F33C}"/>
               </a:ext>
             </a:extLst>
           </p:cNvPr>
@@ -8725,7 +8725,7 @@
           <p:cNvPr id="11" name="">
             <a:extLst xmlns:a="http://schemas.openxmlformats.org/drawingml/2006/main">
               <a:ext uri="{FF2B5EF4-FFF2-40B4-BE49-F238E27FC236}">
-                <a16:creationId xmlns:a16="http://schemas.microsoft.com/office/drawing/2014/main" id="{96768C3F-608A-448D-9583-C1266DC9194E}"/>
+                <a16:creationId xmlns:a16="http://schemas.microsoft.com/office/drawing/2014/main" id="{0AB5EA08-477B-4D34-891D-0314095F7D3C}"/>
               </a:ext>
             </a:extLst>
           </p:cNvPr>
@@ -8775,7 +8775,7 @@
           <p:cNvPr id="12" name="">
             <a:extLst xmlns:a="http://schemas.openxmlformats.org/drawingml/2006/main">
               <a:ext uri="{FF2B5EF4-FFF2-40B4-BE49-F238E27FC236}">
-                <a16:creationId xmlns:a16="http://schemas.microsoft.com/office/drawing/2014/main" id="{DF6F3E77-E0C1-4E56-A506-96B93BEA170E}"/>
+                <a16:creationId xmlns:a16="http://schemas.microsoft.com/office/drawing/2014/main" id="{2A4BBBD1-0459-47BD-A4B5-727124A927F6}"/>
               </a:ext>
             </a:extLst>
           </p:cNvPr>
@@ -8825,7 +8825,7 @@
           <p:cNvPr id="13" name="">
             <a:extLst xmlns:a="http://schemas.openxmlformats.org/drawingml/2006/main">
               <a:ext uri="{FF2B5EF4-FFF2-40B4-BE49-F238E27FC236}">
-                <a16:creationId xmlns:a16="http://schemas.microsoft.com/office/drawing/2014/main" id="{03C15693-02EB-4250-901C-303F99DFB3DD}"/>
+                <a16:creationId xmlns:a16="http://schemas.microsoft.com/office/drawing/2014/main" id="{40F49DBC-A445-4FEF-9BE6-CA95CCB34023}"/>
               </a:ext>
             </a:extLst>
           </p:cNvPr>
@@ -8875,7 +8875,7 @@
           <p:cNvPr id="14" name="">
             <a:extLst xmlns:a="http://schemas.openxmlformats.org/drawingml/2006/main">
               <a:ext uri="{FF2B5EF4-FFF2-40B4-BE49-F238E27FC236}">
-                <a16:creationId xmlns:a16="http://schemas.microsoft.com/office/drawing/2014/main" id="{2CE6EA12-5A28-4367-B3CC-FCE5FEA630B2}"/>
+                <a16:creationId xmlns:a16="http://schemas.microsoft.com/office/drawing/2014/main" id="{91355116-6263-447E-8FA7-5288EDDBA4D5}"/>
               </a:ext>
             </a:extLst>
           </p:cNvPr>
@@ -8912,7 +8912,7 @@
           <p:cNvPr id="15" name="">
             <a:extLst xmlns:a="http://schemas.openxmlformats.org/drawingml/2006/main">
               <a:ext uri="{FF2B5EF4-FFF2-40B4-BE49-F238E27FC236}">
-                <a16:creationId xmlns:a16="http://schemas.microsoft.com/office/drawing/2014/main" id="{302E2C78-4F97-496F-94C9-E9DC161AC6E4}"/>
+                <a16:creationId xmlns:a16="http://schemas.microsoft.com/office/drawing/2014/main" id="{E08A09FC-FF97-4C32-BB4A-0C8AD6BBB47A}"/>
               </a:ext>
             </a:extLst>
           </p:cNvPr>
@@ -8960,7 +8960,7 @@
     </p:spTree>
     <p:extLst>
       <p:ext uri="{BB962C8B-B14F-4D97-AF65-F5344CB8AC3E}">
-        <p14:creationId xmlns:p14="http://schemas.microsoft.com/office/powerpoint/2010/main" val="2042555870"/>
+        <p14:creationId xmlns:p14="http://schemas.microsoft.com/office/powerpoint/2010/main" val="979975050"/>
       </p:ext>
     </p:extLst>
   </p:cSld>
@@ -8991,7 +8991,7 @@
           <p:cNvPr id="1" name="">
             <a:extLst xmlns:a="http://schemas.openxmlformats.org/drawingml/2006/main">
               <a:ext uri="{FF2B5EF4-FFF2-40B4-BE49-F238E27FC236}">
-                <a16:creationId xmlns:a16="http://schemas.microsoft.com/office/drawing/2014/main" id="{4213A742-4214-4283-96E8-D003DD866553}"/>
+                <a16:creationId xmlns:a16="http://schemas.microsoft.com/office/drawing/2014/main" id="{2AC24AFA-18DE-4BAD-ADB4-C64188812E85}"/>
               </a:ext>
             </a:extLst>
           </p:cNvPr>
@@ -9041,7 +9041,7 @@
           <p:cNvPr id="2" name="">
             <a:extLst xmlns:a="http://schemas.openxmlformats.org/drawingml/2006/main">
               <a:ext uri="{FF2B5EF4-FFF2-40B4-BE49-F238E27FC236}">
-                <a16:creationId xmlns:a16="http://schemas.microsoft.com/office/drawing/2014/main" id="{6E7BC4CC-5199-4DBA-8515-76C0329713A2}"/>
+                <a16:creationId xmlns:a16="http://schemas.microsoft.com/office/drawing/2014/main" id="{C21F3F16-FFA8-4707-B12E-403825F2F2C3}"/>
               </a:ext>
             </a:extLst>
           </p:cNvPr>
@@ -9091,7 +9091,7 @@
           <p:cNvPr id="3" name="">
             <a:extLst xmlns:a="http://schemas.openxmlformats.org/drawingml/2006/main">
               <a:ext uri="{FF2B5EF4-FFF2-40B4-BE49-F238E27FC236}">
-                <a16:creationId xmlns:a16="http://schemas.microsoft.com/office/drawing/2014/main" id="{E79E6238-512C-4B55-B575-D0F6E80EBA76}"/>
+                <a16:creationId xmlns:a16="http://schemas.microsoft.com/office/drawing/2014/main" id="{7C78FACC-08CF-44B4-B5DB-3E7E239B539B}"/>
               </a:ext>
             </a:extLst>
           </p:cNvPr>
@@ -9122,7 +9122,7 @@
           <p:cNvPr id="4" name="">
             <a:extLst xmlns:a="http://schemas.openxmlformats.org/drawingml/2006/main">
               <a:ext uri="{FF2B5EF4-FFF2-40B4-BE49-F238E27FC236}">
-                <a16:creationId xmlns:a16="http://schemas.microsoft.com/office/drawing/2014/main" id="{38694165-BA73-44AD-9BDD-116431ADC34D}"/>
+                <a16:creationId xmlns:a16="http://schemas.microsoft.com/office/drawing/2014/main" id="{09DD8017-BB92-42C1-8202-A9DC6EA8D468}"/>
               </a:ext>
             </a:extLst>
           </p:cNvPr>
@@ -9172,7 +9172,7 @@
           <p:cNvPr id="5" name="">
             <a:extLst xmlns:a="http://schemas.openxmlformats.org/drawingml/2006/main">
               <a:ext uri="{FF2B5EF4-FFF2-40B4-BE49-F238E27FC236}">
-                <a16:creationId xmlns:a16="http://schemas.microsoft.com/office/drawing/2014/main" id="{4278D941-8CD8-4833-A477-1672DD1E2BCA}"/>
+                <a16:creationId xmlns:a16="http://schemas.microsoft.com/office/drawing/2014/main" id="{37D3257C-CA5F-46AB-AD05-FF852ED78EFC}"/>
               </a:ext>
             </a:extLst>
           </p:cNvPr>
@@ -9222,7 +9222,7 @@
           <p:cNvPr id="6" name="">
             <a:extLst xmlns:a="http://schemas.openxmlformats.org/drawingml/2006/main">
               <a:ext uri="{FF2B5EF4-FFF2-40B4-BE49-F238E27FC236}">
-                <a16:creationId xmlns:a16="http://schemas.microsoft.com/office/drawing/2014/main" id="{30B9879C-7C1F-4884-A2EF-1A2311E369C1}"/>
+                <a16:creationId xmlns:a16="http://schemas.microsoft.com/office/drawing/2014/main" id="{D54AF2EB-D342-491C-BAB0-FE20776C0AB4}"/>
               </a:ext>
             </a:extLst>
           </p:cNvPr>
@@ -9272,7 +9272,7 @@
           <p:cNvPr id="7" name="">
             <a:extLst xmlns:a="http://schemas.openxmlformats.org/drawingml/2006/main">
               <a:ext uri="{FF2B5EF4-FFF2-40B4-BE49-F238E27FC236}">
-                <a16:creationId xmlns:a16="http://schemas.microsoft.com/office/drawing/2014/main" id="{3E23CE73-0819-4EE8-8743-96E2B96CCBE5}"/>
+                <a16:creationId xmlns:a16="http://schemas.microsoft.com/office/drawing/2014/main" id="{AF5F1841-8B71-47F4-B3DA-2B6DE5A2FF1B}"/>
               </a:ext>
             </a:extLst>
           </p:cNvPr>
@@ -9322,7 +9322,7 @@
           <p:cNvPr id="8" name="">
             <a:extLst xmlns:a="http://schemas.openxmlformats.org/drawingml/2006/main">
               <a:ext uri="{FF2B5EF4-FFF2-40B4-BE49-F238E27FC236}">
-                <a16:creationId xmlns:a16="http://schemas.microsoft.com/office/drawing/2014/main" id="{AFFA8CB2-8C41-445D-8A85-9520F439866B}"/>
+                <a16:creationId xmlns:a16="http://schemas.microsoft.com/office/drawing/2014/main" id="{C384D7CB-2B3D-4743-8758-8243DB552A3A}"/>
               </a:ext>
             </a:extLst>
           </p:cNvPr>
@@ -9372,7 +9372,7 @@
           <p:cNvPr id="9" name="">
             <a:extLst xmlns:a="http://schemas.openxmlformats.org/drawingml/2006/main">
               <a:ext uri="{FF2B5EF4-FFF2-40B4-BE49-F238E27FC236}">
-                <a16:creationId xmlns:a16="http://schemas.microsoft.com/office/drawing/2014/main" id="{F9E6EF3B-B401-4404-84A5-96BD914924E1}"/>
+                <a16:creationId xmlns:a16="http://schemas.microsoft.com/office/drawing/2014/main" id="{228BD6F9-551A-42F9-B771-72D981148FC3}"/>
               </a:ext>
             </a:extLst>
           </p:cNvPr>
@@ -9422,7 +9422,7 @@
           <p:cNvPr id="10" name="">
             <a:extLst xmlns:a="http://schemas.openxmlformats.org/drawingml/2006/main">
               <a:ext uri="{FF2B5EF4-FFF2-40B4-BE49-F238E27FC236}">
-                <a16:creationId xmlns:a16="http://schemas.microsoft.com/office/drawing/2014/main" id="{5B57DC7D-FCBF-4861-B776-14B86C400CA5}"/>
+                <a16:creationId xmlns:a16="http://schemas.microsoft.com/office/drawing/2014/main" id="{2E48E09B-FD9D-4F91-B3A0-3B3E165BFC48}"/>
               </a:ext>
             </a:extLst>
           </p:cNvPr>
@@ -9457,7 +9457,7 @@
           <p:cNvPr id="11" name="">
             <a:extLst xmlns:a="http://schemas.openxmlformats.org/drawingml/2006/main">
               <a:ext uri="{FF2B5EF4-FFF2-40B4-BE49-F238E27FC236}">
-                <a16:creationId xmlns:a16="http://schemas.microsoft.com/office/drawing/2014/main" id="{FAE5B4D0-A1C5-4308-AE10-73BA24605B09}"/>
+                <a16:creationId xmlns:a16="http://schemas.microsoft.com/office/drawing/2014/main" id="{8926C2EB-FF86-4843-90D8-A8599301149F}"/>
               </a:ext>
             </a:extLst>
           </p:cNvPr>
@@ -9507,7 +9507,7 @@
           <p:cNvPr id="12" name="">
             <a:extLst xmlns:a="http://schemas.openxmlformats.org/drawingml/2006/main">
               <a:ext uri="{FF2B5EF4-FFF2-40B4-BE49-F238E27FC236}">
-                <a16:creationId xmlns:a16="http://schemas.microsoft.com/office/drawing/2014/main" id="{FDF7C08C-56DF-4132-A1B8-BFC316C1A1A6}"/>
+                <a16:creationId xmlns:a16="http://schemas.microsoft.com/office/drawing/2014/main" id="{0EDF91AB-D837-476B-8368-3B4CFEB2D2C6}"/>
               </a:ext>
             </a:extLst>
           </p:cNvPr>
@@ -9557,7 +9557,7 @@
           <p:cNvPr id="13" name="">
             <a:extLst xmlns:a="http://schemas.openxmlformats.org/drawingml/2006/main">
               <a:ext uri="{FF2B5EF4-FFF2-40B4-BE49-F238E27FC236}">
-                <a16:creationId xmlns:a16="http://schemas.microsoft.com/office/drawing/2014/main" id="{A188B75F-9D68-4CCA-B5FF-E44E01E5FC63}"/>
+                <a16:creationId xmlns:a16="http://schemas.microsoft.com/office/drawing/2014/main" id="{DE86BF7E-B9A2-4B5B-B97D-E082203BE7D7}"/>
               </a:ext>
             </a:extLst>
           </p:cNvPr>
@@ -9607,7 +9607,7 @@
           <p:cNvPr id="14" name="">
             <a:extLst xmlns:a="http://schemas.openxmlformats.org/drawingml/2006/main">
               <a:ext uri="{FF2B5EF4-FFF2-40B4-BE49-F238E27FC236}">
-                <a16:creationId xmlns:a16="http://schemas.microsoft.com/office/drawing/2014/main" id="{DCB4E312-208D-4057-B9AA-62A1E6DE2D0F}"/>
+                <a16:creationId xmlns:a16="http://schemas.microsoft.com/office/drawing/2014/main" id="{25A4310A-74B5-40D9-862C-1511DA7CEC37}"/>
               </a:ext>
             </a:extLst>
           </p:cNvPr>
@@ -9644,7 +9644,7 @@
           <p:cNvPr id="15" name="">
             <a:extLst xmlns:a="http://schemas.openxmlformats.org/drawingml/2006/main">
               <a:ext uri="{FF2B5EF4-FFF2-40B4-BE49-F238E27FC236}">
-                <a16:creationId xmlns:a16="http://schemas.microsoft.com/office/drawing/2014/main" id="{11654622-4539-422A-A5F4-43E1148BEDB6}"/>
+                <a16:creationId xmlns:a16="http://schemas.microsoft.com/office/drawing/2014/main" id="{DBF20B38-CD6C-47A7-8104-3000E7450955}"/>
               </a:ext>
             </a:extLst>
           </p:cNvPr>
@@ -9692,7 +9692,7 @@
     </p:spTree>
     <p:extLst>
       <p:ext uri="{BB962C8B-B14F-4D97-AF65-F5344CB8AC3E}">
-        <p14:creationId xmlns:p14="http://schemas.microsoft.com/office/powerpoint/2010/main" val="1896982147"/>
+        <p14:creationId xmlns:p14="http://schemas.microsoft.com/office/powerpoint/2010/main" val="994688422"/>
       </p:ext>
     </p:extLst>
   </p:cSld>
@@ -9723,7 +9723,7 @@
           <p:cNvPr id="1" name="">
             <a:extLst xmlns:a="http://schemas.openxmlformats.org/drawingml/2006/main">
               <a:ext uri="{FF2B5EF4-FFF2-40B4-BE49-F238E27FC236}">
-                <a16:creationId xmlns:a16="http://schemas.microsoft.com/office/drawing/2014/main" id="{4174643D-CBB9-457E-BC0C-855F14162470}"/>
+                <a16:creationId xmlns:a16="http://schemas.microsoft.com/office/drawing/2014/main" id="{C491A4BF-D6B0-413A-86D4-4A0297B709E8}"/>
               </a:ext>
             </a:extLst>
           </p:cNvPr>
@@ -9773,7 +9773,7 @@
           <p:cNvPr id="2" name="">
             <a:extLst xmlns:a="http://schemas.openxmlformats.org/drawingml/2006/main">
               <a:ext uri="{FF2B5EF4-FFF2-40B4-BE49-F238E27FC236}">
-                <a16:creationId xmlns:a16="http://schemas.microsoft.com/office/drawing/2014/main" id="{AA2E8336-C1E0-4D09-986A-01F6D8E7C46B}"/>
+                <a16:creationId xmlns:a16="http://schemas.microsoft.com/office/drawing/2014/main" id="{BDD0F289-371E-45E2-9525-1226FB5C1DA9}"/>
               </a:ext>
             </a:extLst>
           </p:cNvPr>
@@ -9823,7 +9823,7 @@
           <p:cNvPr id="3" name="">
             <a:extLst xmlns:a="http://schemas.openxmlformats.org/drawingml/2006/main">
               <a:ext uri="{FF2B5EF4-FFF2-40B4-BE49-F238E27FC236}">
-                <a16:creationId xmlns:a16="http://schemas.microsoft.com/office/drawing/2014/main" id="{EA90BE38-B12C-4BB2-B58D-B73C776C9813}"/>
+                <a16:creationId xmlns:a16="http://schemas.microsoft.com/office/drawing/2014/main" id="{C6D82382-6C6D-43BA-9BFB-426B774C270B}"/>
               </a:ext>
             </a:extLst>
           </p:cNvPr>
@@ -9854,7 +9854,7 @@
           <p:cNvPr id="4" name="">
             <a:extLst xmlns:a="http://schemas.openxmlformats.org/drawingml/2006/main">
               <a:ext uri="{FF2B5EF4-FFF2-40B4-BE49-F238E27FC236}">
-                <a16:creationId xmlns:a16="http://schemas.microsoft.com/office/drawing/2014/main" id="{EFE38027-3921-4E68-AF0A-3A6E4D5019BB}"/>
+                <a16:creationId xmlns:a16="http://schemas.microsoft.com/office/drawing/2014/main" id="{B044304F-8DA8-4E7C-92E8-6280106A1290}"/>
               </a:ext>
             </a:extLst>
           </p:cNvPr>
@@ -9904,7 +9904,7 @@
           <p:cNvPr id="5" name="">
             <a:extLst xmlns:a="http://schemas.openxmlformats.org/drawingml/2006/main">
               <a:ext uri="{FF2B5EF4-FFF2-40B4-BE49-F238E27FC236}">
-                <a16:creationId xmlns:a16="http://schemas.microsoft.com/office/drawing/2014/main" id="{877B5337-5D4E-4037-938E-B91AC89F65B1}"/>
+                <a16:creationId xmlns:a16="http://schemas.microsoft.com/office/drawing/2014/main" id="{C452DE78-BC0F-433A-8CED-645BFE2243D9}"/>
               </a:ext>
             </a:extLst>
           </p:cNvPr>
@@ -9954,7 +9954,7 @@
           <p:cNvPr id="6" name="">
             <a:extLst xmlns:a="http://schemas.openxmlformats.org/drawingml/2006/main">
               <a:ext uri="{FF2B5EF4-FFF2-40B4-BE49-F238E27FC236}">
-                <a16:creationId xmlns:a16="http://schemas.microsoft.com/office/drawing/2014/main" id="{C0ABD398-0D52-4AAB-8F31-CA323C6936AD}"/>
+                <a16:creationId xmlns:a16="http://schemas.microsoft.com/office/drawing/2014/main" id="{1DC360C2-645E-4369-BCD9-C91917F838B7}"/>
               </a:ext>
             </a:extLst>
           </p:cNvPr>
@@ -10004,7 +10004,7 @@
           <p:cNvPr id="7" name="">
             <a:extLst xmlns:a="http://schemas.openxmlformats.org/drawingml/2006/main">
               <a:ext uri="{FF2B5EF4-FFF2-40B4-BE49-F238E27FC236}">
-                <a16:creationId xmlns:a16="http://schemas.microsoft.com/office/drawing/2014/main" id="{261B7A50-EA3D-4B25-98C2-225805C25A00}"/>
+                <a16:creationId xmlns:a16="http://schemas.microsoft.com/office/drawing/2014/main" id="{E46F41F0-7007-4BE0-8FE0-4F4F8EDC7686}"/>
               </a:ext>
             </a:extLst>
           </p:cNvPr>
@@ -10054,7 +10054,7 @@
           <p:cNvPr id="8" name="">
             <a:extLst xmlns:a="http://schemas.openxmlformats.org/drawingml/2006/main">
               <a:ext uri="{FF2B5EF4-FFF2-40B4-BE49-F238E27FC236}">
-                <a16:creationId xmlns:a16="http://schemas.microsoft.com/office/drawing/2014/main" id="{BF5EF558-0359-480C-A2A7-D7AFB9AFDDAA}"/>
+                <a16:creationId xmlns:a16="http://schemas.microsoft.com/office/drawing/2014/main" id="{7B2ACB42-5350-45EB-A976-42F16B8C2FE3}"/>
               </a:ext>
             </a:extLst>
           </p:cNvPr>
@@ -10104,7 +10104,7 @@
           <p:cNvPr id="9" name="">
             <a:extLst xmlns:a="http://schemas.openxmlformats.org/drawingml/2006/main">
               <a:ext uri="{FF2B5EF4-FFF2-40B4-BE49-F238E27FC236}">
-                <a16:creationId xmlns:a16="http://schemas.microsoft.com/office/drawing/2014/main" id="{119CDA49-E1E7-49A1-B43A-0C48207CC93B}"/>
+                <a16:creationId xmlns:a16="http://schemas.microsoft.com/office/drawing/2014/main" id="{5E46BF44-6BB4-41DF-91DE-72EC8F451BC6}"/>
               </a:ext>
             </a:extLst>
           </p:cNvPr>
@@ -10154,7 +10154,7 @@
           <p:cNvPr id="10" name="">
             <a:extLst xmlns:a="http://schemas.openxmlformats.org/drawingml/2006/main">
               <a:ext uri="{FF2B5EF4-FFF2-40B4-BE49-F238E27FC236}">
-                <a16:creationId xmlns:a16="http://schemas.microsoft.com/office/drawing/2014/main" id="{536E7577-AF12-494D-8DE2-D2FCC0CEDD1C}"/>
+                <a16:creationId xmlns:a16="http://schemas.microsoft.com/office/drawing/2014/main" id="{1B055141-3644-4460-A4EC-B50FF39C2914}"/>
               </a:ext>
             </a:extLst>
           </p:cNvPr>
@@ -10189,7 +10189,7 @@
           <p:cNvPr id="11" name="">
             <a:extLst xmlns:a="http://schemas.openxmlformats.org/drawingml/2006/main">
               <a:ext uri="{FF2B5EF4-FFF2-40B4-BE49-F238E27FC236}">
-                <a16:creationId xmlns:a16="http://schemas.microsoft.com/office/drawing/2014/main" id="{440BEE88-2ED1-4B66-97E2-546AA07C881E}"/>
+                <a16:creationId xmlns:a16="http://schemas.microsoft.com/office/drawing/2014/main" id="{8BC6F6CF-B691-4F2A-8E0F-0B1FC5F77C5A}"/>
               </a:ext>
             </a:extLst>
           </p:cNvPr>
@@ -10239,7 +10239,7 @@
           <p:cNvPr id="12" name="">
             <a:extLst xmlns:a="http://schemas.openxmlformats.org/drawingml/2006/main">
               <a:ext uri="{FF2B5EF4-FFF2-40B4-BE49-F238E27FC236}">
-                <a16:creationId xmlns:a16="http://schemas.microsoft.com/office/drawing/2014/main" id="{4553FAC5-8B08-435E-B079-CD80F2938373}"/>
+                <a16:creationId xmlns:a16="http://schemas.microsoft.com/office/drawing/2014/main" id="{B9D623DC-676E-42DD-BE4E-DDE12F5535CF}"/>
               </a:ext>
             </a:extLst>
           </p:cNvPr>
@@ -10289,7 +10289,7 @@
           <p:cNvPr id="13" name="">
             <a:extLst xmlns:a="http://schemas.openxmlformats.org/drawingml/2006/main">
               <a:ext uri="{FF2B5EF4-FFF2-40B4-BE49-F238E27FC236}">
-                <a16:creationId xmlns:a16="http://schemas.microsoft.com/office/drawing/2014/main" id="{205CC170-39F9-49A5-95A3-8C404C1A8274}"/>
+                <a16:creationId xmlns:a16="http://schemas.microsoft.com/office/drawing/2014/main" id="{6CE6D5D1-7ADE-4EA3-A4EE-F7B2435F8D58}"/>
               </a:ext>
             </a:extLst>
           </p:cNvPr>
@@ -10339,7 +10339,7 @@
           <p:cNvPr id="14" name="">
             <a:extLst xmlns:a="http://schemas.openxmlformats.org/drawingml/2006/main">
               <a:ext uri="{FF2B5EF4-FFF2-40B4-BE49-F238E27FC236}">
-                <a16:creationId xmlns:a16="http://schemas.microsoft.com/office/drawing/2014/main" id="{F9B08F7D-09FD-4EFA-A347-D5DC1A5DFBE4}"/>
+                <a16:creationId xmlns:a16="http://schemas.microsoft.com/office/drawing/2014/main" id="{59CCA91B-2F8F-4187-A5AD-0730B25D7A8C}"/>
               </a:ext>
             </a:extLst>
           </p:cNvPr>
@@ -10376,7 +10376,7 @@
           <p:cNvPr id="15" name="">
             <a:extLst xmlns:a="http://schemas.openxmlformats.org/drawingml/2006/main">
               <a:ext uri="{FF2B5EF4-FFF2-40B4-BE49-F238E27FC236}">
-                <a16:creationId xmlns:a16="http://schemas.microsoft.com/office/drawing/2014/main" id="{69B58ED4-3095-48BC-AFBF-36866E9E008B}"/>
+                <a16:creationId xmlns:a16="http://schemas.microsoft.com/office/drawing/2014/main" id="{73D472A1-BA5C-4712-96CE-58937C90687E}"/>
               </a:ext>
             </a:extLst>
           </p:cNvPr>
@@ -10424,7 +10424,7 @@
     </p:spTree>
     <p:extLst>
       <p:ext uri="{BB962C8B-B14F-4D97-AF65-F5344CB8AC3E}">
-        <p14:creationId xmlns:p14="http://schemas.microsoft.com/office/powerpoint/2010/main" val="1626881487"/>
+        <p14:creationId xmlns:p14="http://schemas.microsoft.com/office/powerpoint/2010/main" val="880550762"/>
       </p:ext>
     </p:extLst>
   </p:cSld>
@@ -10455,7 +10455,7 @@
           <p:cNvPr id="1" name="">
             <a:extLst xmlns:a="http://schemas.openxmlformats.org/drawingml/2006/main">
               <a:ext uri="{FF2B5EF4-FFF2-40B4-BE49-F238E27FC236}">
-                <a16:creationId xmlns:a16="http://schemas.microsoft.com/office/drawing/2014/main" id="{163A44E2-3624-4B0B-AD3E-622E5E0F8667}"/>
+                <a16:creationId xmlns:a16="http://schemas.microsoft.com/office/drawing/2014/main" id="{0B3D7529-86BC-47E3-85FD-F4136C28ABAA}"/>
               </a:ext>
             </a:extLst>
           </p:cNvPr>
@@ -10505,7 +10505,7 @@
           <p:cNvPr id="2" name="">
             <a:extLst xmlns:a="http://schemas.openxmlformats.org/drawingml/2006/main">
               <a:ext uri="{FF2B5EF4-FFF2-40B4-BE49-F238E27FC236}">
-                <a16:creationId xmlns:a16="http://schemas.microsoft.com/office/drawing/2014/main" id="{EB87DD10-BB06-4DED-9944-42BDF23BB01D}"/>
+                <a16:creationId xmlns:a16="http://schemas.microsoft.com/office/drawing/2014/main" id="{E68F8CDE-44BC-413D-9575-3B148CF723EA}"/>
               </a:ext>
             </a:extLst>
           </p:cNvPr>
@@ -10555,7 +10555,7 @@
           <p:cNvPr id="3" name="">
             <a:extLst xmlns:a="http://schemas.openxmlformats.org/drawingml/2006/main">
               <a:ext uri="{FF2B5EF4-FFF2-40B4-BE49-F238E27FC236}">
-                <a16:creationId xmlns:a16="http://schemas.microsoft.com/office/drawing/2014/main" id="{479D148C-6C4A-445E-850F-7071C5C89ECF}"/>
+                <a16:creationId xmlns:a16="http://schemas.microsoft.com/office/drawing/2014/main" id="{098199D9-AA9F-44D0-8907-A7927B44FA6F}"/>
               </a:ext>
             </a:extLst>
           </p:cNvPr>
@@ -10586,7 +10586,7 @@
           <p:cNvPr id="4" name="">
             <a:extLst xmlns:a="http://schemas.openxmlformats.org/drawingml/2006/main">
               <a:ext uri="{FF2B5EF4-FFF2-40B4-BE49-F238E27FC236}">
-                <a16:creationId xmlns:a16="http://schemas.microsoft.com/office/drawing/2014/main" id="{585B9E5E-1ADA-4453-AD3F-7F24E5F54BF8}"/>
+                <a16:creationId xmlns:a16="http://schemas.microsoft.com/office/drawing/2014/main" id="{62A7B218-684B-4C4A-8122-16133050619C}"/>
               </a:ext>
             </a:extLst>
           </p:cNvPr>
@@ -10636,7 +10636,7 @@
           <p:cNvPr id="5" name="">
             <a:extLst xmlns:a="http://schemas.openxmlformats.org/drawingml/2006/main">
               <a:ext uri="{FF2B5EF4-FFF2-40B4-BE49-F238E27FC236}">
-                <a16:creationId xmlns:a16="http://schemas.microsoft.com/office/drawing/2014/main" id="{3F354FE3-FCC4-4634-8814-64B51C36F260}"/>
+                <a16:creationId xmlns:a16="http://schemas.microsoft.com/office/drawing/2014/main" id="{D2F51DB3-667A-498F-895E-994641C53111}"/>
               </a:ext>
             </a:extLst>
           </p:cNvPr>
@@ -10686,7 +10686,7 @@
           <p:cNvPr id="6" name="">
             <a:extLst xmlns:a="http://schemas.openxmlformats.org/drawingml/2006/main">
               <a:ext uri="{FF2B5EF4-FFF2-40B4-BE49-F238E27FC236}">
-                <a16:creationId xmlns:a16="http://schemas.microsoft.com/office/drawing/2014/main" id="{E943B82D-D842-494C-9C9D-FE967B63F2DA}"/>
+                <a16:creationId xmlns:a16="http://schemas.microsoft.com/office/drawing/2014/main" id="{B2645189-9645-4D84-9D13-AECFACFF2CC1}"/>
               </a:ext>
             </a:extLst>
           </p:cNvPr>
@@ -10736,7 +10736,7 @@
           <p:cNvPr id="7" name="">
             <a:extLst xmlns:a="http://schemas.openxmlformats.org/drawingml/2006/main">
               <a:ext uri="{FF2B5EF4-FFF2-40B4-BE49-F238E27FC236}">
-                <a16:creationId xmlns:a16="http://schemas.microsoft.com/office/drawing/2014/main" id="{9605778F-2241-45DF-857A-35723A571C4E}"/>
+                <a16:creationId xmlns:a16="http://schemas.microsoft.com/office/drawing/2014/main" id="{C05003E7-903D-4CF6-8417-E22A749B030D}"/>
               </a:ext>
             </a:extLst>
           </p:cNvPr>
@@ -10786,7 +10786,7 @@
           <p:cNvPr id="8" name="">
             <a:extLst xmlns:a="http://schemas.openxmlformats.org/drawingml/2006/main">
               <a:ext uri="{FF2B5EF4-FFF2-40B4-BE49-F238E27FC236}">
-                <a16:creationId xmlns:a16="http://schemas.microsoft.com/office/drawing/2014/main" id="{5E71F39A-9DE1-4A15-AE44-CC969792F1A6}"/>
+                <a16:creationId xmlns:a16="http://schemas.microsoft.com/office/drawing/2014/main" id="{C9A70531-E242-4CA3-B19A-92F22A1729AE}"/>
               </a:ext>
             </a:extLst>
           </p:cNvPr>
@@ -10836,7 +10836,7 @@
           <p:cNvPr id="9" name="">
             <a:extLst xmlns:a="http://schemas.openxmlformats.org/drawingml/2006/main">
               <a:ext uri="{FF2B5EF4-FFF2-40B4-BE49-F238E27FC236}">
-                <a16:creationId xmlns:a16="http://schemas.microsoft.com/office/drawing/2014/main" id="{E3F50116-10A2-4A4E-B0EF-D58111F22223}"/>
+                <a16:creationId xmlns:a16="http://schemas.microsoft.com/office/drawing/2014/main" id="{82C7BC01-0BF5-4665-AB07-E3872C613AAD}"/>
               </a:ext>
             </a:extLst>
           </p:cNvPr>
@@ -10886,7 +10886,7 @@
           <p:cNvPr id="10" name="">
             <a:extLst xmlns:a="http://schemas.openxmlformats.org/drawingml/2006/main">
               <a:ext uri="{FF2B5EF4-FFF2-40B4-BE49-F238E27FC236}">
-                <a16:creationId xmlns:a16="http://schemas.microsoft.com/office/drawing/2014/main" id="{59001277-6229-4B90-87FE-47C6F24FC99C}"/>
+                <a16:creationId xmlns:a16="http://schemas.microsoft.com/office/drawing/2014/main" id="{F37DDA06-FB04-4A2D-8013-CCAF14784752}"/>
               </a:ext>
             </a:extLst>
           </p:cNvPr>
@@ -10921,7 +10921,7 @@
           <p:cNvPr id="11" name="">
             <a:extLst xmlns:a="http://schemas.openxmlformats.org/drawingml/2006/main">
               <a:ext uri="{FF2B5EF4-FFF2-40B4-BE49-F238E27FC236}">
-                <a16:creationId xmlns:a16="http://schemas.microsoft.com/office/drawing/2014/main" id="{7BB91A80-416E-42DD-B308-6A97684D9FA6}"/>
+                <a16:creationId xmlns:a16="http://schemas.microsoft.com/office/drawing/2014/main" id="{FBEDA9C4-B64D-4D38-A814-02D67CB871CF}"/>
               </a:ext>
             </a:extLst>
           </p:cNvPr>
@@ -10971,7 +10971,7 @@
           <p:cNvPr id="12" name="">
             <a:extLst xmlns:a="http://schemas.openxmlformats.org/drawingml/2006/main">
               <a:ext uri="{FF2B5EF4-FFF2-40B4-BE49-F238E27FC236}">
-                <a16:creationId xmlns:a16="http://schemas.microsoft.com/office/drawing/2014/main" id="{CAFE7EBB-A873-4DED-8D1A-B7E1F7267333}"/>
+                <a16:creationId xmlns:a16="http://schemas.microsoft.com/office/drawing/2014/main" id="{FA4BA94A-5923-43AB-B24E-383AA5F21FD7}"/>
               </a:ext>
             </a:extLst>
           </p:cNvPr>
@@ -11021,7 +11021,7 @@
           <p:cNvPr id="13" name="">
             <a:extLst xmlns:a="http://schemas.openxmlformats.org/drawingml/2006/main">
               <a:ext uri="{FF2B5EF4-FFF2-40B4-BE49-F238E27FC236}">
-                <a16:creationId xmlns:a16="http://schemas.microsoft.com/office/drawing/2014/main" id="{10380243-4AC5-45BB-8AD2-E8FB6BAF6994}"/>
+                <a16:creationId xmlns:a16="http://schemas.microsoft.com/office/drawing/2014/main" id="{3B72B3C1-836A-4B97-94BC-59B3749041AC}"/>
               </a:ext>
             </a:extLst>
           </p:cNvPr>
@@ -11071,7 +11071,7 @@
           <p:cNvPr id="14" name="">
             <a:extLst xmlns:a="http://schemas.openxmlformats.org/drawingml/2006/main">
               <a:ext uri="{FF2B5EF4-FFF2-40B4-BE49-F238E27FC236}">
-                <a16:creationId xmlns:a16="http://schemas.microsoft.com/office/drawing/2014/main" id="{7BEB9D9F-5C0E-4AB3-B3C0-A7D42211D7EA}"/>
+                <a16:creationId xmlns:a16="http://schemas.microsoft.com/office/drawing/2014/main" id="{0DBF7A0A-07BA-4A05-9414-20F26F666AA3}"/>
               </a:ext>
             </a:extLst>
           </p:cNvPr>
@@ -11108,7 +11108,7 @@
           <p:cNvPr id="15" name="">
             <a:extLst xmlns:a="http://schemas.openxmlformats.org/drawingml/2006/main">
               <a:ext uri="{FF2B5EF4-FFF2-40B4-BE49-F238E27FC236}">
-                <a16:creationId xmlns:a16="http://schemas.microsoft.com/office/drawing/2014/main" id="{42F25427-70F4-416D-8A77-37E560E4E060}"/>
+                <a16:creationId xmlns:a16="http://schemas.microsoft.com/office/drawing/2014/main" id="{71201A64-7653-4767-947A-70A3113C9A98}"/>
               </a:ext>
             </a:extLst>
           </p:cNvPr>
@@ -11156,7 +11156,7 @@
     </p:spTree>
     <p:extLst>
       <p:ext uri="{BB962C8B-B14F-4D97-AF65-F5344CB8AC3E}">
-        <p14:creationId xmlns:p14="http://schemas.microsoft.com/office/powerpoint/2010/main" val="430519312"/>
+        <p14:creationId xmlns:p14="http://schemas.microsoft.com/office/powerpoint/2010/main" val="1669021399"/>
       </p:ext>
     </p:extLst>
   </p:cSld>
@@ -11187,7 +11187,7 @@
           <p:cNvPr id="1" name="">
             <a:extLst xmlns:a="http://schemas.openxmlformats.org/drawingml/2006/main">
               <a:ext uri="{FF2B5EF4-FFF2-40B4-BE49-F238E27FC236}">
-                <a16:creationId xmlns:a16="http://schemas.microsoft.com/office/drawing/2014/main" id="{95395DB9-D550-408D-934B-A63BBCA28B17}"/>
+                <a16:creationId xmlns:a16="http://schemas.microsoft.com/office/drawing/2014/main" id="{9CAA6C55-B111-457A-9385-25D48CCBECDC}"/>
               </a:ext>
             </a:extLst>
           </p:cNvPr>
@@ -11237,7 +11237,7 @@
           <p:cNvPr id="2" name="">
             <a:extLst xmlns:a="http://schemas.openxmlformats.org/drawingml/2006/main">
               <a:ext uri="{FF2B5EF4-FFF2-40B4-BE49-F238E27FC236}">
-                <a16:creationId xmlns:a16="http://schemas.microsoft.com/office/drawing/2014/main" id="{CEC73A43-F92D-4E73-BD94-0E8B0EFCAC85}"/>
+                <a16:creationId xmlns:a16="http://schemas.microsoft.com/office/drawing/2014/main" id="{8CD3140E-9EEF-4E0E-B6E7-7ADAAA9D30D4}"/>
               </a:ext>
             </a:extLst>
           </p:cNvPr>
@@ -11287,7 +11287,7 @@
           <p:cNvPr id="3" name="">
             <a:extLst xmlns:a="http://schemas.openxmlformats.org/drawingml/2006/main">
               <a:ext uri="{FF2B5EF4-FFF2-40B4-BE49-F238E27FC236}">
-                <a16:creationId xmlns:a16="http://schemas.microsoft.com/office/drawing/2014/main" id="{D3E8884D-F6AE-44DC-BF52-078057623DB8}"/>
+                <a16:creationId xmlns:a16="http://schemas.microsoft.com/office/drawing/2014/main" id="{ED97D261-A764-488A-8F59-5C5ACB718FB6}"/>
               </a:ext>
             </a:extLst>
           </p:cNvPr>
@@ -11318,79 +11318,228 @@
           <p:cNvPr id="4" name="">
             <a:extLst xmlns:a="http://schemas.openxmlformats.org/drawingml/2006/main">
               <a:ext uri="{FF2B5EF4-FFF2-40B4-BE49-F238E27FC236}">
-                <a16:creationId xmlns:a16="http://schemas.microsoft.com/office/drawing/2014/main" id="{D0F6414A-1676-44BA-9534-6C631CC69E0D}"/>
-              </a:ext>
-            </a:extLst>
-          </p:cNvPr>
-          <p:cNvSpPr>
-            <a:spLocks xmlns:a="http://schemas.openxmlformats.org/drawingml/2006/main" noGrp="1"/>
-          </p:cNvSpPr>
-          <p:nvPr/>
-        </p:nvSpPr>
-        <p:spPr>
-          <a:xfrm xmlns:a="http://schemas.openxmlformats.org/drawingml/2006/main">
-            <a:off x="838200" y="1809750"/>
-            <a:ext cx="4667250" cy="1409700"/>
-          </a:xfrm>
-          <a:prstGeom xmlns:a="http://schemas.openxmlformats.org/drawingml/2006/main" prst="roundRect">
-            <a:avLst>
-              <a:gd name="adj" fmla="val 5405"/>
-            </a:avLst>
+                <a16:creationId xmlns:a16="http://schemas.microsoft.com/office/drawing/2014/main" id="{67B2862A-87C0-4070-81E4-49CD77C0E0E5}"/>
+              </a:ext>
+            </a:extLst>
+          </p:cNvPr>
+          <p:cNvSpPr>
+            <a:spLocks xmlns:a="http://schemas.openxmlformats.org/drawingml/2006/main" noGrp="1"/>
+          </p:cNvSpPr>
+          <p:nvPr/>
+        </p:nvSpPr>
+        <p:spPr>
+          <a:xfrm xmlns:a="http://schemas.openxmlformats.org/drawingml/2006/main">
+            <a:off x="800100" y="1752600"/>
+            <a:ext cx="1619250" cy="247650"/>
+          </a:xfrm>
+          <a:prstGeom xmlns:a="http://schemas.openxmlformats.org/drawingml/2006/main" prst="rect">
+            <a:avLst/>
+          </a:prstGeom>
+          <a:noFill xmlns:a="http://schemas.openxmlformats.org/drawingml/2006/main"/>
+          <a:ln xmlns:a="http://schemas.openxmlformats.org/drawingml/2006/main" w="0">
+            <a:noFill/>
+            <a:prstDash val="solid"/>
+          </a:ln>
+        </p:spPr>
+        <p:txBody>
+          <a:bodyPr xmlns:a="http://schemas.openxmlformats.org/drawingml/2006/main"/>
+          <a:lstStyle xmlns:a="http://schemas.openxmlformats.org/drawingml/2006/main"/>
+          <a:p xmlns:a="http://schemas.openxmlformats.org/drawingml/2006/main">
+            <a:pPr algn="l">
+              <a:defRPr sz="1200" b="1">
+                <a:solidFill>
+                  <a:srgbClr val="667085"/>
+                </a:solidFill>
+              </a:defRPr>
+            </a:pPr>
+            <a:r>
+              <a:rPr sz="1200" b="1">
+                <a:solidFill>
+                  <a:srgbClr val="667085"/>
+                </a:solidFill>
+              </a:rPr>
+              <a:t>原始圖表</a:t>
+            </a:r>
+          </a:p>
+        </p:txBody>
+      </p:sp>
+      <p:pic>
+        <p:nvPicPr>
+          <p:cNvPr id="29" name=""/>
+          <p:cNvPicPr>
+            <a:picLocks xmlns:a="http://schemas.openxmlformats.org/drawingml/2006/main" noChangeAspect="1"/>
+          </p:cNvPicPr>
+          <p:nvPr/>
+        </p:nvPicPr>
+        <p:blipFill>
+          <a:blip xmlns:r="http://schemas.openxmlformats.org/officeDocument/2006/relationships" xmlns:a="http://schemas.openxmlformats.org/drawingml/2006/main" r:embed="R4a75606259d34b3c"/>
+          <a:stretch xmlns:a="http://schemas.openxmlformats.org/drawingml/2006/main"/>
+        </p:blipFill>
+        <p:spPr>
+          <a:xfrm xmlns:a="http://schemas.openxmlformats.org/drawingml/2006/main">
+            <a:off x="1126269" y="2057400"/>
+            <a:ext cx="5043612" cy="3790950"/>
+          </a:xfrm>
+          <a:prstGeom xmlns:a="http://schemas.openxmlformats.org/drawingml/2006/main" prst="rect">
+            <a:avLst/>
+          </a:prstGeom>
+        </p:spPr>
+      </p:pic>
+      <p:sp>
+        <p:nvSpPr>
+          <p:cNvPr id="6" name="">
+            <a:extLst xmlns:a="http://schemas.openxmlformats.org/drawingml/2006/main">
+              <a:ext uri="{FF2B5EF4-FFF2-40B4-BE49-F238E27FC236}">
+                <a16:creationId xmlns:a16="http://schemas.microsoft.com/office/drawing/2014/main" id="{CF43F4B1-E6FE-4496-9459-1A313C409ADA}"/>
+              </a:ext>
+            </a:extLst>
+          </p:cNvPr>
+          <p:cNvSpPr>
+            <a:spLocks xmlns:a="http://schemas.openxmlformats.org/drawingml/2006/main" noGrp="1"/>
+          </p:cNvSpPr>
+          <p:nvPr/>
+        </p:nvSpPr>
+        <p:spPr>
+          <a:xfrm xmlns:a="http://schemas.openxmlformats.org/drawingml/2006/main">
+            <a:off x="6858000" y="1790700"/>
+            <a:ext cx="19050" cy="4095750"/>
+          </a:xfrm>
+          <a:prstGeom xmlns:a="http://schemas.openxmlformats.org/drawingml/2006/main" prst="rect">
+            <a:avLst/>
           </a:prstGeom>
           <a:solidFill xmlns:a="http://schemas.openxmlformats.org/drawingml/2006/main">
-            <a:srgbClr val="FFFFFF"/>
+            <a:srgbClr val="D0D7E2"/>
           </a:solidFill>
-          <a:ln xmlns:a="http://schemas.openxmlformats.org/drawingml/2006/main" w="9525">
-            <a:solidFill>
-              <a:srgbClr val="CDD8E5"/>
-            </a:solidFill>
-            <a:prstDash val="solid"/>
-          </a:ln>
-        </p:spPr>
-      </p:sp>
-      <p:sp>
-        <p:nvSpPr>
-          <p:cNvPr id="5" name="">
-            <a:extLst xmlns:a="http://schemas.openxmlformats.org/drawingml/2006/main">
-              <a:ext uri="{FF2B5EF4-FFF2-40B4-BE49-F238E27FC236}">
-                <a16:creationId xmlns:a16="http://schemas.microsoft.com/office/drawing/2014/main" id="{F4C9A67F-F886-461D-8EAB-20D2B534E7B5}"/>
-              </a:ext>
-            </a:extLst>
-          </p:cNvPr>
-          <p:cNvSpPr>
-            <a:spLocks xmlns:a="http://schemas.openxmlformats.org/drawingml/2006/main" noGrp="1"/>
-          </p:cNvSpPr>
-          <p:nvPr/>
-        </p:nvSpPr>
-        <p:spPr>
-          <a:xfrm xmlns:a="http://schemas.openxmlformats.org/drawingml/2006/main">
-            <a:off x="1085850" y="2019300"/>
-            <a:ext cx="4095750" cy="304800"/>
-          </a:xfrm>
-          <a:prstGeom xmlns:a="http://schemas.openxmlformats.org/drawingml/2006/main" prst="rect">
-            <a:avLst/>
-          </a:prstGeom>
-          <a:noFill xmlns:a="http://schemas.openxmlformats.org/drawingml/2006/main"/>
-          <a:ln xmlns:a="http://schemas.openxmlformats.org/drawingml/2006/main" w="0">
-            <a:noFill/>
-            <a:prstDash val="solid"/>
-          </a:ln>
-        </p:spPr>
-        <p:txBody>
-          <a:bodyPr xmlns:a="http://schemas.openxmlformats.org/drawingml/2006/main"/>
-          <a:lstStyle xmlns:a="http://schemas.openxmlformats.org/drawingml/2006/main"/>
-          <a:p xmlns:a="http://schemas.openxmlformats.org/drawingml/2006/main">
-            <a:pPr algn="l">
-              <a:defRPr sz="1875" b="1">
-                <a:solidFill>
-                  <a:srgbClr val="B42318"/>
-                </a:solidFill>
-              </a:defRPr>
-            </a:pPr>
-            <a:r>
-              <a:rPr sz="1875" b="1">
-                <a:solidFill>
-                  <a:srgbClr val="B42318"/>
+          <a:ln xmlns:a="http://schemas.openxmlformats.org/drawingml/2006/main" w="0">
+            <a:noFill/>
+            <a:prstDash val="solid"/>
+          </a:ln>
+        </p:spPr>
+      </p:sp>
+      <p:sp>
+        <p:nvSpPr>
+          <p:cNvPr id="7" name="">
+            <a:extLst xmlns:a="http://schemas.openxmlformats.org/drawingml/2006/main">
+              <a:ext uri="{FF2B5EF4-FFF2-40B4-BE49-F238E27FC236}">
+                <a16:creationId xmlns:a16="http://schemas.microsoft.com/office/drawing/2014/main" id="{D7B35ADC-FAD6-418E-BE55-D26B926B6AA2}"/>
+              </a:ext>
+            </a:extLst>
+          </p:cNvPr>
+          <p:cNvSpPr>
+            <a:spLocks xmlns:a="http://schemas.openxmlformats.org/drawingml/2006/main" noGrp="1"/>
+          </p:cNvSpPr>
+          <p:nvPr/>
+        </p:nvSpPr>
+        <p:spPr>
+          <a:xfrm xmlns:a="http://schemas.openxmlformats.org/drawingml/2006/main">
+            <a:off x="7181850" y="1752600"/>
+            <a:ext cx="1905000" cy="247650"/>
+          </a:xfrm>
+          <a:prstGeom xmlns:a="http://schemas.openxmlformats.org/drawingml/2006/main" prst="rect">
+            <a:avLst/>
+          </a:prstGeom>
+          <a:noFill xmlns:a="http://schemas.openxmlformats.org/drawingml/2006/main"/>
+          <a:ln xmlns:a="http://schemas.openxmlformats.org/drawingml/2006/main" w="0">
+            <a:noFill/>
+            <a:prstDash val="solid"/>
+          </a:ln>
+        </p:spPr>
+        <p:txBody>
+          <a:bodyPr xmlns:a="http://schemas.openxmlformats.org/drawingml/2006/main"/>
+          <a:lstStyle xmlns:a="http://schemas.openxmlformats.org/drawingml/2006/main"/>
+          <a:p xmlns:a="http://schemas.openxmlformats.org/drawingml/2006/main">
+            <a:pPr algn="l">
+              <a:defRPr sz="1200" b="1">
+                <a:solidFill>
+                  <a:srgbClr val="667085"/>
+                </a:solidFill>
+              </a:defRPr>
+            </a:pPr>
+            <a:r>
+              <a:rPr sz="1200" b="1">
+                <a:solidFill>
+                  <a:srgbClr val="667085"/>
+                </a:solidFill>
+              </a:rPr>
+              <a:t>臨床解讀</a:t>
+            </a:r>
+          </a:p>
+        </p:txBody>
+      </p:sp>
+      <p:sp>
+        <p:nvSpPr>
+          <p:cNvPr id="8" name="">
+            <a:extLst xmlns:a="http://schemas.openxmlformats.org/drawingml/2006/main">
+              <a:ext uri="{FF2B5EF4-FFF2-40B4-BE49-F238E27FC236}">
+                <a16:creationId xmlns:a16="http://schemas.microsoft.com/office/drawing/2014/main" id="{4DF13926-47F0-4981-BFFF-94DD06BC9A95}"/>
+              </a:ext>
+            </a:extLst>
+          </p:cNvPr>
+          <p:cNvSpPr>
+            <a:spLocks xmlns:a="http://schemas.openxmlformats.org/drawingml/2006/main" noGrp="1"/>
+          </p:cNvSpPr>
+          <p:nvPr/>
+        </p:nvSpPr>
+        <p:spPr>
+          <a:xfrm xmlns:a="http://schemas.openxmlformats.org/drawingml/2006/main">
+            <a:off x="7181850" y="2133600"/>
+            <a:ext cx="76200" cy="552450"/>
+          </a:xfrm>
+          <a:prstGeom xmlns:a="http://schemas.openxmlformats.org/drawingml/2006/main" prst="rect">
+            <a:avLst/>
+          </a:prstGeom>
+          <a:solidFill xmlns:a="http://schemas.openxmlformats.org/drawingml/2006/main">
+            <a:srgbClr val="B42318"/>
+          </a:solidFill>
+          <a:ln xmlns:a="http://schemas.openxmlformats.org/drawingml/2006/main" w="0">
+            <a:noFill/>
+            <a:prstDash val="solid"/>
+          </a:ln>
+        </p:spPr>
+      </p:sp>
+      <p:sp>
+        <p:nvSpPr>
+          <p:cNvPr id="9" name="">
+            <a:extLst xmlns:a="http://schemas.openxmlformats.org/drawingml/2006/main">
+              <a:ext uri="{FF2B5EF4-FFF2-40B4-BE49-F238E27FC236}">
+                <a16:creationId xmlns:a16="http://schemas.microsoft.com/office/drawing/2014/main" id="{74209598-F265-47D8-9180-AC72880F9003}"/>
+              </a:ext>
+            </a:extLst>
+          </p:cNvPr>
+          <p:cNvSpPr>
+            <a:spLocks xmlns:a="http://schemas.openxmlformats.org/drawingml/2006/main" noGrp="1"/>
+          </p:cNvSpPr>
+          <p:nvPr/>
+        </p:nvSpPr>
+        <p:spPr>
+          <a:xfrm xmlns:a="http://schemas.openxmlformats.org/drawingml/2006/main">
+            <a:off x="7448550" y="2133600"/>
+            <a:ext cx="3333750" cy="266700"/>
+          </a:xfrm>
+          <a:prstGeom xmlns:a="http://schemas.openxmlformats.org/drawingml/2006/main" prst="rect">
+            <a:avLst/>
+          </a:prstGeom>
+          <a:noFill xmlns:a="http://schemas.openxmlformats.org/drawingml/2006/main"/>
+          <a:ln xmlns:a="http://schemas.openxmlformats.org/drawingml/2006/main" w="0">
+            <a:noFill/>
+            <a:prstDash val="solid"/>
+          </a:ln>
+        </p:spPr>
+        <p:txBody>
+          <a:bodyPr xmlns:a="http://schemas.openxmlformats.org/drawingml/2006/main"/>
+          <a:lstStyle xmlns:a="http://schemas.openxmlformats.org/drawingml/2006/main"/>
+          <a:p xmlns:a="http://schemas.openxmlformats.org/drawingml/2006/main">
+            <a:pPr algn="l">
+              <a:defRPr sz="1725" b="1">
+                <a:solidFill>
+                  <a:srgbClr val="0B2F59"/>
+                </a:solidFill>
+              </a:defRPr>
+            </a:pPr>
+            <a:r>
+              <a:rPr sz="1725" b="1">
+                <a:solidFill>
+                  <a:srgbClr val="0B2F59"/>
                 </a:solidFill>
               </a:rPr>
               <a:t>Medical</a:t>
@@ -11400,45 +11549,45 @@
       </p:sp>
       <p:sp>
         <p:nvSpPr>
-          <p:cNvPr id="6" name="">
-            <a:extLst xmlns:a="http://schemas.openxmlformats.org/drawingml/2006/main">
-              <a:ext uri="{FF2B5EF4-FFF2-40B4-BE49-F238E27FC236}">
-                <a16:creationId xmlns:a16="http://schemas.microsoft.com/office/drawing/2014/main" id="{09A72941-E7E0-4ABB-BEAE-D126B904E0EF}"/>
-              </a:ext>
-            </a:extLst>
-          </p:cNvPr>
-          <p:cNvSpPr>
-            <a:spLocks xmlns:a="http://schemas.openxmlformats.org/drawingml/2006/main" noGrp="1"/>
-          </p:cNvSpPr>
-          <p:nvPr/>
-        </p:nvSpPr>
-        <p:spPr>
-          <a:xfrm xmlns:a="http://schemas.openxmlformats.org/drawingml/2006/main">
-            <a:off x="1085850" y="2457450"/>
-            <a:ext cx="4095750" cy="495300"/>
-          </a:xfrm>
-          <a:prstGeom xmlns:a="http://schemas.openxmlformats.org/drawingml/2006/main" prst="rect">
-            <a:avLst/>
-          </a:prstGeom>
-          <a:noFill xmlns:a="http://schemas.openxmlformats.org/drawingml/2006/main"/>
-          <a:ln xmlns:a="http://schemas.openxmlformats.org/drawingml/2006/main" w="0">
-            <a:noFill/>
-            <a:prstDash val="solid"/>
-          </a:ln>
-        </p:spPr>
-        <p:txBody>
-          <a:bodyPr xmlns:a="http://schemas.openxmlformats.org/drawingml/2006/main"/>
-          <a:lstStyle xmlns:a="http://schemas.openxmlformats.org/drawingml/2006/main"/>
-          <a:p xmlns:a="http://schemas.openxmlformats.org/drawingml/2006/main">
-            <a:pPr algn="l">
-              <a:defRPr sz="1575" b="0">
+          <p:cNvPr id="10" name="">
+            <a:extLst xmlns:a="http://schemas.openxmlformats.org/drawingml/2006/main">
+              <a:ext uri="{FF2B5EF4-FFF2-40B4-BE49-F238E27FC236}">
+                <a16:creationId xmlns:a16="http://schemas.microsoft.com/office/drawing/2014/main" id="{97A20A91-7D06-4A7C-B29F-5A53A7E4A76B}"/>
+              </a:ext>
+            </a:extLst>
+          </p:cNvPr>
+          <p:cNvSpPr>
+            <a:spLocks xmlns:a="http://schemas.openxmlformats.org/drawingml/2006/main" noGrp="1"/>
+          </p:cNvSpPr>
+          <p:nvPr/>
+        </p:nvSpPr>
+        <p:spPr>
+          <a:xfrm xmlns:a="http://schemas.openxmlformats.org/drawingml/2006/main">
+            <a:off x="7448550" y="2457450"/>
+            <a:ext cx="3600450" cy="457200"/>
+          </a:xfrm>
+          <a:prstGeom xmlns:a="http://schemas.openxmlformats.org/drawingml/2006/main" prst="rect">
+            <a:avLst/>
+          </a:prstGeom>
+          <a:noFill xmlns:a="http://schemas.openxmlformats.org/drawingml/2006/main"/>
+          <a:ln xmlns:a="http://schemas.openxmlformats.org/drawingml/2006/main" w="0">
+            <a:noFill/>
+            <a:prstDash val="solid"/>
+          </a:ln>
+        </p:spPr>
+        <p:txBody>
+          <a:bodyPr xmlns:a="http://schemas.openxmlformats.org/drawingml/2006/main"/>
+          <a:lstStyle xmlns:a="http://schemas.openxmlformats.org/drawingml/2006/main"/>
+          <a:p xmlns:a="http://schemas.openxmlformats.org/drawingml/2006/main">
+            <a:pPr algn="l">
+              <a:defRPr sz="1350" b="0">
                 <a:solidFill>
                   <a:srgbClr val="182230"/>
                 </a:solidFill>
               </a:defRPr>
             </a:pPr>
             <a:r>
-              <a:rPr sz="1575" b="0">
+              <a:rPr sz="1350" b="0">
                 <a:solidFill>
                   <a:srgbClr val="182230"/>
                 </a:solidFill>
@@ -11450,82 +11599,78 @@
       </p:sp>
       <p:sp>
         <p:nvSpPr>
-          <p:cNvPr id="7" name="">
-            <a:extLst xmlns:a="http://schemas.openxmlformats.org/drawingml/2006/main">
-              <a:ext uri="{FF2B5EF4-FFF2-40B4-BE49-F238E27FC236}">
-                <a16:creationId xmlns:a16="http://schemas.microsoft.com/office/drawing/2014/main" id="{C781F4B3-FE51-4829-A3BE-1AC5F68A0805}"/>
-              </a:ext>
-            </a:extLst>
-          </p:cNvPr>
-          <p:cNvSpPr>
-            <a:spLocks xmlns:a="http://schemas.openxmlformats.org/drawingml/2006/main" noGrp="1"/>
-          </p:cNvSpPr>
-          <p:nvPr/>
-        </p:nvSpPr>
-        <p:spPr>
-          <a:xfrm xmlns:a="http://schemas.openxmlformats.org/drawingml/2006/main">
-            <a:off x="6343650" y="1809750"/>
-            <a:ext cx="4667250" cy="1409700"/>
-          </a:xfrm>
-          <a:prstGeom xmlns:a="http://schemas.openxmlformats.org/drawingml/2006/main" prst="roundRect">
-            <a:avLst>
-              <a:gd name="adj" fmla="val 5405"/>
-            </a:avLst>
+          <p:cNvPr id="11" name="">
+            <a:extLst xmlns:a="http://schemas.openxmlformats.org/drawingml/2006/main">
+              <a:ext uri="{FF2B5EF4-FFF2-40B4-BE49-F238E27FC236}">
+                <a16:creationId xmlns:a16="http://schemas.microsoft.com/office/drawing/2014/main" id="{EAC5B0C5-A432-436E-A99D-BB455B6C5468}"/>
+              </a:ext>
+            </a:extLst>
+          </p:cNvPr>
+          <p:cNvSpPr>
+            <a:spLocks xmlns:a="http://schemas.openxmlformats.org/drawingml/2006/main" noGrp="1"/>
+          </p:cNvSpPr>
+          <p:nvPr/>
+        </p:nvSpPr>
+        <p:spPr>
+          <a:xfrm xmlns:a="http://schemas.openxmlformats.org/drawingml/2006/main">
+            <a:off x="7181850" y="3028950"/>
+            <a:ext cx="76200" cy="552450"/>
+          </a:xfrm>
+          <a:prstGeom xmlns:a="http://schemas.openxmlformats.org/drawingml/2006/main" prst="rect">
+            <a:avLst/>
           </a:prstGeom>
           <a:solidFill xmlns:a="http://schemas.openxmlformats.org/drawingml/2006/main">
-            <a:srgbClr val="FFFFFF"/>
+            <a:srgbClr val="1B6CA8"/>
           </a:solidFill>
-          <a:ln xmlns:a="http://schemas.openxmlformats.org/drawingml/2006/main" w="9525">
-            <a:solidFill>
-              <a:srgbClr val="CDD8E5"/>
-            </a:solidFill>
-            <a:prstDash val="solid"/>
-          </a:ln>
-        </p:spPr>
-      </p:sp>
-      <p:sp>
-        <p:nvSpPr>
-          <p:cNvPr id="8" name="">
-            <a:extLst xmlns:a="http://schemas.openxmlformats.org/drawingml/2006/main">
-              <a:ext uri="{FF2B5EF4-FFF2-40B4-BE49-F238E27FC236}">
-                <a16:creationId xmlns:a16="http://schemas.microsoft.com/office/drawing/2014/main" id="{584D5111-F1B6-4155-9CDB-F701DFB12B13}"/>
-              </a:ext>
-            </a:extLst>
-          </p:cNvPr>
-          <p:cNvSpPr>
-            <a:spLocks xmlns:a="http://schemas.openxmlformats.org/drawingml/2006/main" noGrp="1"/>
-          </p:cNvSpPr>
-          <p:nvPr/>
-        </p:nvSpPr>
-        <p:spPr>
-          <a:xfrm xmlns:a="http://schemas.openxmlformats.org/drawingml/2006/main">
-            <a:off x="6591300" y="2019300"/>
-            <a:ext cx="4095750" cy="304800"/>
-          </a:xfrm>
-          <a:prstGeom xmlns:a="http://schemas.openxmlformats.org/drawingml/2006/main" prst="rect">
-            <a:avLst/>
-          </a:prstGeom>
-          <a:noFill xmlns:a="http://schemas.openxmlformats.org/drawingml/2006/main"/>
-          <a:ln xmlns:a="http://schemas.openxmlformats.org/drawingml/2006/main" w="0">
-            <a:noFill/>
-            <a:prstDash val="solid"/>
-          </a:ln>
-        </p:spPr>
-        <p:txBody>
-          <a:bodyPr xmlns:a="http://schemas.openxmlformats.org/drawingml/2006/main"/>
-          <a:lstStyle xmlns:a="http://schemas.openxmlformats.org/drawingml/2006/main"/>
-          <a:p xmlns:a="http://schemas.openxmlformats.org/drawingml/2006/main">
-            <a:pPr algn="l">
-              <a:defRPr sz="1875" b="1">
-                <a:solidFill>
-                  <a:srgbClr val="1B6CA8"/>
-                </a:solidFill>
-              </a:defRPr>
-            </a:pPr>
-            <a:r>
-              <a:rPr sz="1875" b="1">
-                <a:solidFill>
-                  <a:srgbClr val="1B6CA8"/>
+          <a:ln xmlns:a="http://schemas.openxmlformats.org/drawingml/2006/main" w="0">
+            <a:noFill/>
+            <a:prstDash val="solid"/>
+          </a:ln>
+        </p:spPr>
+      </p:sp>
+      <p:sp>
+        <p:nvSpPr>
+          <p:cNvPr id="12" name="">
+            <a:extLst xmlns:a="http://schemas.openxmlformats.org/drawingml/2006/main">
+              <a:ext uri="{FF2B5EF4-FFF2-40B4-BE49-F238E27FC236}">
+                <a16:creationId xmlns:a16="http://schemas.microsoft.com/office/drawing/2014/main" id="{7C6BCDF3-7862-4B9C-97EF-CDEFBF40A42D}"/>
+              </a:ext>
+            </a:extLst>
+          </p:cNvPr>
+          <p:cNvSpPr>
+            <a:spLocks xmlns:a="http://schemas.openxmlformats.org/drawingml/2006/main" noGrp="1"/>
+          </p:cNvSpPr>
+          <p:nvPr/>
+        </p:nvSpPr>
+        <p:spPr>
+          <a:xfrm xmlns:a="http://schemas.openxmlformats.org/drawingml/2006/main">
+            <a:off x="7448550" y="3028950"/>
+            <a:ext cx="3333750" cy="266700"/>
+          </a:xfrm>
+          <a:prstGeom xmlns:a="http://schemas.openxmlformats.org/drawingml/2006/main" prst="rect">
+            <a:avLst/>
+          </a:prstGeom>
+          <a:noFill xmlns:a="http://schemas.openxmlformats.org/drawingml/2006/main"/>
+          <a:ln xmlns:a="http://schemas.openxmlformats.org/drawingml/2006/main" w="0">
+            <a:noFill/>
+            <a:prstDash val="solid"/>
+          </a:ln>
+        </p:spPr>
+        <p:txBody>
+          <a:bodyPr xmlns:a="http://schemas.openxmlformats.org/drawingml/2006/main"/>
+          <a:lstStyle xmlns:a="http://schemas.openxmlformats.org/drawingml/2006/main"/>
+          <a:p xmlns:a="http://schemas.openxmlformats.org/drawingml/2006/main">
+            <a:pPr algn="l">
+              <a:defRPr sz="1725" b="1">
+                <a:solidFill>
+                  <a:srgbClr val="0B2F59"/>
+                </a:solidFill>
+              </a:defRPr>
+            </a:pPr>
+            <a:r>
+              <a:rPr sz="1725" b="1">
+                <a:solidFill>
+                  <a:srgbClr val="0B2F59"/>
                 </a:solidFill>
               </a:rPr>
               <a:t>Mind and emotion</a:t>
@@ -11535,45 +11680,45 @@
       </p:sp>
       <p:sp>
         <p:nvSpPr>
-          <p:cNvPr id="9" name="">
-            <a:extLst xmlns:a="http://schemas.openxmlformats.org/drawingml/2006/main">
-              <a:ext uri="{FF2B5EF4-FFF2-40B4-BE49-F238E27FC236}">
-                <a16:creationId xmlns:a16="http://schemas.microsoft.com/office/drawing/2014/main" id="{E360E9B3-2FB3-41AD-876C-B365E67528A1}"/>
-              </a:ext>
-            </a:extLst>
-          </p:cNvPr>
-          <p:cNvSpPr>
-            <a:spLocks xmlns:a="http://schemas.openxmlformats.org/drawingml/2006/main" noGrp="1"/>
-          </p:cNvSpPr>
-          <p:nvPr/>
-        </p:nvSpPr>
-        <p:spPr>
-          <a:xfrm xmlns:a="http://schemas.openxmlformats.org/drawingml/2006/main">
-            <a:off x="6591300" y="2457450"/>
-            <a:ext cx="4095750" cy="495300"/>
-          </a:xfrm>
-          <a:prstGeom xmlns:a="http://schemas.openxmlformats.org/drawingml/2006/main" prst="rect">
-            <a:avLst/>
-          </a:prstGeom>
-          <a:noFill xmlns:a="http://schemas.openxmlformats.org/drawingml/2006/main"/>
-          <a:ln xmlns:a="http://schemas.openxmlformats.org/drawingml/2006/main" w="0">
-            <a:noFill/>
-            <a:prstDash val="solid"/>
-          </a:ln>
-        </p:spPr>
-        <p:txBody>
-          <a:bodyPr xmlns:a="http://schemas.openxmlformats.org/drawingml/2006/main"/>
-          <a:lstStyle xmlns:a="http://schemas.openxmlformats.org/drawingml/2006/main"/>
-          <a:p xmlns:a="http://schemas.openxmlformats.org/drawingml/2006/main">
-            <a:pPr algn="l">
-              <a:defRPr sz="1575" b="0">
+          <p:cNvPr id="13" name="">
+            <a:extLst xmlns:a="http://schemas.openxmlformats.org/drawingml/2006/main">
+              <a:ext uri="{FF2B5EF4-FFF2-40B4-BE49-F238E27FC236}">
+                <a16:creationId xmlns:a16="http://schemas.microsoft.com/office/drawing/2014/main" id="{7D3B0607-A95D-4A31-9506-F427AC86B3A6}"/>
+              </a:ext>
+            </a:extLst>
+          </p:cNvPr>
+          <p:cNvSpPr>
+            <a:spLocks xmlns:a="http://schemas.openxmlformats.org/drawingml/2006/main" noGrp="1"/>
+          </p:cNvSpPr>
+          <p:nvPr/>
+        </p:nvSpPr>
+        <p:spPr>
+          <a:xfrm xmlns:a="http://schemas.openxmlformats.org/drawingml/2006/main">
+            <a:off x="7448550" y="3352800"/>
+            <a:ext cx="3600450" cy="457200"/>
+          </a:xfrm>
+          <a:prstGeom xmlns:a="http://schemas.openxmlformats.org/drawingml/2006/main" prst="rect">
+            <a:avLst/>
+          </a:prstGeom>
+          <a:noFill xmlns:a="http://schemas.openxmlformats.org/drawingml/2006/main"/>
+          <a:ln xmlns:a="http://schemas.openxmlformats.org/drawingml/2006/main" w="0">
+            <a:noFill/>
+            <a:prstDash val="solid"/>
+          </a:ln>
+        </p:spPr>
+        <p:txBody>
+          <a:bodyPr xmlns:a="http://schemas.openxmlformats.org/drawingml/2006/main"/>
+          <a:lstStyle xmlns:a="http://schemas.openxmlformats.org/drawingml/2006/main"/>
+          <a:p xmlns:a="http://schemas.openxmlformats.org/drawingml/2006/main">
+            <a:pPr algn="l">
+              <a:defRPr sz="1350" b="0">
                 <a:solidFill>
                   <a:srgbClr val="182230"/>
                 </a:solidFill>
               </a:defRPr>
             </a:pPr>
             <a:r>
-              <a:rPr sz="1575" b="0">
+              <a:rPr sz="1350" b="0">
                 <a:solidFill>
                   <a:srgbClr val="182230"/>
                 </a:solidFill>
@@ -11585,82 +11730,78 @@
       </p:sp>
       <p:sp>
         <p:nvSpPr>
-          <p:cNvPr id="10" name="">
-            <a:extLst xmlns:a="http://schemas.openxmlformats.org/drawingml/2006/main">
-              <a:ext uri="{FF2B5EF4-FFF2-40B4-BE49-F238E27FC236}">
-                <a16:creationId xmlns:a16="http://schemas.microsoft.com/office/drawing/2014/main" id="{D443D223-838D-4DB6-A994-1F2EEB24CFC8}"/>
-              </a:ext>
-            </a:extLst>
-          </p:cNvPr>
-          <p:cNvSpPr>
-            <a:spLocks xmlns:a="http://schemas.openxmlformats.org/drawingml/2006/main" noGrp="1"/>
-          </p:cNvSpPr>
-          <p:nvPr/>
-        </p:nvSpPr>
-        <p:spPr>
-          <a:xfrm xmlns:a="http://schemas.openxmlformats.org/drawingml/2006/main">
-            <a:off x="838200" y="3771900"/>
-            <a:ext cx="4667250" cy="1409700"/>
-          </a:xfrm>
-          <a:prstGeom xmlns:a="http://schemas.openxmlformats.org/drawingml/2006/main" prst="roundRect">
-            <a:avLst>
-              <a:gd name="adj" fmla="val 5405"/>
-            </a:avLst>
+          <p:cNvPr id="14" name="">
+            <a:extLst xmlns:a="http://schemas.openxmlformats.org/drawingml/2006/main">
+              <a:ext uri="{FF2B5EF4-FFF2-40B4-BE49-F238E27FC236}">
+                <a16:creationId xmlns:a16="http://schemas.microsoft.com/office/drawing/2014/main" id="{C6D9BE50-54A0-444A-8A24-F744B62F7E20}"/>
+              </a:ext>
+            </a:extLst>
+          </p:cNvPr>
+          <p:cNvSpPr>
+            <a:spLocks xmlns:a="http://schemas.openxmlformats.org/drawingml/2006/main" noGrp="1"/>
+          </p:cNvSpPr>
+          <p:nvPr/>
+        </p:nvSpPr>
+        <p:spPr>
+          <a:xfrm xmlns:a="http://schemas.openxmlformats.org/drawingml/2006/main">
+            <a:off x="7181850" y="3924300"/>
+            <a:ext cx="76200" cy="552450"/>
+          </a:xfrm>
+          <a:prstGeom xmlns:a="http://schemas.openxmlformats.org/drawingml/2006/main" prst="rect">
+            <a:avLst/>
           </a:prstGeom>
           <a:solidFill xmlns:a="http://schemas.openxmlformats.org/drawingml/2006/main">
-            <a:srgbClr val="FFFFFF"/>
+            <a:srgbClr val="1F8A8A"/>
           </a:solidFill>
-          <a:ln xmlns:a="http://schemas.openxmlformats.org/drawingml/2006/main" w="9525">
-            <a:solidFill>
-              <a:srgbClr val="CDD8E5"/>
-            </a:solidFill>
-            <a:prstDash val="solid"/>
-          </a:ln>
-        </p:spPr>
-      </p:sp>
-      <p:sp>
-        <p:nvSpPr>
-          <p:cNvPr id="11" name="">
-            <a:extLst xmlns:a="http://schemas.openxmlformats.org/drawingml/2006/main">
-              <a:ext uri="{FF2B5EF4-FFF2-40B4-BE49-F238E27FC236}">
-                <a16:creationId xmlns:a16="http://schemas.microsoft.com/office/drawing/2014/main" id="{AAAF4003-AC1E-427F-B301-D8F387CFC432}"/>
-              </a:ext>
-            </a:extLst>
-          </p:cNvPr>
-          <p:cNvSpPr>
-            <a:spLocks xmlns:a="http://schemas.openxmlformats.org/drawingml/2006/main" noGrp="1"/>
-          </p:cNvSpPr>
-          <p:nvPr/>
-        </p:nvSpPr>
-        <p:spPr>
-          <a:xfrm xmlns:a="http://schemas.openxmlformats.org/drawingml/2006/main">
-            <a:off x="1085850" y="3981450"/>
-            <a:ext cx="4095750" cy="304800"/>
-          </a:xfrm>
-          <a:prstGeom xmlns:a="http://schemas.openxmlformats.org/drawingml/2006/main" prst="rect">
-            <a:avLst/>
-          </a:prstGeom>
-          <a:noFill xmlns:a="http://schemas.openxmlformats.org/drawingml/2006/main"/>
-          <a:ln xmlns:a="http://schemas.openxmlformats.org/drawingml/2006/main" w="0">
-            <a:noFill/>
-            <a:prstDash val="solid"/>
-          </a:ln>
-        </p:spPr>
-        <p:txBody>
-          <a:bodyPr xmlns:a="http://schemas.openxmlformats.org/drawingml/2006/main"/>
-          <a:lstStyle xmlns:a="http://schemas.openxmlformats.org/drawingml/2006/main"/>
-          <a:p xmlns:a="http://schemas.openxmlformats.org/drawingml/2006/main">
-            <a:pPr algn="l">
-              <a:defRPr sz="1875" b="1">
-                <a:solidFill>
-                  <a:srgbClr val="1F8A8A"/>
-                </a:solidFill>
-              </a:defRPr>
-            </a:pPr>
-            <a:r>
-              <a:rPr sz="1875" b="1">
-                <a:solidFill>
-                  <a:srgbClr val="1F8A8A"/>
+          <a:ln xmlns:a="http://schemas.openxmlformats.org/drawingml/2006/main" w="0">
+            <a:noFill/>
+            <a:prstDash val="solid"/>
+          </a:ln>
+        </p:spPr>
+      </p:sp>
+      <p:sp>
+        <p:nvSpPr>
+          <p:cNvPr id="15" name="">
+            <a:extLst xmlns:a="http://schemas.openxmlformats.org/drawingml/2006/main">
+              <a:ext uri="{FF2B5EF4-FFF2-40B4-BE49-F238E27FC236}">
+                <a16:creationId xmlns:a16="http://schemas.microsoft.com/office/drawing/2014/main" id="{6457644F-6979-40A5-9290-D457DD6FFEAB}"/>
+              </a:ext>
+            </a:extLst>
+          </p:cNvPr>
+          <p:cNvSpPr>
+            <a:spLocks xmlns:a="http://schemas.openxmlformats.org/drawingml/2006/main" noGrp="1"/>
+          </p:cNvSpPr>
+          <p:nvPr/>
+        </p:nvSpPr>
+        <p:spPr>
+          <a:xfrm xmlns:a="http://schemas.openxmlformats.org/drawingml/2006/main">
+            <a:off x="7448550" y="3924300"/>
+            <a:ext cx="3333750" cy="266700"/>
+          </a:xfrm>
+          <a:prstGeom xmlns:a="http://schemas.openxmlformats.org/drawingml/2006/main" prst="rect">
+            <a:avLst/>
+          </a:prstGeom>
+          <a:noFill xmlns:a="http://schemas.openxmlformats.org/drawingml/2006/main"/>
+          <a:ln xmlns:a="http://schemas.openxmlformats.org/drawingml/2006/main" w="0">
+            <a:noFill/>
+            <a:prstDash val="solid"/>
+          </a:ln>
+        </p:spPr>
+        <p:txBody>
+          <a:bodyPr xmlns:a="http://schemas.openxmlformats.org/drawingml/2006/main"/>
+          <a:lstStyle xmlns:a="http://schemas.openxmlformats.org/drawingml/2006/main"/>
+          <a:p xmlns:a="http://schemas.openxmlformats.org/drawingml/2006/main">
+            <a:pPr algn="l">
+              <a:defRPr sz="1725" b="1">
+                <a:solidFill>
+                  <a:srgbClr val="0B2F59"/>
+                </a:solidFill>
+              </a:defRPr>
+            </a:pPr>
+            <a:r>
+              <a:rPr sz="1725" b="1">
+                <a:solidFill>
+                  <a:srgbClr val="0B2F59"/>
                 </a:solidFill>
               </a:rPr>
               <a:t>Physical</a:t>
@@ -11670,45 +11811,45 @@
       </p:sp>
       <p:sp>
         <p:nvSpPr>
-          <p:cNvPr id="12" name="">
-            <a:extLst xmlns:a="http://schemas.openxmlformats.org/drawingml/2006/main">
-              <a:ext uri="{FF2B5EF4-FFF2-40B4-BE49-F238E27FC236}">
-                <a16:creationId xmlns:a16="http://schemas.microsoft.com/office/drawing/2014/main" id="{AFFBADE0-CA3C-4764-A583-8701E7E7D785}"/>
-              </a:ext>
-            </a:extLst>
-          </p:cNvPr>
-          <p:cNvSpPr>
-            <a:spLocks xmlns:a="http://schemas.openxmlformats.org/drawingml/2006/main" noGrp="1"/>
-          </p:cNvSpPr>
-          <p:nvPr/>
-        </p:nvSpPr>
-        <p:spPr>
-          <a:xfrm xmlns:a="http://schemas.openxmlformats.org/drawingml/2006/main">
-            <a:off x="1085850" y="4419600"/>
-            <a:ext cx="4095750" cy="495300"/>
-          </a:xfrm>
-          <a:prstGeom xmlns:a="http://schemas.openxmlformats.org/drawingml/2006/main" prst="rect">
-            <a:avLst/>
-          </a:prstGeom>
-          <a:noFill xmlns:a="http://schemas.openxmlformats.org/drawingml/2006/main"/>
-          <a:ln xmlns:a="http://schemas.openxmlformats.org/drawingml/2006/main" w="0">
-            <a:noFill/>
-            <a:prstDash val="solid"/>
-          </a:ln>
-        </p:spPr>
-        <p:txBody>
-          <a:bodyPr xmlns:a="http://schemas.openxmlformats.org/drawingml/2006/main"/>
-          <a:lstStyle xmlns:a="http://schemas.openxmlformats.org/drawingml/2006/main"/>
-          <a:p xmlns:a="http://schemas.openxmlformats.org/drawingml/2006/main">
-            <a:pPr algn="l">
-              <a:defRPr sz="1575" b="0">
+          <p:cNvPr id="16" name="">
+            <a:extLst xmlns:a="http://schemas.openxmlformats.org/drawingml/2006/main">
+              <a:ext uri="{FF2B5EF4-FFF2-40B4-BE49-F238E27FC236}">
+                <a16:creationId xmlns:a16="http://schemas.microsoft.com/office/drawing/2014/main" id="{669862E0-C8C2-40FA-9A92-E69188653C0B}"/>
+              </a:ext>
+            </a:extLst>
+          </p:cNvPr>
+          <p:cNvSpPr>
+            <a:spLocks xmlns:a="http://schemas.openxmlformats.org/drawingml/2006/main" noGrp="1"/>
+          </p:cNvSpPr>
+          <p:nvPr/>
+        </p:nvSpPr>
+        <p:spPr>
+          <a:xfrm xmlns:a="http://schemas.openxmlformats.org/drawingml/2006/main">
+            <a:off x="7448550" y="4248150"/>
+            <a:ext cx="3600450" cy="457200"/>
+          </a:xfrm>
+          <a:prstGeom xmlns:a="http://schemas.openxmlformats.org/drawingml/2006/main" prst="rect">
+            <a:avLst/>
+          </a:prstGeom>
+          <a:noFill xmlns:a="http://schemas.openxmlformats.org/drawingml/2006/main"/>
+          <a:ln xmlns:a="http://schemas.openxmlformats.org/drawingml/2006/main" w="0">
+            <a:noFill/>
+            <a:prstDash val="solid"/>
+          </a:ln>
+        </p:spPr>
+        <p:txBody>
+          <a:bodyPr xmlns:a="http://schemas.openxmlformats.org/drawingml/2006/main"/>
+          <a:lstStyle xmlns:a="http://schemas.openxmlformats.org/drawingml/2006/main"/>
+          <a:p xmlns:a="http://schemas.openxmlformats.org/drawingml/2006/main">
+            <a:pPr algn="l">
+              <a:defRPr sz="1350" b="0">
                 <a:solidFill>
                   <a:srgbClr val="182230"/>
                 </a:solidFill>
               </a:defRPr>
             </a:pPr>
             <a:r>
-              <a:rPr sz="1575" b="0">
+              <a:rPr sz="1350" b="0">
                 <a:solidFill>
                   <a:srgbClr val="182230"/>
                 </a:solidFill>
@@ -11720,82 +11861,78 @@
       </p:sp>
       <p:sp>
         <p:nvSpPr>
-          <p:cNvPr id="13" name="">
-            <a:extLst xmlns:a="http://schemas.openxmlformats.org/drawingml/2006/main">
-              <a:ext uri="{FF2B5EF4-FFF2-40B4-BE49-F238E27FC236}">
-                <a16:creationId xmlns:a16="http://schemas.microsoft.com/office/drawing/2014/main" id="{B1991104-46E7-4164-9264-88451F66A6C9}"/>
-              </a:ext>
-            </a:extLst>
-          </p:cNvPr>
-          <p:cNvSpPr>
-            <a:spLocks xmlns:a="http://schemas.openxmlformats.org/drawingml/2006/main" noGrp="1"/>
-          </p:cNvSpPr>
-          <p:nvPr/>
-        </p:nvSpPr>
-        <p:spPr>
-          <a:xfrm xmlns:a="http://schemas.openxmlformats.org/drawingml/2006/main">
-            <a:off x="6343650" y="3771900"/>
-            <a:ext cx="4667250" cy="1409700"/>
-          </a:xfrm>
-          <a:prstGeom xmlns:a="http://schemas.openxmlformats.org/drawingml/2006/main" prst="roundRect">
-            <a:avLst>
-              <a:gd name="adj" fmla="val 5405"/>
-            </a:avLst>
+          <p:cNvPr id="17" name="">
+            <a:extLst xmlns:a="http://schemas.openxmlformats.org/drawingml/2006/main">
+              <a:ext uri="{FF2B5EF4-FFF2-40B4-BE49-F238E27FC236}">
+                <a16:creationId xmlns:a16="http://schemas.microsoft.com/office/drawing/2014/main" id="{6B220450-51F5-4EE0-947C-EE0FAFCD3538}"/>
+              </a:ext>
+            </a:extLst>
+          </p:cNvPr>
+          <p:cNvSpPr>
+            <a:spLocks xmlns:a="http://schemas.openxmlformats.org/drawingml/2006/main" noGrp="1"/>
+          </p:cNvSpPr>
+          <p:nvPr/>
+        </p:nvSpPr>
+        <p:spPr>
+          <a:xfrm xmlns:a="http://schemas.openxmlformats.org/drawingml/2006/main">
+            <a:off x="7181850" y="4819650"/>
+            <a:ext cx="76200" cy="552450"/>
+          </a:xfrm>
+          <a:prstGeom xmlns:a="http://schemas.openxmlformats.org/drawingml/2006/main" prst="rect">
+            <a:avLst/>
           </a:prstGeom>
           <a:solidFill xmlns:a="http://schemas.openxmlformats.org/drawingml/2006/main">
-            <a:srgbClr val="FFFFFF"/>
+            <a:srgbClr val="C77D0E"/>
           </a:solidFill>
-          <a:ln xmlns:a="http://schemas.openxmlformats.org/drawingml/2006/main" w="9525">
-            <a:solidFill>
-              <a:srgbClr val="CDD8E5"/>
-            </a:solidFill>
-            <a:prstDash val="solid"/>
-          </a:ln>
-        </p:spPr>
-      </p:sp>
-      <p:sp>
-        <p:nvSpPr>
-          <p:cNvPr id="14" name="">
-            <a:extLst xmlns:a="http://schemas.openxmlformats.org/drawingml/2006/main">
-              <a:ext uri="{FF2B5EF4-FFF2-40B4-BE49-F238E27FC236}">
-                <a16:creationId xmlns:a16="http://schemas.microsoft.com/office/drawing/2014/main" id="{9A99F5AC-7AAF-42EE-AE09-E0A6406D923E}"/>
-              </a:ext>
-            </a:extLst>
-          </p:cNvPr>
-          <p:cNvSpPr>
-            <a:spLocks xmlns:a="http://schemas.openxmlformats.org/drawingml/2006/main" noGrp="1"/>
-          </p:cNvSpPr>
-          <p:nvPr/>
-        </p:nvSpPr>
-        <p:spPr>
-          <a:xfrm xmlns:a="http://schemas.openxmlformats.org/drawingml/2006/main">
-            <a:off x="6591300" y="3981450"/>
-            <a:ext cx="4095750" cy="304800"/>
-          </a:xfrm>
-          <a:prstGeom xmlns:a="http://schemas.openxmlformats.org/drawingml/2006/main" prst="rect">
-            <a:avLst/>
-          </a:prstGeom>
-          <a:noFill xmlns:a="http://schemas.openxmlformats.org/drawingml/2006/main"/>
-          <a:ln xmlns:a="http://schemas.openxmlformats.org/drawingml/2006/main" w="0">
-            <a:noFill/>
-            <a:prstDash val="solid"/>
-          </a:ln>
-        </p:spPr>
-        <p:txBody>
-          <a:bodyPr xmlns:a="http://schemas.openxmlformats.org/drawingml/2006/main"/>
-          <a:lstStyle xmlns:a="http://schemas.openxmlformats.org/drawingml/2006/main"/>
-          <a:p xmlns:a="http://schemas.openxmlformats.org/drawingml/2006/main">
-            <a:pPr algn="l">
-              <a:defRPr sz="1875" b="1">
-                <a:solidFill>
-                  <a:srgbClr val="C77D0E"/>
-                </a:solidFill>
-              </a:defRPr>
-            </a:pPr>
-            <a:r>
-              <a:rPr sz="1875" b="1">
-                <a:solidFill>
-                  <a:srgbClr val="C77D0E"/>
+          <a:ln xmlns:a="http://schemas.openxmlformats.org/drawingml/2006/main" w="0">
+            <a:noFill/>
+            <a:prstDash val="solid"/>
+          </a:ln>
+        </p:spPr>
+      </p:sp>
+      <p:sp>
+        <p:nvSpPr>
+          <p:cNvPr id="18" name="">
+            <a:extLst xmlns:a="http://schemas.openxmlformats.org/drawingml/2006/main">
+              <a:ext uri="{FF2B5EF4-FFF2-40B4-BE49-F238E27FC236}">
+                <a16:creationId xmlns:a16="http://schemas.microsoft.com/office/drawing/2014/main" id="{ADE8DE43-D546-4FA9-A833-0259F8AFEFAA}"/>
+              </a:ext>
+            </a:extLst>
+          </p:cNvPr>
+          <p:cNvSpPr>
+            <a:spLocks xmlns:a="http://schemas.openxmlformats.org/drawingml/2006/main" noGrp="1"/>
+          </p:cNvSpPr>
+          <p:nvPr/>
+        </p:nvSpPr>
+        <p:spPr>
+          <a:xfrm xmlns:a="http://schemas.openxmlformats.org/drawingml/2006/main">
+            <a:off x="7448550" y="4819650"/>
+            <a:ext cx="3333750" cy="266700"/>
+          </a:xfrm>
+          <a:prstGeom xmlns:a="http://schemas.openxmlformats.org/drawingml/2006/main" prst="rect">
+            <a:avLst/>
+          </a:prstGeom>
+          <a:noFill xmlns:a="http://schemas.openxmlformats.org/drawingml/2006/main"/>
+          <a:ln xmlns:a="http://schemas.openxmlformats.org/drawingml/2006/main" w="0">
+            <a:noFill/>
+            <a:prstDash val="solid"/>
+          </a:ln>
+        </p:spPr>
+        <p:txBody>
+          <a:bodyPr xmlns:a="http://schemas.openxmlformats.org/drawingml/2006/main"/>
+          <a:lstStyle xmlns:a="http://schemas.openxmlformats.org/drawingml/2006/main"/>
+          <a:p xmlns:a="http://schemas.openxmlformats.org/drawingml/2006/main">
+            <a:pPr algn="l">
+              <a:defRPr sz="1725" b="1">
+                <a:solidFill>
+                  <a:srgbClr val="0B2F59"/>
+                </a:solidFill>
+              </a:defRPr>
+            </a:pPr>
+            <a:r>
+              <a:rPr sz="1725" b="1">
+                <a:solidFill>
+                  <a:srgbClr val="0B2F59"/>
                 </a:solidFill>
               </a:rPr>
               <a:t>Social</a:t>
@@ -11805,45 +11942,45 @@
       </p:sp>
       <p:sp>
         <p:nvSpPr>
-          <p:cNvPr id="15" name="">
-            <a:extLst xmlns:a="http://schemas.openxmlformats.org/drawingml/2006/main">
-              <a:ext uri="{FF2B5EF4-FFF2-40B4-BE49-F238E27FC236}">
-                <a16:creationId xmlns:a16="http://schemas.microsoft.com/office/drawing/2014/main" id="{9B6EBB38-0248-4761-85E4-3254BEAF2FF9}"/>
-              </a:ext>
-            </a:extLst>
-          </p:cNvPr>
-          <p:cNvSpPr>
-            <a:spLocks xmlns:a="http://schemas.openxmlformats.org/drawingml/2006/main" noGrp="1"/>
-          </p:cNvSpPr>
-          <p:nvPr/>
-        </p:nvSpPr>
-        <p:spPr>
-          <a:xfrm xmlns:a="http://schemas.openxmlformats.org/drawingml/2006/main">
-            <a:off x="6591300" y="4419600"/>
-            <a:ext cx="4095750" cy="495300"/>
-          </a:xfrm>
-          <a:prstGeom xmlns:a="http://schemas.openxmlformats.org/drawingml/2006/main" prst="rect">
-            <a:avLst/>
-          </a:prstGeom>
-          <a:noFill xmlns:a="http://schemas.openxmlformats.org/drawingml/2006/main"/>
-          <a:ln xmlns:a="http://schemas.openxmlformats.org/drawingml/2006/main" w="0">
-            <a:noFill/>
-            <a:prstDash val="solid"/>
-          </a:ln>
-        </p:spPr>
-        <p:txBody>
-          <a:bodyPr xmlns:a="http://schemas.openxmlformats.org/drawingml/2006/main"/>
-          <a:lstStyle xmlns:a="http://schemas.openxmlformats.org/drawingml/2006/main"/>
-          <a:p xmlns:a="http://schemas.openxmlformats.org/drawingml/2006/main">
-            <a:pPr algn="l">
-              <a:defRPr sz="1575" b="0">
+          <p:cNvPr id="19" name="">
+            <a:extLst xmlns:a="http://schemas.openxmlformats.org/drawingml/2006/main">
+              <a:ext uri="{FF2B5EF4-FFF2-40B4-BE49-F238E27FC236}">
+                <a16:creationId xmlns:a16="http://schemas.microsoft.com/office/drawing/2014/main" id="{3960AB90-0C33-4A83-B23F-CDA7F8A088C6}"/>
+              </a:ext>
+            </a:extLst>
+          </p:cNvPr>
+          <p:cNvSpPr>
+            <a:spLocks xmlns:a="http://schemas.openxmlformats.org/drawingml/2006/main" noGrp="1"/>
+          </p:cNvSpPr>
+          <p:nvPr/>
+        </p:nvSpPr>
+        <p:spPr>
+          <a:xfrm xmlns:a="http://schemas.openxmlformats.org/drawingml/2006/main">
+            <a:off x="7448550" y="5143500"/>
+            <a:ext cx="3600450" cy="457200"/>
+          </a:xfrm>
+          <a:prstGeom xmlns:a="http://schemas.openxmlformats.org/drawingml/2006/main" prst="rect">
+            <a:avLst/>
+          </a:prstGeom>
+          <a:noFill xmlns:a="http://schemas.openxmlformats.org/drawingml/2006/main"/>
+          <a:ln xmlns:a="http://schemas.openxmlformats.org/drawingml/2006/main" w="0">
+            <a:noFill/>
+            <a:prstDash val="solid"/>
+          </a:ln>
+        </p:spPr>
+        <p:txBody>
+          <a:bodyPr xmlns:a="http://schemas.openxmlformats.org/drawingml/2006/main"/>
+          <a:lstStyle xmlns:a="http://schemas.openxmlformats.org/drawingml/2006/main"/>
+          <a:p xmlns:a="http://schemas.openxmlformats.org/drawingml/2006/main">
+            <a:pPr algn="l">
+              <a:defRPr sz="1350" b="0">
                 <a:solidFill>
                   <a:srgbClr val="182230"/>
                 </a:solidFill>
               </a:defRPr>
             </a:pPr>
             <a:r>
-              <a:rPr sz="1575" b="0">
+              <a:rPr sz="1350" b="0">
                 <a:solidFill>
                   <a:srgbClr val="182230"/>
                 </a:solidFill>
@@ -11855,10 +11992,60 @@
       </p:sp>
       <p:sp>
         <p:nvSpPr>
-          <p:cNvPr id="16" name="">
-            <a:extLst xmlns:a="http://schemas.openxmlformats.org/drawingml/2006/main">
-              <a:ext uri="{FF2B5EF4-FFF2-40B4-BE49-F238E27FC236}">
-                <a16:creationId xmlns:a16="http://schemas.microsoft.com/office/drawing/2014/main" id="{E6321B0D-C66D-42F7-A2AA-26F0DD2B0A19}"/>
+          <p:cNvPr id="20" name="">
+            <a:extLst xmlns:a="http://schemas.openxmlformats.org/drawingml/2006/main">
+              <a:ext uri="{FF2B5EF4-FFF2-40B4-BE49-F238E27FC236}">
+                <a16:creationId xmlns:a16="http://schemas.microsoft.com/office/drawing/2014/main" id="{5959921C-AF50-4C91-B2C5-BAF8F5026C5E}"/>
+              </a:ext>
+            </a:extLst>
+          </p:cNvPr>
+          <p:cNvSpPr>
+            <a:spLocks xmlns:a="http://schemas.openxmlformats.org/drawingml/2006/main" noGrp="1"/>
+          </p:cNvSpPr>
+          <p:nvPr/>
+        </p:nvSpPr>
+        <p:spPr>
+          <a:xfrm xmlns:a="http://schemas.openxmlformats.org/drawingml/2006/main">
+            <a:off x="800100" y="6019800"/>
+            <a:ext cx="9239250" cy="171450"/>
+          </a:xfrm>
+          <a:prstGeom xmlns:a="http://schemas.openxmlformats.org/drawingml/2006/main" prst="rect">
+            <a:avLst/>
+          </a:prstGeom>
+          <a:noFill xmlns:a="http://schemas.openxmlformats.org/drawingml/2006/main"/>
+          <a:ln xmlns:a="http://schemas.openxmlformats.org/drawingml/2006/main" w="0">
+            <a:noFill/>
+            <a:prstDash val="solid"/>
+          </a:ln>
+        </p:spPr>
+        <p:txBody>
+          <a:bodyPr xmlns:a="http://schemas.openxmlformats.org/drawingml/2006/main"/>
+          <a:lstStyle xmlns:a="http://schemas.openxmlformats.org/drawingml/2006/main"/>
+          <a:p xmlns:a="http://schemas.openxmlformats.org/drawingml/2006/main">
+            <a:pPr algn="l">
+              <a:defRPr sz="825" b="0">
+                <a:solidFill>
+                  <a:srgbClr val="667085"/>
+                </a:solidFill>
+              </a:defRPr>
+            </a:pPr>
+            <a:r>
+              <a:rPr sz="825" b="0">
+                <a:solidFill>
+                  <a:srgbClr val="667085"/>
+                </a:solidFill>
+              </a:rPr>
+              <a:t>Figure 1. Lewsey et al., Circulation 2026. 原圖保留英文標示以維持原始內容。</a:t>
+            </a:r>
+          </a:p>
+        </p:txBody>
+      </p:sp>
+      <p:sp>
+        <p:nvSpPr>
+          <p:cNvPr id="21" name="">
+            <a:extLst xmlns:a="http://schemas.openxmlformats.org/drawingml/2006/main">
+              <a:ext uri="{FF2B5EF4-FFF2-40B4-BE49-F238E27FC236}">
+                <a16:creationId xmlns:a16="http://schemas.microsoft.com/office/drawing/2014/main" id="{3739B1E6-7081-40A3-AA41-CC2E003F6A3B}"/>
               </a:ext>
             </a:extLst>
           </p:cNvPr>
@@ -11905,10 +12092,10 @@
       </p:sp>
       <p:sp>
         <p:nvSpPr>
-          <p:cNvPr id="17" name="">
-            <a:extLst xmlns:a="http://schemas.openxmlformats.org/drawingml/2006/main">
-              <a:ext uri="{FF2B5EF4-FFF2-40B4-BE49-F238E27FC236}">
-                <a16:creationId xmlns:a16="http://schemas.microsoft.com/office/drawing/2014/main" id="{2D34001E-085E-48C1-92AD-426E5DD529ED}"/>
+          <p:cNvPr id="22" name="">
+            <a:extLst xmlns:a="http://schemas.openxmlformats.org/drawingml/2006/main">
+              <a:ext uri="{FF2B5EF4-FFF2-40B4-BE49-F238E27FC236}">
+                <a16:creationId xmlns:a16="http://schemas.microsoft.com/office/drawing/2014/main" id="{B0256903-8E8C-476B-A37A-2613CF6EFBB9}"/>
               </a:ext>
             </a:extLst>
           </p:cNvPr>
@@ -11955,10 +12142,10 @@
       </p:sp>
       <p:sp>
         <p:nvSpPr>
-          <p:cNvPr id="18" name="">
-            <a:extLst xmlns:a="http://schemas.openxmlformats.org/drawingml/2006/main">
-              <a:ext uri="{FF2B5EF4-FFF2-40B4-BE49-F238E27FC236}">
-                <a16:creationId xmlns:a16="http://schemas.microsoft.com/office/drawing/2014/main" id="{D5342B7A-FC4D-485B-975E-01056EE51E80}"/>
+          <p:cNvPr id="23" name="">
+            <a:extLst xmlns:a="http://schemas.openxmlformats.org/drawingml/2006/main">
+              <a:ext uri="{FF2B5EF4-FFF2-40B4-BE49-F238E27FC236}">
+                <a16:creationId xmlns:a16="http://schemas.microsoft.com/office/drawing/2014/main" id="{4A32D39E-7A99-4262-A9FA-2F891A7732E1}"/>
               </a:ext>
             </a:extLst>
           </p:cNvPr>
@@ -11992,10 +12179,10 @@
       </p:sp>
       <p:sp>
         <p:nvSpPr>
-          <p:cNvPr id="19" name="">
-            <a:extLst xmlns:a="http://schemas.openxmlformats.org/drawingml/2006/main">
-              <a:ext uri="{FF2B5EF4-FFF2-40B4-BE49-F238E27FC236}">
-                <a16:creationId xmlns:a16="http://schemas.microsoft.com/office/drawing/2014/main" id="{2B512CE6-C119-489B-9D3F-E0965B6AE830}"/>
+          <p:cNvPr id="24" name="">
+            <a:extLst xmlns:a="http://schemas.openxmlformats.org/drawingml/2006/main">
+              <a:ext uri="{FF2B5EF4-FFF2-40B4-BE49-F238E27FC236}">
+                <a16:creationId xmlns:a16="http://schemas.microsoft.com/office/drawing/2014/main" id="{ECFF19EE-E9D1-4986-A616-C06D89610906}"/>
               </a:ext>
             </a:extLst>
           </p:cNvPr>
@@ -12043,7 +12230,7 @@
     </p:spTree>
     <p:extLst>
       <p:ext uri="{BB962C8B-B14F-4D97-AF65-F5344CB8AC3E}">
-        <p14:creationId xmlns:p14="http://schemas.microsoft.com/office/powerpoint/2010/main" val="1624276274"/>
+        <p14:creationId xmlns:p14="http://schemas.microsoft.com/office/powerpoint/2010/main" val="797121008"/>
       </p:ext>
     </p:extLst>
   </p:cSld>
@@ -12074,7 +12261,7 @@
           <p:cNvPr id="1" name="">
             <a:extLst xmlns:a="http://schemas.openxmlformats.org/drawingml/2006/main">
               <a:ext uri="{FF2B5EF4-FFF2-40B4-BE49-F238E27FC236}">
-                <a16:creationId xmlns:a16="http://schemas.microsoft.com/office/drawing/2014/main" id="{A62E027C-D033-4D9A-9071-389F9D632B6E}"/>
+                <a16:creationId xmlns:a16="http://schemas.microsoft.com/office/drawing/2014/main" id="{3D19B7B9-A805-43D5-9280-D8CFDE94933C}"/>
               </a:ext>
             </a:extLst>
           </p:cNvPr>
@@ -12124,7 +12311,7 @@
           <p:cNvPr id="2" name="">
             <a:extLst xmlns:a="http://schemas.openxmlformats.org/drawingml/2006/main">
               <a:ext uri="{FF2B5EF4-FFF2-40B4-BE49-F238E27FC236}">
-                <a16:creationId xmlns:a16="http://schemas.microsoft.com/office/drawing/2014/main" id="{87FD2D76-F4AA-4694-8246-DC1F7CB41C3A}"/>
+                <a16:creationId xmlns:a16="http://schemas.microsoft.com/office/drawing/2014/main" id="{B59C1805-4BBE-4726-8EAD-AB074B56D7A0}"/>
               </a:ext>
             </a:extLst>
           </p:cNvPr>
@@ -12174,7 +12361,7 @@
           <p:cNvPr id="3" name="">
             <a:extLst xmlns:a="http://schemas.openxmlformats.org/drawingml/2006/main">
               <a:ext uri="{FF2B5EF4-FFF2-40B4-BE49-F238E27FC236}">
-                <a16:creationId xmlns:a16="http://schemas.microsoft.com/office/drawing/2014/main" id="{EDCF896E-0482-4CBC-B8AB-E0305FF5A92A}"/>
+                <a16:creationId xmlns:a16="http://schemas.microsoft.com/office/drawing/2014/main" id="{F3512340-6A41-4567-BCE5-088786F806E3}"/>
               </a:ext>
             </a:extLst>
           </p:cNvPr>
@@ -12205,7 +12392,7 @@
           <p:cNvPr id="4" name="">
             <a:extLst xmlns:a="http://schemas.openxmlformats.org/drawingml/2006/main">
               <a:ext uri="{FF2B5EF4-FFF2-40B4-BE49-F238E27FC236}">
-                <a16:creationId xmlns:a16="http://schemas.microsoft.com/office/drawing/2014/main" id="{32624675-2E8D-40E6-80DA-CE891F22274B}"/>
+                <a16:creationId xmlns:a16="http://schemas.microsoft.com/office/drawing/2014/main" id="{BE8C3A1E-7A7E-432D-904A-7E512D1602F3}"/>
               </a:ext>
             </a:extLst>
           </p:cNvPr>
@@ -12255,7 +12442,7 @@
           <p:cNvPr id="5" name="">
             <a:extLst xmlns:a="http://schemas.openxmlformats.org/drawingml/2006/main">
               <a:ext uri="{FF2B5EF4-FFF2-40B4-BE49-F238E27FC236}">
-                <a16:creationId xmlns:a16="http://schemas.microsoft.com/office/drawing/2014/main" id="{0B0095A8-430C-44A9-AC9B-4580F98E81E6}"/>
+                <a16:creationId xmlns:a16="http://schemas.microsoft.com/office/drawing/2014/main" id="{8839D2AD-C104-4FEE-B6B9-CD9F498BB5B5}"/>
               </a:ext>
             </a:extLst>
           </p:cNvPr>
@@ -12305,7 +12492,7 @@
           <p:cNvPr id="6" name="">
             <a:extLst xmlns:a="http://schemas.openxmlformats.org/drawingml/2006/main">
               <a:ext uri="{FF2B5EF4-FFF2-40B4-BE49-F238E27FC236}">
-                <a16:creationId xmlns:a16="http://schemas.microsoft.com/office/drawing/2014/main" id="{D5D6DFD5-1532-4AA3-9ED1-FAFB84C9C7A6}"/>
+                <a16:creationId xmlns:a16="http://schemas.microsoft.com/office/drawing/2014/main" id="{A7F78F4F-B9FA-4BBB-8CCA-DEEF397E1F00}"/>
               </a:ext>
             </a:extLst>
           </p:cNvPr>
@@ -12355,7 +12542,7 @@
           <p:cNvPr id="7" name="">
             <a:extLst xmlns:a="http://schemas.openxmlformats.org/drawingml/2006/main">
               <a:ext uri="{FF2B5EF4-FFF2-40B4-BE49-F238E27FC236}">
-                <a16:creationId xmlns:a16="http://schemas.microsoft.com/office/drawing/2014/main" id="{2DB3C12F-A5FC-491E-AF51-C05626230B9A}"/>
+                <a16:creationId xmlns:a16="http://schemas.microsoft.com/office/drawing/2014/main" id="{14724003-B654-4B8C-92E7-866ECF8400CB}"/>
               </a:ext>
             </a:extLst>
           </p:cNvPr>
@@ -12405,7 +12592,7 @@
           <p:cNvPr id="8" name="">
             <a:extLst xmlns:a="http://schemas.openxmlformats.org/drawingml/2006/main">
               <a:ext uri="{FF2B5EF4-FFF2-40B4-BE49-F238E27FC236}">
-                <a16:creationId xmlns:a16="http://schemas.microsoft.com/office/drawing/2014/main" id="{761DF998-0A1C-4659-88DB-7815ADCF96AD}"/>
+                <a16:creationId xmlns:a16="http://schemas.microsoft.com/office/drawing/2014/main" id="{B02E6986-A9F6-4FD6-85B8-562EC34CFEED}"/>
               </a:ext>
             </a:extLst>
           </p:cNvPr>
@@ -12455,7 +12642,7 @@
           <p:cNvPr id="9" name="">
             <a:extLst xmlns:a="http://schemas.openxmlformats.org/drawingml/2006/main">
               <a:ext uri="{FF2B5EF4-FFF2-40B4-BE49-F238E27FC236}">
-                <a16:creationId xmlns:a16="http://schemas.microsoft.com/office/drawing/2014/main" id="{0EB8A8A1-C920-4E94-A232-A3029DE69261}"/>
+                <a16:creationId xmlns:a16="http://schemas.microsoft.com/office/drawing/2014/main" id="{2CB27C78-D5A6-4E43-B697-02C9460F8B3B}"/>
               </a:ext>
             </a:extLst>
           </p:cNvPr>
@@ -12505,7 +12692,7 @@
           <p:cNvPr id="10" name="">
             <a:extLst xmlns:a="http://schemas.openxmlformats.org/drawingml/2006/main">
               <a:ext uri="{FF2B5EF4-FFF2-40B4-BE49-F238E27FC236}">
-                <a16:creationId xmlns:a16="http://schemas.microsoft.com/office/drawing/2014/main" id="{02DCC4B0-D143-4547-AEC9-36DC1560B203}"/>
+                <a16:creationId xmlns:a16="http://schemas.microsoft.com/office/drawing/2014/main" id="{5AD220E1-B713-4C68-8C02-C5EE52E69A1B}"/>
               </a:ext>
             </a:extLst>
           </p:cNvPr>
@@ -12540,7 +12727,7 @@
           <p:cNvPr id="11" name="">
             <a:extLst xmlns:a="http://schemas.openxmlformats.org/drawingml/2006/main">
               <a:ext uri="{FF2B5EF4-FFF2-40B4-BE49-F238E27FC236}">
-                <a16:creationId xmlns:a16="http://schemas.microsoft.com/office/drawing/2014/main" id="{2606F8C9-36E4-4611-9904-E8F8B39E2EF0}"/>
+                <a16:creationId xmlns:a16="http://schemas.microsoft.com/office/drawing/2014/main" id="{297CBF32-1A59-44FC-92C8-53EDF59A8B8F}"/>
               </a:ext>
             </a:extLst>
           </p:cNvPr>
@@ -12590,7 +12777,7 @@
           <p:cNvPr id="12" name="">
             <a:extLst xmlns:a="http://schemas.openxmlformats.org/drawingml/2006/main">
               <a:ext uri="{FF2B5EF4-FFF2-40B4-BE49-F238E27FC236}">
-                <a16:creationId xmlns:a16="http://schemas.microsoft.com/office/drawing/2014/main" id="{8C3A287A-39D4-4C0C-B3B3-2CBACEBB174F}"/>
+                <a16:creationId xmlns:a16="http://schemas.microsoft.com/office/drawing/2014/main" id="{963232D6-A033-43EC-97AC-50951BBD1D4E}"/>
               </a:ext>
             </a:extLst>
           </p:cNvPr>
@@ -12640,7 +12827,7 @@
           <p:cNvPr id="13" name="">
             <a:extLst xmlns:a="http://schemas.openxmlformats.org/drawingml/2006/main">
               <a:ext uri="{FF2B5EF4-FFF2-40B4-BE49-F238E27FC236}">
-                <a16:creationId xmlns:a16="http://schemas.microsoft.com/office/drawing/2014/main" id="{535CA731-0978-481D-8A38-610303C26752}"/>
+                <a16:creationId xmlns:a16="http://schemas.microsoft.com/office/drawing/2014/main" id="{EB573A40-0D70-4E5E-A2E0-DC222BF9F5D8}"/>
               </a:ext>
             </a:extLst>
           </p:cNvPr>
@@ -12690,7 +12877,7 @@
           <p:cNvPr id="14" name="">
             <a:extLst xmlns:a="http://schemas.openxmlformats.org/drawingml/2006/main">
               <a:ext uri="{FF2B5EF4-FFF2-40B4-BE49-F238E27FC236}">
-                <a16:creationId xmlns:a16="http://schemas.microsoft.com/office/drawing/2014/main" id="{D273F00D-5766-45F3-90D1-40A0F57C321B}"/>
+                <a16:creationId xmlns:a16="http://schemas.microsoft.com/office/drawing/2014/main" id="{F29DF86C-3407-47EA-994A-1AACAADE5960}"/>
               </a:ext>
             </a:extLst>
           </p:cNvPr>
@@ -12727,7 +12914,7 @@
           <p:cNvPr id="15" name="">
             <a:extLst xmlns:a="http://schemas.openxmlformats.org/drawingml/2006/main">
               <a:ext uri="{FF2B5EF4-FFF2-40B4-BE49-F238E27FC236}">
-                <a16:creationId xmlns:a16="http://schemas.microsoft.com/office/drawing/2014/main" id="{10E9CBE1-A654-4FC9-8494-D238456E085A}"/>
+                <a16:creationId xmlns:a16="http://schemas.microsoft.com/office/drawing/2014/main" id="{3FDD8AB1-5F42-4960-B72D-0ACE6763786B}"/>
               </a:ext>
             </a:extLst>
           </p:cNvPr>
@@ -12775,7 +12962,7 @@
     </p:spTree>
     <p:extLst>
       <p:ext uri="{BB962C8B-B14F-4D97-AF65-F5344CB8AC3E}">
-        <p14:creationId xmlns:p14="http://schemas.microsoft.com/office/powerpoint/2010/main" val="1925813270"/>
+        <p14:creationId xmlns:p14="http://schemas.microsoft.com/office/powerpoint/2010/main" val="522091943"/>
       </p:ext>
     </p:extLst>
   </p:cSld>
@@ -12806,7 +12993,7 @@
           <p:cNvPr id="1" name="">
             <a:extLst xmlns:a="http://schemas.openxmlformats.org/drawingml/2006/main">
               <a:ext uri="{FF2B5EF4-FFF2-40B4-BE49-F238E27FC236}">
-                <a16:creationId xmlns:a16="http://schemas.microsoft.com/office/drawing/2014/main" id="{598FB27F-1A59-41E4-A107-45C9936CA027}"/>
+                <a16:creationId xmlns:a16="http://schemas.microsoft.com/office/drawing/2014/main" id="{C9725389-848F-47B1-B26F-D1640AB6A168}"/>
               </a:ext>
             </a:extLst>
           </p:cNvPr>
@@ -12856,7 +13043,7 @@
           <p:cNvPr id="2" name="">
             <a:extLst xmlns:a="http://schemas.openxmlformats.org/drawingml/2006/main">
               <a:ext uri="{FF2B5EF4-FFF2-40B4-BE49-F238E27FC236}">
-                <a16:creationId xmlns:a16="http://schemas.microsoft.com/office/drawing/2014/main" id="{D990E0B1-5891-48AB-9468-844863496233}"/>
+                <a16:creationId xmlns:a16="http://schemas.microsoft.com/office/drawing/2014/main" id="{FE7213E2-E243-4EC5-8C8D-39B1EA48EB69}"/>
               </a:ext>
             </a:extLst>
           </p:cNvPr>
@@ -12906,7 +13093,7 @@
           <p:cNvPr id="3" name="">
             <a:extLst xmlns:a="http://schemas.openxmlformats.org/drawingml/2006/main">
               <a:ext uri="{FF2B5EF4-FFF2-40B4-BE49-F238E27FC236}">
-                <a16:creationId xmlns:a16="http://schemas.microsoft.com/office/drawing/2014/main" id="{2A9E2D72-9B58-4D37-94CC-5085A632F3B9}"/>
+                <a16:creationId xmlns:a16="http://schemas.microsoft.com/office/drawing/2014/main" id="{411B84E3-608B-475C-A0BA-DAC637E5B875}"/>
               </a:ext>
             </a:extLst>
           </p:cNvPr>
@@ -12932,84 +13119,152 @@
           </a:ln>
         </p:spPr>
       </p:sp>
-      <p:sp>
-        <p:nvSpPr>
-          <p:cNvPr id="4" name="">
-            <a:extLst xmlns:a="http://schemas.openxmlformats.org/drawingml/2006/main">
-              <a:ext uri="{FF2B5EF4-FFF2-40B4-BE49-F238E27FC236}">
-                <a16:creationId xmlns:a16="http://schemas.microsoft.com/office/drawing/2014/main" id="{429CCA61-EA84-4A5B-A405-04BE2489482A}"/>
-              </a:ext>
-            </a:extLst>
-          </p:cNvPr>
-          <p:cNvSpPr>
-            <a:spLocks xmlns:a="http://schemas.openxmlformats.org/drawingml/2006/main" noGrp="1"/>
-          </p:cNvSpPr>
-          <p:nvPr/>
-        </p:nvSpPr>
-        <p:spPr>
-          <a:xfrm xmlns:a="http://schemas.openxmlformats.org/drawingml/2006/main">
-            <a:off x="742950" y="1809750"/>
-            <a:ext cx="3257550" cy="2686050"/>
-          </a:xfrm>
-          <a:prstGeom xmlns:a="http://schemas.openxmlformats.org/drawingml/2006/main" prst="roundRect">
-            <a:avLst>
-              <a:gd name="adj" fmla="val 2837"/>
-            </a:avLst>
+      <p:pic>
+        <p:nvPicPr>
+          <p:cNvPr id="25" name=""/>
+          <p:cNvPicPr>
+            <a:picLocks xmlns:a="http://schemas.openxmlformats.org/drawingml/2006/main" noChangeAspect="1"/>
+          </p:cNvPicPr>
+          <p:nvPr/>
+        </p:nvPicPr>
+        <p:blipFill>
+          <a:blip xmlns:r="http://schemas.openxmlformats.org/officeDocument/2006/relationships" xmlns:a="http://schemas.openxmlformats.org/drawingml/2006/main" r:embed="R1efb9e0bf0da4ef3"/>
+          <a:stretch xmlns:a="http://schemas.openxmlformats.org/drawingml/2006/main"/>
+        </p:blipFill>
+        <p:spPr>
+          <a:xfrm xmlns:a="http://schemas.openxmlformats.org/drawingml/2006/main">
+            <a:off x="1696403" y="1657350"/>
+            <a:ext cx="3789045" cy="4210050"/>
+          </a:xfrm>
+          <a:prstGeom xmlns:a="http://schemas.openxmlformats.org/drawingml/2006/main" prst="rect">
+            <a:avLst/>
+          </a:prstGeom>
+        </p:spPr>
+      </p:pic>
+      <p:sp>
+        <p:nvSpPr>
+          <p:cNvPr id="5" name="">
+            <a:extLst xmlns:a="http://schemas.openxmlformats.org/drawingml/2006/main">
+              <a:ext uri="{FF2B5EF4-FFF2-40B4-BE49-F238E27FC236}">
+                <a16:creationId xmlns:a16="http://schemas.microsoft.com/office/drawing/2014/main" id="{60CE55EB-76C0-4F2F-9C96-8BF469DDA9B7}"/>
+              </a:ext>
+            </a:extLst>
+          </p:cNvPr>
+          <p:cNvSpPr>
+            <a:spLocks xmlns:a="http://schemas.openxmlformats.org/drawingml/2006/main" noGrp="1"/>
+          </p:cNvSpPr>
+          <p:nvPr/>
+        </p:nvSpPr>
+        <p:spPr>
+          <a:xfrm xmlns:a="http://schemas.openxmlformats.org/drawingml/2006/main">
+            <a:off x="7124700" y="1790700"/>
+            <a:ext cx="3810000" cy="323850"/>
+          </a:xfrm>
+          <a:prstGeom xmlns:a="http://schemas.openxmlformats.org/drawingml/2006/main" prst="rect">
+            <a:avLst/>
+          </a:prstGeom>
+          <a:noFill xmlns:a="http://schemas.openxmlformats.org/drawingml/2006/main"/>
+          <a:ln xmlns:a="http://schemas.openxmlformats.org/drawingml/2006/main" w="0">
+            <a:noFill/>
+            <a:prstDash val="solid"/>
+          </a:ln>
+        </p:spPr>
+        <p:txBody>
+          <a:bodyPr xmlns:a="http://schemas.openxmlformats.org/drawingml/2006/main"/>
+          <a:lstStyle xmlns:a="http://schemas.openxmlformats.org/drawingml/2006/main"/>
+          <a:p xmlns:a="http://schemas.openxmlformats.org/drawingml/2006/main">
+            <a:pPr algn="l">
+              <a:defRPr sz="1800" b="1">
+                <a:solidFill>
+                  <a:srgbClr val="0B2F59"/>
+                </a:solidFill>
+              </a:defRPr>
+            </a:pPr>
+            <a:r>
+              <a:rPr sz="1800" b="1">
+                <a:solidFill>
+                  <a:srgbClr val="0B2F59"/>
+                </a:solidFill>
+              </a:rPr>
+              <a:t>用原圖快速定位問題，再回到可介入層級</a:t>
+            </a:r>
+          </a:p>
+        </p:txBody>
+      </p:sp>
+      <p:sp>
+        <p:nvSpPr>
+          <p:cNvPr id="6" name="">
+            <a:extLst xmlns:a="http://schemas.openxmlformats.org/drawingml/2006/main">
+              <a:ext uri="{FF2B5EF4-FFF2-40B4-BE49-F238E27FC236}">
+                <a16:creationId xmlns:a16="http://schemas.microsoft.com/office/drawing/2014/main" id="{30A595A1-249E-4F64-9EAD-DFB05EB5986F}"/>
+              </a:ext>
+            </a:extLst>
+          </p:cNvPr>
+          <p:cNvSpPr>
+            <a:spLocks xmlns:a="http://schemas.openxmlformats.org/drawingml/2006/main" noGrp="1"/>
+          </p:cNvSpPr>
+          <p:nvPr/>
+        </p:nvSpPr>
+        <p:spPr>
+          <a:xfrm xmlns:a="http://schemas.openxmlformats.org/drawingml/2006/main">
+            <a:off x="7124700" y="2381250"/>
+            <a:ext cx="95250" cy="590550"/>
+          </a:xfrm>
+          <a:prstGeom xmlns:a="http://schemas.openxmlformats.org/drawingml/2006/main" prst="rect">
+            <a:avLst/>
           </a:prstGeom>
           <a:solidFill xmlns:a="http://schemas.openxmlformats.org/drawingml/2006/main">
-            <a:srgbClr val="FFFFFF"/>
+            <a:srgbClr val="B42318"/>
           </a:solidFill>
-          <a:ln xmlns:a="http://schemas.openxmlformats.org/drawingml/2006/main" w="9525">
-            <a:solidFill>
-              <a:srgbClr val="CDD8E5"/>
-            </a:solidFill>
-            <a:prstDash val="solid"/>
-          </a:ln>
-        </p:spPr>
-      </p:sp>
-      <p:sp>
-        <p:nvSpPr>
-          <p:cNvPr id="5" name="">
-            <a:extLst xmlns:a="http://schemas.openxmlformats.org/drawingml/2006/main">
-              <a:ext uri="{FF2B5EF4-FFF2-40B4-BE49-F238E27FC236}">
-                <a16:creationId xmlns:a16="http://schemas.microsoft.com/office/drawing/2014/main" id="{58C2EF1E-6339-4274-9B24-4DFD1ABB58A4}"/>
-              </a:ext>
-            </a:extLst>
-          </p:cNvPr>
-          <p:cNvSpPr>
-            <a:spLocks xmlns:a="http://schemas.openxmlformats.org/drawingml/2006/main" noGrp="1"/>
-          </p:cNvSpPr>
-          <p:nvPr/>
-        </p:nvSpPr>
-        <p:spPr>
-          <a:xfrm xmlns:a="http://schemas.openxmlformats.org/drawingml/2006/main">
-            <a:off x="971550" y="2095500"/>
-            <a:ext cx="2800350" cy="304800"/>
-          </a:xfrm>
-          <a:prstGeom xmlns:a="http://schemas.openxmlformats.org/drawingml/2006/main" prst="rect">
-            <a:avLst/>
-          </a:prstGeom>
-          <a:noFill xmlns:a="http://schemas.openxmlformats.org/drawingml/2006/main"/>
-          <a:ln xmlns:a="http://schemas.openxmlformats.org/drawingml/2006/main" w="0">
-            <a:noFill/>
-            <a:prstDash val="solid"/>
-          </a:ln>
-        </p:spPr>
-        <p:txBody>
-          <a:bodyPr xmlns:a="http://schemas.openxmlformats.org/drawingml/2006/main"/>
-          <a:lstStyle xmlns:a="http://schemas.openxmlformats.org/drawingml/2006/main"/>
-          <a:p xmlns:a="http://schemas.openxmlformats.org/drawingml/2006/main">
-            <a:pPr algn="l">
-              <a:defRPr sz="1875" b="1">
-                <a:solidFill>
-                  <a:srgbClr val="B42318"/>
-                </a:solidFill>
-              </a:defRPr>
-            </a:pPr>
-            <a:r>
-              <a:rPr sz="1875" b="1">
-                <a:solidFill>
-                  <a:srgbClr val="B42318"/>
+          <a:ln xmlns:a="http://schemas.openxmlformats.org/drawingml/2006/main" w="0">
+            <a:noFill/>
+            <a:prstDash val="solid"/>
+          </a:ln>
+        </p:spPr>
+      </p:sp>
+      <p:sp>
+        <p:nvSpPr>
+          <p:cNvPr id="7" name="">
+            <a:extLst xmlns:a="http://schemas.openxmlformats.org/drawingml/2006/main">
+              <a:ext uri="{FF2B5EF4-FFF2-40B4-BE49-F238E27FC236}">
+                <a16:creationId xmlns:a16="http://schemas.microsoft.com/office/drawing/2014/main" id="{CBEB624F-14DF-4AF0-B36A-7A78CA2B3E2D}"/>
+              </a:ext>
+            </a:extLst>
+          </p:cNvPr>
+          <p:cNvSpPr>
+            <a:spLocks xmlns:a="http://schemas.openxmlformats.org/drawingml/2006/main" noGrp="1"/>
+          </p:cNvSpPr>
+          <p:nvPr/>
+        </p:nvSpPr>
+        <p:spPr>
+          <a:xfrm xmlns:a="http://schemas.openxmlformats.org/drawingml/2006/main">
+            <a:off x="7429500" y="2381250"/>
+            <a:ext cx="3238500" cy="257175"/>
+          </a:xfrm>
+          <a:prstGeom xmlns:a="http://schemas.openxmlformats.org/drawingml/2006/main" prst="rect">
+            <a:avLst/>
+          </a:prstGeom>
+          <a:noFill xmlns:a="http://schemas.openxmlformats.org/drawingml/2006/main"/>
+          <a:ln xmlns:a="http://schemas.openxmlformats.org/drawingml/2006/main" w="0">
+            <a:noFill/>
+            <a:prstDash val="solid"/>
+          </a:ln>
+        </p:spPr>
+        <p:txBody>
+          <a:bodyPr xmlns:a="http://schemas.openxmlformats.org/drawingml/2006/main"/>
+          <a:lstStyle xmlns:a="http://schemas.openxmlformats.org/drawingml/2006/main"/>
+          <a:p xmlns:a="http://schemas.openxmlformats.org/drawingml/2006/main">
+            <a:pPr algn="l">
+              <a:defRPr sz="1650" b="1">
+                <a:solidFill>
+                  <a:srgbClr val="0B2F59"/>
+                </a:solidFill>
+              </a:defRPr>
+            </a:pPr>
+            <a:r>
+              <a:rPr sz="1650" b="1">
+                <a:solidFill>
+                  <a:srgbClr val="0B2F59"/>
                 </a:solidFill>
               </a:rPr>
               <a:t>病人層級</a:t>
@@ -13019,45 +13274,45 @@
       </p:sp>
       <p:sp>
         <p:nvSpPr>
-          <p:cNvPr id="6" name="">
-            <a:extLst xmlns:a="http://schemas.openxmlformats.org/drawingml/2006/main">
-              <a:ext uri="{FF2B5EF4-FFF2-40B4-BE49-F238E27FC236}">
-                <a16:creationId xmlns:a16="http://schemas.microsoft.com/office/drawing/2014/main" id="{D30E6288-EE39-41E6-ADB2-8E6B9AAFA837}"/>
-              </a:ext>
-            </a:extLst>
-          </p:cNvPr>
-          <p:cNvSpPr>
-            <a:spLocks xmlns:a="http://schemas.openxmlformats.org/drawingml/2006/main" noGrp="1"/>
-          </p:cNvSpPr>
-          <p:nvPr/>
-        </p:nvSpPr>
-        <p:spPr>
-          <a:xfrm xmlns:a="http://schemas.openxmlformats.org/drawingml/2006/main">
-            <a:off x="971550" y="2628900"/>
-            <a:ext cx="2800350" cy="1257300"/>
-          </a:xfrm>
-          <a:prstGeom xmlns:a="http://schemas.openxmlformats.org/drawingml/2006/main" prst="rect">
-            <a:avLst/>
-          </a:prstGeom>
-          <a:noFill xmlns:a="http://schemas.openxmlformats.org/drawingml/2006/main"/>
-          <a:ln xmlns:a="http://schemas.openxmlformats.org/drawingml/2006/main" w="0">
-            <a:noFill/>
-            <a:prstDash val="solid"/>
-          </a:ln>
-        </p:spPr>
-        <p:txBody>
-          <a:bodyPr xmlns:a="http://schemas.openxmlformats.org/drawingml/2006/main"/>
-          <a:lstStyle xmlns:a="http://schemas.openxmlformats.org/drawingml/2006/main"/>
-          <a:p xmlns:a="http://schemas.openxmlformats.org/drawingml/2006/main">
-            <a:pPr algn="l">
-              <a:defRPr sz="1650" b="0">
+          <p:cNvPr id="8" name="">
+            <a:extLst xmlns:a="http://schemas.openxmlformats.org/drawingml/2006/main">
+              <a:ext uri="{FF2B5EF4-FFF2-40B4-BE49-F238E27FC236}">
+                <a16:creationId xmlns:a16="http://schemas.microsoft.com/office/drawing/2014/main" id="{B5E5D908-9C53-46BD-A141-492A7393C38B}"/>
+              </a:ext>
+            </a:extLst>
+          </p:cNvPr>
+          <p:cNvSpPr>
+            <a:spLocks xmlns:a="http://schemas.openxmlformats.org/drawingml/2006/main" noGrp="1"/>
+          </p:cNvSpPr>
+          <p:nvPr/>
+        </p:nvSpPr>
+        <p:spPr>
+          <a:xfrm xmlns:a="http://schemas.openxmlformats.org/drawingml/2006/main">
+            <a:off x="7429500" y="2686050"/>
+            <a:ext cx="3333750" cy="495300"/>
+          </a:xfrm>
+          <a:prstGeom xmlns:a="http://schemas.openxmlformats.org/drawingml/2006/main" prst="rect">
+            <a:avLst/>
+          </a:prstGeom>
+          <a:noFill xmlns:a="http://schemas.openxmlformats.org/drawingml/2006/main"/>
+          <a:ln xmlns:a="http://schemas.openxmlformats.org/drawingml/2006/main" w="0">
+            <a:noFill/>
+            <a:prstDash val="solid"/>
+          </a:ln>
+        </p:spPr>
+        <p:txBody>
+          <a:bodyPr xmlns:a="http://schemas.openxmlformats.org/drawingml/2006/main"/>
+          <a:lstStyle xmlns:a="http://schemas.openxmlformats.org/drawingml/2006/main"/>
+          <a:p xmlns:a="http://schemas.openxmlformats.org/drawingml/2006/main">
+            <a:pPr algn="l">
+              <a:defRPr sz="1275" b="0">
                 <a:solidFill>
                   <a:srgbClr val="182230"/>
                 </a:solidFill>
               </a:defRPr>
             </a:pPr>
             <a:r>
-              <a:rPr sz="1650" b="0">
+              <a:rPr sz="1275" b="0">
                 <a:solidFill>
                   <a:srgbClr val="182230"/>
                 </a:solidFill>
@@ -13069,82 +13324,78 @@
       </p:sp>
       <p:sp>
         <p:nvSpPr>
-          <p:cNvPr id="7" name="">
-            <a:extLst xmlns:a="http://schemas.openxmlformats.org/drawingml/2006/main">
-              <a:ext uri="{FF2B5EF4-FFF2-40B4-BE49-F238E27FC236}">
-                <a16:creationId xmlns:a16="http://schemas.microsoft.com/office/drawing/2014/main" id="{5DBFCD97-73CA-463A-8228-8A0F800F8F48}"/>
-              </a:ext>
-            </a:extLst>
-          </p:cNvPr>
-          <p:cNvSpPr>
-            <a:spLocks xmlns:a="http://schemas.openxmlformats.org/drawingml/2006/main" noGrp="1"/>
-          </p:cNvSpPr>
-          <p:nvPr/>
-        </p:nvSpPr>
-        <p:spPr>
-          <a:xfrm xmlns:a="http://schemas.openxmlformats.org/drawingml/2006/main">
-            <a:off x="4457700" y="1809750"/>
-            <a:ext cx="3257550" cy="2686050"/>
-          </a:xfrm>
-          <a:prstGeom xmlns:a="http://schemas.openxmlformats.org/drawingml/2006/main" prst="roundRect">
-            <a:avLst>
-              <a:gd name="adj" fmla="val 2837"/>
-            </a:avLst>
+          <p:cNvPr id="9" name="">
+            <a:extLst xmlns:a="http://schemas.openxmlformats.org/drawingml/2006/main">
+              <a:ext uri="{FF2B5EF4-FFF2-40B4-BE49-F238E27FC236}">
+                <a16:creationId xmlns:a16="http://schemas.microsoft.com/office/drawing/2014/main" id="{EA7F2764-3585-4E81-80E3-393EBF939DC3}"/>
+              </a:ext>
+            </a:extLst>
+          </p:cNvPr>
+          <p:cNvSpPr>
+            <a:spLocks xmlns:a="http://schemas.openxmlformats.org/drawingml/2006/main" noGrp="1"/>
+          </p:cNvSpPr>
+          <p:nvPr/>
+        </p:nvSpPr>
+        <p:spPr>
+          <a:xfrm xmlns:a="http://schemas.openxmlformats.org/drawingml/2006/main">
+            <a:off x="7124700" y="3286125"/>
+            <a:ext cx="95250" cy="590550"/>
+          </a:xfrm>
+          <a:prstGeom xmlns:a="http://schemas.openxmlformats.org/drawingml/2006/main" prst="rect">
+            <a:avLst/>
           </a:prstGeom>
           <a:solidFill xmlns:a="http://schemas.openxmlformats.org/drawingml/2006/main">
-            <a:srgbClr val="FFFFFF"/>
+            <a:srgbClr val="1B6CA8"/>
           </a:solidFill>
-          <a:ln xmlns:a="http://schemas.openxmlformats.org/drawingml/2006/main" w="9525">
-            <a:solidFill>
-              <a:srgbClr val="CDD8E5"/>
-            </a:solidFill>
-            <a:prstDash val="solid"/>
-          </a:ln>
-        </p:spPr>
-      </p:sp>
-      <p:sp>
-        <p:nvSpPr>
-          <p:cNvPr id="8" name="">
-            <a:extLst xmlns:a="http://schemas.openxmlformats.org/drawingml/2006/main">
-              <a:ext uri="{FF2B5EF4-FFF2-40B4-BE49-F238E27FC236}">
-                <a16:creationId xmlns:a16="http://schemas.microsoft.com/office/drawing/2014/main" id="{D0053D12-FACA-4B54-9DD4-4E5292F0B073}"/>
-              </a:ext>
-            </a:extLst>
-          </p:cNvPr>
-          <p:cNvSpPr>
-            <a:spLocks xmlns:a="http://schemas.openxmlformats.org/drawingml/2006/main" noGrp="1"/>
-          </p:cNvSpPr>
-          <p:nvPr/>
-        </p:nvSpPr>
-        <p:spPr>
-          <a:xfrm xmlns:a="http://schemas.openxmlformats.org/drawingml/2006/main">
-            <a:off x="4686300" y="2095500"/>
-            <a:ext cx="2800350" cy="304800"/>
-          </a:xfrm>
-          <a:prstGeom xmlns:a="http://schemas.openxmlformats.org/drawingml/2006/main" prst="rect">
-            <a:avLst/>
-          </a:prstGeom>
-          <a:noFill xmlns:a="http://schemas.openxmlformats.org/drawingml/2006/main"/>
-          <a:ln xmlns:a="http://schemas.openxmlformats.org/drawingml/2006/main" w="0">
-            <a:noFill/>
-            <a:prstDash val="solid"/>
-          </a:ln>
-        </p:spPr>
-        <p:txBody>
-          <a:bodyPr xmlns:a="http://schemas.openxmlformats.org/drawingml/2006/main"/>
-          <a:lstStyle xmlns:a="http://schemas.openxmlformats.org/drawingml/2006/main"/>
-          <a:p xmlns:a="http://schemas.openxmlformats.org/drawingml/2006/main">
-            <a:pPr algn="l">
-              <a:defRPr sz="1875" b="1">
-                <a:solidFill>
-                  <a:srgbClr val="1B6CA8"/>
-                </a:solidFill>
-              </a:defRPr>
-            </a:pPr>
-            <a:r>
-              <a:rPr sz="1875" b="1">
-                <a:solidFill>
-                  <a:srgbClr val="1B6CA8"/>
+          <a:ln xmlns:a="http://schemas.openxmlformats.org/drawingml/2006/main" w="0">
+            <a:noFill/>
+            <a:prstDash val="solid"/>
+          </a:ln>
+        </p:spPr>
+      </p:sp>
+      <p:sp>
+        <p:nvSpPr>
+          <p:cNvPr id="10" name="">
+            <a:extLst xmlns:a="http://schemas.openxmlformats.org/drawingml/2006/main">
+              <a:ext uri="{FF2B5EF4-FFF2-40B4-BE49-F238E27FC236}">
+                <a16:creationId xmlns:a16="http://schemas.microsoft.com/office/drawing/2014/main" id="{E6772F18-4C12-4D26-9E6D-07F33AFA75C8}"/>
+              </a:ext>
+            </a:extLst>
+          </p:cNvPr>
+          <p:cNvSpPr>
+            <a:spLocks xmlns:a="http://schemas.openxmlformats.org/drawingml/2006/main" noGrp="1"/>
+          </p:cNvSpPr>
+          <p:nvPr/>
+        </p:nvSpPr>
+        <p:spPr>
+          <a:xfrm xmlns:a="http://schemas.openxmlformats.org/drawingml/2006/main">
+            <a:off x="7429500" y="3286125"/>
+            <a:ext cx="3238500" cy="257175"/>
+          </a:xfrm>
+          <a:prstGeom xmlns:a="http://schemas.openxmlformats.org/drawingml/2006/main" prst="rect">
+            <a:avLst/>
+          </a:prstGeom>
+          <a:noFill xmlns:a="http://schemas.openxmlformats.org/drawingml/2006/main"/>
+          <a:ln xmlns:a="http://schemas.openxmlformats.org/drawingml/2006/main" w="0">
+            <a:noFill/>
+            <a:prstDash val="solid"/>
+          </a:ln>
+        </p:spPr>
+        <p:txBody>
+          <a:bodyPr xmlns:a="http://schemas.openxmlformats.org/drawingml/2006/main"/>
+          <a:lstStyle xmlns:a="http://schemas.openxmlformats.org/drawingml/2006/main"/>
+          <a:p xmlns:a="http://schemas.openxmlformats.org/drawingml/2006/main">
+            <a:pPr algn="l">
+              <a:defRPr sz="1650" b="1">
+                <a:solidFill>
+                  <a:srgbClr val="0B2F59"/>
+                </a:solidFill>
+              </a:defRPr>
+            </a:pPr>
+            <a:r>
+              <a:rPr sz="1650" b="1">
+                <a:solidFill>
+                  <a:srgbClr val="0B2F59"/>
                 </a:solidFill>
               </a:rPr>
               <a:t>醫療團隊層級</a:t>
@@ -13154,45 +13405,45 @@
       </p:sp>
       <p:sp>
         <p:nvSpPr>
-          <p:cNvPr id="9" name="">
-            <a:extLst xmlns:a="http://schemas.openxmlformats.org/drawingml/2006/main">
-              <a:ext uri="{FF2B5EF4-FFF2-40B4-BE49-F238E27FC236}">
-                <a16:creationId xmlns:a16="http://schemas.microsoft.com/office/drawing/2014/main" id="{8F40F051-1A0C-4059-B6C2-A8E4C48798F1}"/>
-              </a:ext>
-            </a:extLst>
-          </p:cNvPr>
-          <p:cNvSpPr>
-            <a:spLocks xmlns:a="http://schemas.openxmlformats.org/drawingml/2006/main" noGrp="1"/>
-          </p:cNvSpPr>
-          <p:nvPr/>
-        </p:nvSpPr>
-        <p:spPr>
-          <a:xfrm xmlns:a="http://schemas.openxmlformats.org/drawingml/2006/main">
-            <a:off x="4686300" y="2628900"/>
-            <a:ext cx="2800350" cy="1257300"/>
-          </a:xfrm>
-          <a:prstGeom xmlns:a="http://schemas.openxmlformats.org/drawingml/2006/main" prst="rect">
-            <a:avLst/>
-          </a:prstGeom>
-          <a:noFill xmlns:a="http://schemas.openxmlformats.org/drawingml/2006/main"/>
-          <a:ln xmlns:a="http://schemas.openxmlformats.org/drawingml/2006/main" w="0">
-            <a:noFill/>
-            <a:prstDash val="solid"/>
-          </a:ln>
-        </p:spPr>
-        <p:txBody>
-          <a:bodyPr xmlns:a="http://schemas.openxmlformats.org/drawingml/2006/main"/>
-          <a:lstStyle xmlns:a="http://schemas.openxmlformats.org/drawingml/2006/main"/>
-          <a:p xmlns:a="http://schemas.openxmlformats.org/drawingml/2006/main">
-            <a:pPr algn="l">
-              <a:defRPr sz="1650" b="0">
+          <p:cNvPr id="11" name="">
+            <a:extLst xmlns:a="http://schemas.openxmlformats.org/drawingml/2006/main">
+              <a:ext uri="{FF2B5EF4-FFF2-40B4-BE49-F238E27FC236}">
+                <a16:creationId xmlns:a16="http://schemas.microsoft.com/office/drawing/2014/main" id="{27870448-EAA8-4567-8278-443D82BDF3CB}"/>
+              </a:ext>
+            </a:extLst>
+          </p:cNvPr>
+          <p:cNvSpPr>
+            <a:spLocks xmlns:a="http://schemas.openxmlformats.org/drawingml/2006/main" noGrp="1"/>
+          </p:cNvSpPr>
+          <p:nvPr/>
+        </p:nvSpPr>
+        <p:spPr>
+          <a:xfrm xmlns:a="http://schemas.openxmlformats.org/drawingml/2006/main">
+            <a:off x="7429500" y="3590925"/>
+            <a:ext cx="3333750" cy="495300"/>
+          </a:xfrm>
+          <a:prstGeom xmlns:a="http://schemas.openxmlformats.org/drawingml/2006/main" prst="rect">
+            <a:avLst/>
+          </a:prstGeom>
+          <a:noFill xmlns:a="http://schemas.openxmlformats.org/drawingml/2006/main"/>
+          <a:ln xmlns:a="http://schemas.openxmlformats.org/drawingml/2006/main" w="0">
+            <a:noFill/>
+            <a:prstDash val="solid"/>
+          </a:ln>
+        </p:spPr>
+        <p:txBody>
+          <a:bodyPr xmlns:a="http://schemas.openxmlformats.org/drawingml/2006/main"/>
+          <a:lstStyle xmlns:a="http://schemas.openxmlformats.org/drawingml/2006/main"/>
+          <a:p xmlns:a="http://schemas.openxmlformats.org/drawingml/2006/main">
+            <a:pPr algn="l">
+              <a:defRPr sz="1275" b="0">
                 <a:solidFill>
                   <a:srgbClr val="182230"/>
                 </a:solidFill>
               </a:defRPr>
             </a:pPr>
             <a:r>
-              <a:rPr sz="1650" b="0">
+              <a:rPr sz="1275" b="0">
                 <a:solidFill>
                   <a:srgbClr val="182230"/>
                 </a:solidFill>
@@ -13204,82 +13455,78 @@
       </p:sp>
       <p:sp>
         <p:nvSpPr>
-          <p:cNvPr id="10" name="">
-            <a:extLst xmlns:a="http://schemas.openxmlformats.org/drawingml/2006/main">
-              <a:ext uri="{FF2B5EF4-FFF2-40B4-BE49-F238E27FC236}">
-                <a16:creationId xmlns:a16="http://schemas.microsoft.com/office/drawing/2014/main" id="{907980B9-CF07-461D-87A9-9A24D1D4DA8C}"/>
-              </a:ext>
-            </a:extLst>
-          </p:cNvPr>
-          <p:cNvSpPr>
-            <a:spLocks xmlns:a="http://schemas.openxmlformats.org/drawingml/2006/main" noGrp="1"/>
-          </p:cNvSpPr>
-          <p:nvPr/>
-        </p:nvSpPr>
-        <p:spPr>
-          <a:xfrm xmlns:a="http://schemas.openxmlformats.org/drawingml/2006/main">
-            <a:off x="8172450" y="1809750"/>
-            <a:ext cx="3257550" cy="2686050"/>
-          </a:xfrm>
-          <a:prstGeom xmlns:a="http://schemas.openxmlformats.org/drawingml/2006/main" prst="roundRect">
-            <a:avLst>
-              <a:gd name="adj" fmla="val 2837"/>
-            </a:avLst>
+          <p:cNvPr id="12" name="">
+            <a:extLst xmlns:a="http://schemas.openxmlformats.org/drawingml/2006/main">
+              <a:ext uri="{FF2B5EF4-FFF2-40B4-BE49-F238E27FC236}">
+                <a16:creationId xmlns:a16="http://schemas.microsoft.com/office/drawing/2014/main" id="{8E4A7753-C019-4FAE-9430-845F6A4C50DE}"/>
+              </a:ext>
+            </a:extLst>
+          </p:cNvPr>
+          <p:cNvSpPr>
+            <a:spLocks xmlns:a="http://schemas.openxmlformats.org/drawingml/2006/main" noGrp="1"/>
+          </p:cNvSpPr>
+          <p:nvPr/>
+        </p:nvSpPr>
+        <p:spPr>
+          <a:xfrm xmlns:a="http://schemas.openxmlformats.org/drawingml/2006/main">
+            <a:off x="7124700" y="4191000"/>
+            <a:ext cx="95250" cy="590550"/>
+          </a:xfrm>
+          <a:prstGeom xmlns:a="http://schemas.openxmlformats.org/drawingml/2006/main" prst="rect">
+            <a:avLst/>
           </a:prstGeom>
           <a:solidFill xmlns:a="http://schemas.openxmlformats.org/drawingml/2006/main">
-            <a:srgbClr val="FFFFFF"/>
+            <a:srgbClr val="1F8A8A"/>
           </a:solidFill>
-          <a:ln xmlns:a="http://schemas.openxmlformats.org/drawingml/2006/main" w="9525">
-            <a:solidFill>
-              <a:srgbClr val="CDD8E5"/>
-            </a:solidFill>
-            <a:prstDash val="solid"/>
-          </a:ln>
-        </p:spPr>
-      </p:sp>
-      <p:sp>
-        <p:nvSpPr>
-          <p:cNvPr id="11" name="">
-            <a:extLst xmlns:a="http://schemas.openxmlformats.org/drawingml/2006/main">
-              <a:ext uri="{FF2B5EF4-FFF2-40B4-BE49-F238E27FC236}">
-                <a16:creationId xmlns:a16="http://schemas.microsoft.com/office/drawing/2014/main" id="{CE5BB29F-2A34-4D68-BC08-2289E93DF6F0}"/>
-              </a:ext>
-            </a:extLst>
-          </p:cNvPr>
-          <p:cNvSpPr>
-            <a:spLocks xmlns:a="http://schemas.openxmlformats.org/drawingml/2006/main" noGrp="1"/>
-          </p:cNvSpPr>
-          <p:nvPr/>
-        </p:nvSpPr>
-        <p:spPr>
-          <a:xfrm xmlns:a="http://schemas.openxmlformats.org/drawingml/2006/main">
-            <a:off x="8401050" y="2095500"/>
-            <a:ext cx="2800350" cy="304800"/>
-          </a:xfrm>
-          <a:prstGeom xmlns:a="http://schemas.openxmlformats.org/drawingml/2006/main" prst="rect">
-            <a:avLst/>
-          </a:prstGeom>
-          <a:noFill xmlns:a="http://schemas.openxmlformats.org/drawingml/2006/main"/>
-          <a:ln xmlns:a="http://schemas.openxmlformats.org/drawingml/2006/main" w="0">
-            <a:noFill/>
-            <a:prstDash val="solid"/>
-          </a:ln>
-        </p:spPr>
-        <p:txBody>
-          <a:bodyPr xmlns:a="http://schemas.openxmlformats.org/drawingml/2006/main"/>
-          <a:lstStyle xmlns:a="http://schemas.openxmlformats.org/drawingml/2006/main"/>
-          <a:p xmlns:a="http://schemas.openxmlformats.org/drawingml/2006/main">
-            <a:pPr algn="l">
-              <a:defRPr sz="1875" b="1">
-                <a:solidFill>
-                  <a:srgbClr val="1F8A8A"/>
-                </a:solidFill>
-              </a:defRPr>
-            </a:pPr>
-            <a:r>
-              <a:rPr sz="1875" b="1">
-                <a:solidFill>
-                  <a:srgbClr val="1F8A8A"/>
+          <a:ln xmlns:a="http://schemas.openxmlformats.org/drawingml/2006/main" w="0">
+            <a:noFill/>
+            <a:prstDash val="solid"/>
+          </a:ln>
+        </p:spPr>
+      </p:sp>
+      <p:sp>
+        <p:nvSpPr>
+          <p:cNvPr id="13" name="">
+            <a:extLst xmlns:a="http://schemas.openxmlformats.org/drawingml/2006/main">
+              <a:ext uri="{FF2B5EF4-FFF2-40B4-BE49-F238E27FC236}">
+                <a16:creationId xmlns:a16="http://schemas.microsoft.com/office/drawing/2014/main" id="{7B5425B4-8607-4986-9882-EB66EAB6CC2F}"/>
+              </a:ext>
+            </a:extLst>
+          </p:cNvPr>
+          <p:cNvSpPr>
+            <a:spLocks xmlns:a="http://schemas.openxmlformats.org/drawingml/2006/main" noGrp="1"/>
+          </p:cNvSpPr>
+          <p:nvPr/>
+        </p:nvSpPr>
+        <p:spPr>
+          <a:xfrm xmlns:a="http://schemas.openxmlformats.org/drawingml/2006/main">
+            <a:off x="7429500" y="4191000"/>
+            <a:ext cx="3238500" cy="257175"/>
+          </a:xfrm>
+          <a:prstGeom xmlns:a="http://schemas.openxmlformats.org/drawingml/2006/main" prst="rect">
+            <a:avLst/>
+          </a:prstGeom>
+          <a:noFill xmlns:a="http://schemas.openxmlformats.org/drawingml/2006/main"/>
+          <a:ln xmlns:a="http://schemas.openxmlformats.org/drawingml/2006/main" w="0">
+            <a:noFill/>
+            <a:prstDash val="solid"/>
+          </a:ln>
+        </p:spPr>
+        <p:txBody>
+          <a:bodyPr xmlns:a="http://schemas.openxmlformats.org/drawingml/2006/main"/>
+          <a:lstStyle xmlns:a="http://schemas.openxmlformats.org/drawingml/2006/main"/>
+          <a:p xmlns:a="http://schemas.openxmlformats.org/drawingml/2006/main">
+            <a:pPr algn="l">
+              <a:defRPr sz="1650" b="1">
+                <a:solidFill>
+                  <a:srgbClr val="0B2F59"/>
+                </a:solidFill>
+              </a:defRPr>
+            </a:pPr>
+            <a:r>
+              <a:rPr sz="1650" b="1">
+                <a:solidFill>
+                  <a:srgbClr val="0B2F59"/>
                 </a:solidFill>
               </a:rPr>
               <a:t>系統層級</a:t>
@@ -13289,45 +13536,45 @@
       </p:sp>
       <p:sp>
         <p:nvSpPr>
-          <p:cNvPr id="12" name="">
-            <a:extLst xmlns:a="http://schemas.openxmlformats.org/drawingml/2006/main">
-              <a:ext uri="{FF2B5EF4-FFF2-40B4-BE49-F238E27FC236}">
-                <a16:creationId xmlns:a16="http://schemas.microsoft.com/office/drawing/2014/main" id="{C0CF47EF-2757-4FA3-9EA7-E87237E5DEEB}"/>
-              </a:ext>
-            </a:extLst>
-          </p:cNvPr>
-          <p:cNvSpPr>
-            <a:spLocks xmlns:a="http://schemas.openxmlformats.org/drawingml/2006/main" noGrp="1"/>
-          </p:cNvSpPr>
-          <p:nvPr/>
-        </p:nvSpPr>
-        <p:spPr>
-          <a:xfrm xmlns:a="http://schemas.openxmlformats.org/drawingml/2006/main">
-            <a:off x="8401050" y="2628900"/>
-            <a:ext cx="2800350" cy="1257300"/>
-          </a:xfrm>
-          <a:prstGeom xmlns:a="http://schemas.openxmlformats.org/drawingml/2006/main" prst="rect">
-            <a:avLst/>
-          </a:prstGeom>
-          <a:noFill xmlns:a="http://schemas.openxmlformats.org/drawingml/2006/main"/>
-          <a:ln xmlns:a="http://schemas.openxmlformats.org/drawingml/2006/main" w="0">
-            <a:noFill/>
-            <a:prstDash val="solid"/>
-          </a:ln>
-        </p:spPr>
-        <p:txBody>
-          <a:bodyPr xmlns:a="http://schemas.openxmlformats.org/drawingml/2006/main"/>
-          <a:lstStyle xmlns:a="http://schemas.openxmlformats.org/drawingml/2006/main"/>
-          <a:p xmlns:a="http://schemas.openxmlformats.org/drawingml/2006/main">
-            <a:pPr algn="l">
-              <a:defRPr sz="1650" b="0">
+          <p:cNvPr id="14" name="">
+            <a:extLst xmlns:a="http://schemas.openxmlformats.org/drawingml/2006/main">
+              <a:ext uri="{FF2B5EF4-FFF2-40B4-BE49-F238E27FC236}">
+                <a16:creationId xmlns:a16="http://schemas.microsoft.com/office/drawing/2014/main" id="{53D034EE-12AA-4CE1-B84D-737DCE296E54}"/>
+              </a:ext>
+            </a:extLst>
+          </p:cNvPr>
+          <p:cNvSpPr>
+            <a:spLocks xmlns:a="http://schemas.openxmlformats.org/drawingml/2006/main" noGrp="1"/>
+          </p:cNvSpPr>
+          <p:nvPr/>
+        </p:nvSpPr>
+        <p:spPr>
+          <a:xfrm xmlns:a="http://schemas.openxmlformats.org/drawingml/2006/main">
+            <a:off x="7429500" y="4495800"/>
+            <a:ext cx="3333750" cy="495300"/>
+          </a:xfrm>
+          <a:prstGeom xmlns:a="http://schemas.openxmlformats.org/drawingml/2006/main" prst="rect">
+            <a:avLst/>
+          </a:prstGeom>
+          <a:noFill xmlns:a="http://schemas.openxmlformats.org/drawingml/2006/main"/>
+          <a:ln xmlns:a="http://schemas.openxmlformats.org/drawingml/2006/main" w="0">
+            <a:noFill/>
+            <a:prstDash val="solid"/>
+          </a:ln>
+        </p:spPr>
+        <p:txBody>
+          <a:bodyPr xmlns:a="http://schemas.openxmlformats.org/drawingml/2006/main"/>
+          <a:lstStyle xmlns:a="http://schemas.openxmlformats.org/drawingml/2006/main"/>
+          <a:p xmlns:a="http://schemas.openxmlformats.org/drawingml/2006/main">
+            <a:pPr algn="l">
+              <a:defRPr sz="1275" b="0">
                 <a:solidFill>
                   <a:srgbClr val="182230"/>
                 </a:solidFill>
               </a:defRPr>
             </a:pPr>
             <a:r>
-              <a:rPr sz="1650" b="0">
+              <a:rPr sz="1275" b="0">
                 <a:solidFill>
                   <a:srgbClr val="182230"/>
                 </a:solidFill>
@@ -13339,80 +13586,76 @@
       </p:sp>
       <p:sp>
         <p:nvSpPr>
-          <p:cNvPr id="13" name="">
-            <a:extLst xmlns:a="http://schemas.openxmlformats.org/drawingml/2006/main">
-              <a:ext uri="{FF2B5EF4-FFF2-40B4-BE49-F238E27FC236}">
-                <a16:creationId xmlns:a16="http://schemas.microsoft.com/office/drawing/2014/main" id="{0E51CA47-8F6F-43BA-84CB-4F8EB9C30C2F}"/>
-              </a:ext>
-            </a:extLst>
-          </p:cNvPr>
-          <p:cNvSpPr>
-            <a:spLocks xmlns:a="http://schemas.openxmlformats.org/drawingml/2006/main" noGrp="1"/>
-          </p:cNvSpPr>
-          <p:nvPr/>
-        </p:nvSpPr>
-        <p:spPr>
-          <a:xfrm xmlns:a="http://schemas.openxmlformats.org/drawingml/2006/main">
-            <a:off x="1028700" y="5257800"/>
-            <a:ext cx="9525000" cy="647700"/>
-          </a:xfrm>
-          <a:prstGeom xmlns:a="http://schemas.openxmlformats.org/drawingml/2006/main" prst="roundRect">
-            <a:avLst>
-              <a:gd name="adj" fmla="val 11765"/>
-            </a:avLst>
+          <p:cNvPr id="15" name="">
+            <a:extLst xmlns:a="http://schemas.openxmlformats.org/drawingml/2006/main">
+              <a:ext uri="{FF2B5EF4-FFF2-40B4-BE49-F238E27FC236}">
+                <a16:creationId xmlns:a16="http://schemas.microsoft.com/office/drawing/2014/main" id="{3A591CFB-B461-4654-80B0-A8CEBF457A0B}"/>
+              </a:ext>
+            </a:extLst>
+          </p:cNvPr>
+          <p:cNvSpPr>
+            <a:spLocks xmlns:a="http://schemas.openxmlformats.org/drawingml/2006/main" noGrp="1"/>
+          </p:cNvSpPr>
+          <p:nvPr/>
+        </p:nvSpPr>
+        <p:spPr>
+          <a:xfrm xmlns:a="http://schemas.openxmlformats.org/drawingml/2006/main">
+            <a:off x="7124700" y="5353050"/>
+            <a:ext cx="3714750" cy="19050"/>
+          </a:xfrm>
+          <a:prstGeom xmlns:a="http://schemas.openxmlformats.org/drawingml/2006/main" prst="rect">
+            <a:avLst/>
           </a:prstGeom>
           <a:solidFill xmlns:a="http://schemas.openxmlformats.org/drawingml/2006/main">
-            <a:srgbClr val="FFF8EA"/>
+            <a:srgbClr val="C77D0E"/>
           </a:solidFill>
-          <a:ln xmlns:a="http://schemas.openxmlformats.org/drawingml/2006/main" w="9525">
-            <a:solidFill>
-              <a:srgbClr val="EDC56D"/>
-            </a:solidFill>
-            <a:prstDash val="solid"/>
-          </a:ln>
-        </p:spPr>
-      </p:sp>
-      <p:sp>
-        <p:nvSpPr>
-          <p:cNvPr id="14" name="">
-            <a:extLst xmlns:a="http://schemas.openxmlformats.org/drawingml/2006/main">
-              <a:ext uri="{FF2B5EF4-FFF2-40B4-BE49-F238E27FC236}">
-                <a16:creationId xmlns:a16="http://schemas.microsoft.com/office/drawing/2014/main" id="{BB2FD599-8565-4918-AB62-C0122150DD75}"/>
-              </a:ext>
-            </a:extLst>
-          </p:cNvPr>
-          <p:cNvSpPr>
-            <a:spLocks xmlns:a="http://schemas.openxmlformats.org/drawingml/2006/main" noGrp="1"/>
-          </p:cNvSpPr>
-          <p:nvPr/>
-        </p:nvSpPr>
-        <p:spPr>
-          <a:xfrm xmlns:a="http://schemas.openxmlformats.org/drawingml/2006/main">
-            <a:off x="1295400" y="5429250"/>
-            <a:ext cx="8991600" cy="285750"/>
-          </a:xfrm>
-          <a:prstGeom xmlns:a="http://schemas.openxmlformats.org/drawingml/2006/main" prst="rect">
-            <a:avLst/>
-          </a:prstGeom>
-          <a:noFill xmlns:a="http://schemas.openxmlformats.org/drawingml/2006/main"/>
-          <a:ln xmlns:a="http://schemas.openxmlformats.org/drawingml/2006/main" w="0">
-            <a:noFill/>
-            <a:prstDash val="solid"/>
-          </a:ln>
-        </p:spPr>
-        <p:txBody>
-          <a:bodyPr xmlns:a="http://schemas.openxmlformats.org/drawingml/2006/main"/>
-          <a:lstStyle xmlns:a="http://schemas.openxmlformats.org/drawingml/2006/main"/>
-          <a:p xmlns:a="http://schemas.openxmlformats.org/drawingml/2006/main">
-            <a:pPr algn="ctr">
-              <a:defRPr sz="1725" b="1">
+          <a:ln xmlns:a="http://schemas.openxmlformats.org/drawingml/2006/main" w="0">
+            <a:noFill/>
+            <a:prstDash val="solid"/>
+          </a:ln>
+        </p:spPr>
+      </p:sp>
+      <p:sp>
+        <p:nvSpPr>
+          <p:cNvPr id="16" name="">
+            <a:extLst xmlns:a="http://schemas.openxmlformats.org/drawingml/2006/main">
+              <a:ext uri="{FF2B5EF4-FFF2-40B4-BE49-F238E27FC236}">
+                <a16:creationId xmlns:a16="http://schemas.microsoft.com/office/drawing/2014/main" id="{6EB5C8D2-3A67-4186-8992-9331F241574F}"/>
+              </a:ext>
+            </a:extLst>
+          </p:cNvPr>
+          <p:cNvSpPr>
+            <a:spLocks xmlns:a="http://schemas.openxmlformats.org/drawingml/2006/main" noGrp="1"/>
+          </p:cNvSpPr>
+          <p:nvPr/>
+        </p:nvSpPr>
+        <p:spPr>
+          <a:xfrm xmlns:a="http://schemas.openxmlformats.org/drawingml/2006/main">
+            <a:off x="7124700" y="5505450"/>
+            <a:ext cx="3676650" cy="457200"/>
+          </a:xfrm>
+          <a:prstGeom xmlns:a="http://schemas.openxmlformats.org/drawingml/2006/main" prst="rect">
+            <a:avLst/>
+          </a:prstGeom>
+          <a:noFill xmlns:a="http://schemas.openxmlformats.org/drawingml/2006/main"/>
+          <a:ln xmlns:a="http://schemas.openxmlformats.org/drawingml/2006/main" w="0">
+            <a:noFill/>
+            <a:prstDash val="solid"/>
+          </a:ln>
+        </p:spPr>
+        <p:txBody>
+          <a:bodyPr xmlns:a="http://schemas.openxmlformats.org/drawingml/2006/main"/>
+          <a:lstStyle xmlns:a="http://schemas.openxmlformats.org/drawingml/2006/main"/>
+          <a:p xmlns:a="http://schemas.openxmlformats.org/drawingml/2006/main">
+            <a:pPr algn="l">
+              <a:defRPr sz="1350" b="1">
                 <a:solidFill>
                   <a:srgbClr val="0B2F59"/>
                 </a:solidFill>
               </a:defRPr>
             </a:pPr>
             <a:r>
-              <a:rPr sz="1725" b="1">
+              <a:rPr sz="1350" b="1">
                 <a:solidFill>
                   <a:srgbClr val="0B2F59"/>
                 </a:solidFill>
@@ -13424,10 +13667,60 @@
       </p:sp>
       <p:sp>
         <p:nvSpPr>
-          <p:cNvPr id="15" name="">
-            <a:extLst xmlns:a="http://schemas.openxmlformats.org/drawingml/2006/main">
-              <a:ext uri="{FF2B5EF4-FFF2-40B4-BE49-F238E27FC236}">
-                <a16:creationId xmlns:a16="http://schemas.microsoft.com/office/drawing/2014/main" id="{7BD88913-6944-4B94-9817-C070E161B3AF}"/>
+          <p:cNvPr id="17" name="">
+            <a:extLst xmlns:a="http://schemas.openxmlformats.org/drawingml/2006/main">
+              <a:ext uri="{FF2B5EF4-FFF2-40B4-BE49-F238E27FC236}">
+                <a16:creationId xmlns:a16="http://schemas.microsoft.com/office/drawing/2014/main" id="{8DD3514C-13C8-4B5B-97B0-1C1D9588DF03}"/>
+              </a:ext>
+            </a:extLst>
+          </p:cNvPr>
+          <p:cNvSpPr>
+            <a:spLocks xmlns:a="http://schemas.openxmlformats.org/drawingml/2006/main" noGrp="1"/>
+          </p:cNvSpPr>
+          <p:nvPr/>
+        </p:nvSpPr>
+        <p:spPr>
+          <a:xfrm xmlns:a="http://schemas.openxmlformats.org/drawingml/2006/main">
+            <a:off x="685800" y="6019800"/>
+            <a:ext cx="9239250" cy="171450"/>
+          </a:xfrm>
+          <a:prstGeom xmlns:a="http://schemas.openxmlformats.org/drawingml/2006/main" prst="rect">
+            <a:avLst/>
+          </a:prstGeom>
+          <a:noFill xmlns:a="http://schemas.openxmlformats.org/drawingml/2006/main"/>
+          <a:ln xmlns:a="http://schemas.openxmlformats.org/drawingml/2006/main" w="0">
+            <a:noFill/>
+            <a:prstDash val="solid"/>
+          </a:ln>
+        </p:spPr>
+        <p:txBody>
+          <a:bodyPr xmlns:a="http://schemas.openxmlformats.org/drawingml/2006/main"/>
+          <a:lstStyle xmlns:a="http://schemas.openxmlformats.org/drawingml/2006/main"/>
+          <a:p xmlns:a="http://schemas.openxmlformats.org/drawingml/2006/main">
+            <a:pPr algn="l">
+              <a:defRPr sz="825" b="0">
+                <a:solidFill>
+                  <a:srgbClr val="667085"/>
+                </a:solidFill>
+              </a:defRPr>
+            </a:pPr>
+            <a:r>
+              <a:rPr sz="825" b="0">
+                <a:solidFill>
+                  <a:srgbClr val="667085"/>
+                </a:solidFill>
+              </a:rPr>
+              <a:t>Figure 2. Lewsey et al., Circulation 2026. 原圖保留英文標示以維持原始內容。</a:t>
+            </a:r>
+          </a:p>
+        </p:txBody>
+      </p:sp>
+      <p:sp>
+        <p:nvSpPr>
+          <p:cNvPr id="18" name="">
+            <a:extLst xmlns:a="http://schemas.openxmlformats.org/drawingml/2006/main">
+              <a:ext uri="{FF2B5EF4-FFF2-40B4-BE49-F238E27FC236}">
+                <a16:creationId xmlns:a16="http://schemas.microsoft.com/office/drawing/2014/main" id="{B05E992A-49A0-464E-9F30-F169FFA302FB}"/>
               </a:ext>
             </a:extLst>
           </p:cNvPr>
@@ -13474,10 +13767,10 @@
       </p:sp>
       <p:sp>
         <p:nvSpPr>
-          <p:cNvPr id="16" name="">
-            <a:extLst xmlns:a="http://schemas.openxmlformats.org/drawingml/2006/main">
-              <a:ext uri="{FF2B5EF4-FFF2-40B4-BE49-F238E27FC236}">
-                <a16:creationId xmlns:a16="http://schemas.microsoft.com/office/drawing/2014/main" id="{4D60E73E-E391-4B72-A520-FD1E23101A4E}"/>
+          <p:cNvPr id="19" name="">
+            <a:extLst xmlns:a="http://schemas.openxmlformats.org/drawingml/2006/main">
+              <a:ext uri="{FF2B5EF4-FFF2-40B4-BE49-F238E27FC236}">
+                <a16:creationId xmlns:a16="http://schemas.microsoft.com/office/drawing/2014/main" id="{CFBC0C0D-901C-4B52-AA87-B9AE379B89FB}"/>
               </a:ext>
             </a:extLst>
           </p:cNvPr>
@@ -13524,10 +13817,10 @@
       </p:sp>
       <p:sp>
         <p:nvSpPr>
-          <p:cNvPr id="17" name="">
-            <a:extLst xmlns:a="http://schemas.openxmlformats.org/drawingml/2006/main">
-              <a:ext uri="{FF2B5EF4-FFF2-40B4-BE49-F238E27FC236}">
-                <a16:creationId xmlns:a16="http://schemas.microsoft.com/office/drawing/2014/main" id="{33D1A520-A485-4AC2-B90D-EC2C45F28A51}"/>
+          <p:cNvPr id="20" name="">
+            <a:extLst xmlns:a="http://schemas.openxmlformats.org/drawingml/2006/main">
+              <a:ext uri="{FF2B5EF4-FFF2-40B4-BE49-F238E27FC236}">
+                <a16:creationId xmlns:a16="http://schemas.microsoft.com/office/drawing/2014/main" id="{09E5ED72-3D30-4552-9D4F-28A14AA2A1BF}"/>
               </a:ext>
             </a:extLst>
           </p:cNvPr>
@@ -13561,10 +13854,10 @@
       </p:sp>
       <p:sp>
         <p:nvSpPr>
-          <p:cNvPr id="18" name="">
-            <a:extLst xmlns:a="http://schemas.openxmlformats.org/drawingml/2006/main">
-              <a:ext uri="{FF2B5EF4-FFF2-40B4-BE49-F238E27FC236}">
-                <a16:creationId xmlns:a16="http://schemas.microsoft.com/office/drawing/2014/main" id="{2BCB59B6-4176-449D-A205-B2E854C689C2}"/>
+          <p:cNvPr id="21" name="">
+            <a:extLst xmlns:a="http://schemas.openxmlformats.org/drawingml/2006/main">
+              <a:ext uri="{FF2B5EF4-FFF2-40B4-BE49-F238E27FC236}">
+                <a16:creationId xmlns:a16="http://schemas.microsoft.com/office/drawing/2014/main" id="{14A43C39-5EBB-44AA-838E-EE1C9476FFCF}"/>
               </a:ext>
             </a:extLst>
           </p:cNvPr>
@@ -13612,7 +13905,7 @@
     </p:spTree>
     <p:extLst>
       <p:ext uri="{BB962C8B-B14F-4D97-AF65-F5344CB8AC3E}">
-        <p14:creationId xmlns:p14="http://schemas.microsoft.com/office/powerpoint/2010/main" val="729970290"/>
+        <p14:creationId xmlns:p14="http://schemas.microsoft.com/office/powerpoint/2010/main" val="41019237"/>
       </p:ext>
     </p:extLst>
   </p:cSld>
@@ -13643,7 +13936,7 @@
           <p:cNvPr id="1" name="">
             <a:extLst xmlns:a="http://schemas.openxmlformats.org/drawingml/2006/main">
               <a:ext uri="{FF2B5EF4-FFF2-40B4-BE49-F238E27FC236}">
-                <a16:creationId xmlns:a16="http://schemas.microsoft.com/office/drawing/2014/main" id="{496696B2-229C-416C-88F0-6EFF445A74A2}"/>
+                <a16:creationId xmlns:a16="http://schemas.microsoft.com/office/drawing/2014/main" id="{9F962A4A-11B5-4779-973F-F3C61218D0A7}"/>
               </a:ext>
             </a:extLst>
           </p:cNvPr>
@@ -13693,7 +13986,7 @@
           <p:cNvPr id="2" name="">
             <a:extLst xmlns:a="http://schemas.openxmlformats.org/drawingml/2006/main">
               <a:ext uri="{FF2B5EF4-FFF2-40B4-BE49-F238E27FC236}">
-                <a16:creationId xmlns:a16="http://schemas.microsoft.com/office/drawing/2014/main" id="{AE9D1DD5-AD83-4B0E-BE2D-A7648DE14220}"/>
+                <a16:creationId xmlns:a16="http://schemas.microsoft.com/office/drawing/2014/main" id="{F3E98D97-CF60-49B8-8342-1F813981C2FE}"/>
               </a:ext>
             </a:extLst>
           </p:cNvPr>
@@ -13743,7 +14036,7 @@
           <p:cNvPr id="3" name="">
             <a:extLst xmlns:a="http://schemas.openxmlformats.org/drawingml/2006/main">
               <a:ext uri="{FF2B5EF4-FFF2-40B4-BE49-F238E27FC236}">
-                <a16:creationId xmlns:a16="http://schemas.microsoft.com/office/drawing/2014/main" id="{941DD1EB-4A6D-471F-A78F-B3C063EEC911}"/>
+                <a16:creationId xmlns:a16="http://schemas.microsoft.com/office/drawing/2014/main" id="{EF120B84-0B83-4E1F-821A-97235E8591F1}"/>
               </a:ext>
             </a:extLst>
           </p:cNvPr>
@@ -13774,7 +14067,7 @@
           <p:cNvPr id="4" name="">
             <a:extLst xmlns:a="http://schemas.openxmlformats.org/drawingml/2006/main">
               <a:ext uri="{FF2B5EF4-FFF2-40B4-BE49-F238E27FC236}">
-                <a16:creationId xmlns:a16="http://schemas.microsoft.com/office/drawing/2014/main" id="{839AF8E5-35AA-4A6D-971D-F042F85EC34D}"/>
+                <a16:creationId xmlns:a16="http://schemas.microsoft.com/office/drawing/2014/main" id="{CD22C39B-C61B-4FD5-A592-3A4003B9835C}"/>
               </a:ext>
             </a:extLst>
           </p:cNvPr>
@@ -13824,7 +14117,7 @@
           <p:cNvPr id="5" name="">
             <a:extLst xmlns:a="http://schemas.openxmlformats.org/drawingml/2006/main">
               <a:ext uri="{FF2B5EF4-FFF2-40B4-BE49-F238E27FC236}">
-                <a16:creationId xmlns:a16="http://schemas.microsoft.com/office/drawing/2014/main" id="{AD4402AE-35DA-4EF1-BFA0-B4073FA01B8C}"/>
+                <a16:creationId xmlns:a16="http://schemas.microsoft.com/office/drawing/2014/main" id="{B7335FBD-D528-4E15-9BD0-E3965995211A}"/>
               </a:ext>
             </a:extLst>
           </p:cNvPr>
@@ -13874,7 +14167,7 @@
           <p:cNvPr id="6" name="">
             <a:extLst xmlns:a="http://schemas.openxmlformats.org/drawingml/2006/main">
               <a:ext uri="{FF2B5EF4-FFF2-40B4-BE49-F238E27FC236}">
-                <a16:creationId xmlns:a16="http://schemas.microsoft.com/office/drawing/2014/main" id="{C935B069-0298-46BA-AA98-8BC923D10F30}"/>
+                <a16:creationId xmlns:a16="http://schemas.microsoft.com/office/drawing/2014/main" id="{B570EB54-E231-4B00-A28D-18ACF533C4C7}"/>
               </a:ext>
             </a:extLst>
           </p:cNvPr>
@@ -13924,7 +14217,7 @@
           <p:cNvPr id="7" name="">
             <a:extLst xmlns:a="http://schemas.openxmlformats.org/drawingml/2006/main">
               <a:ext uri="{FF2B5EF4-FFF2-40B4-BE49-F238E27FC236}">
-                <a16:creationId xmlns:a16="http://schemas.microsoft.com/office/drawing/2014/main" id="{886F7964-5BD2-4CDE-BAA5-4E4CAC9A8883}"/>
+                <a16:creationId xmlns:a16="http://schemas.microsoft.com/office/drawing/2014/main" id="{27722877-F7FF-4EA2-B423-FC5C3C910D8F}"/>
               </a:ext>
             </a:extLst>
           </p:cNvPr>
@@ -13974,7 +14267,7 @@
           <p:cNvPr id="8" name="">
             <a:extLst xmlns:a="http://schemas.openxmlformats.org/drawingml/2006/main">
               <a:ext uri="{FF2B5EF4-FFF2-40B4-BE49-F238E27FC236}">
-                <a16:creationId xmlns:a16="http://schemas.microsoft.com/office/drawing/2014/main" id="{2E5374A0-C9A8-4AD7-B289-985F6BFC54CB}"/>
+                <a16:creationId xmlns:a16="http://schemas.microsoft.com/office/drawing/2014/main" id="{0C56CE7A-64A4-4C89-8E0B-76381CE7F10B}"/>
               </a:ext>
             </a:extLst>
           </p:cNvPr>
@@ -14024,7 +14317,7 @@
           <p:cNvPr id="9" name="">
             <a:extLst xmlns:a="http://schemas.openxmlformats.org/drawingml/2006/main">
               <a:ext uri="{FF2B5EF4-FFF2-40B4-BE49-F238E27FC236}">
-                <a16:creationId xmlns:a16="http://schemas.microsoft.com/office/drawing/2014/main" id="{10800F63-0C60-4FEB-B167-4A1C920B8B11}"/>
+                <a16:creationId xmlns:a16="http://schemas.microsoft.com/office/drawing/2014/main" id="{003AB9D1-2EBC-465B-B24B-19E76E307F41}"/>
               </a:ext>
             </a:extLst>
           </p:cNvPr>
@@ -14074,7 +14367,7 @@
           <p:cNvPr id="10" name="">
             <a:extLst xmlns:a="http://schemas.openxmlformats.org/drawingml/2006/main">
               <a:ext uri="{FF2B5EF4-FFF2-40B4-BE49-F238E27FC236}">
-                <a16:creationId xmlns:a16="http://schemas.microsoft.com/office/drawing/2014/main" id="{BC58E586-F300-45D1-82FC-F45FACC79A20}"/>
+                <a16:creationId xmlns:a16="http://schemas.microsoft.com/office/drawing/2014/main" id="{1C0FD4BB-D9C1-4CF2-80BC-24B9B95767C0}"/>
               </a:ext>
             </a:extLst>
           </p:cNvPr>
@@ -14109,7 +14402,7 @@
           <p:cNvPr id="11" name="">
             <a:extLst xmlns:a="http://schemas.openxmlformats.org/drawingml/2006/main">
               <a:ext uri="{FF2B5EF4-FFF2-40B4-BE49-F238E27FC236}">
-                <a16:creationId xmlns:a16="http://schemas.microsoft.com/office/drawing/2014/main" id="{BE266A92-1921-473A-AE16-E573660E81B2}"/>
+                <a16:creationId xmlns:a16="http://schemas.microsoft.com/office/drawing/2014/main" id="{BAB9F323-BC05-484C-AEA2-7A34812F0217}"/>
               </a:ext>
             </a:extLst>
           </p:cNvPr>
@@ -14159,7 +14452,7 @@
           <p:cNvPr id="12" name="">
             <a:extLst xmlns:a="http://schemas.openxmlformats.org/drawingml/2006/main">
               <a:ext uri="{FF2B5EF4-FFF2-40B4-BE49-F238E27FC236}">
-                <a16:creationId xmlns:a16="http://schemas.microsoft.com/office/drawing/2014/main" id="{6741583C-2190-453F-8AC3-688EDE292B3F}"/>
+                <a16:creationId xmlns:a16="http://schemas.microsoft.com/office/drawing/2014/main" id="{5021D06B-E4FF-4F0E-8FE0-835E68C8C09E}"/>
               </a:ext>
             </a:extLst>
           </p:cNvPr>
@@ -14209,7 +14502,7 @@
           <p:cNvPr id="13" name="">
             <a:extLst xmlns:a="http://schemas.openxmlformats.org/drawingml/2006/main">
               <a:ext uri="{FF2B5EF4-FFF2-40B4-BE49-F238E27FC236}">
-                <a16:creationId xmlns:a16="http://schemas.microsoft.com/office/drawing/2014/main" id="{6BFB7448-F041-44F9-9BF9-043EFA88BE4B}"/>
+                <a16:creationId xmlns:a16="http://schemas.microsoft.com/office/drawing/2014/main" id="{770D5C15-413C-468F-813B-ECE89DDB78CF}"/>
               </a:ext>
             </a:extLst>
           </p:cNvPr>
@@ -14259,7 +14552,7 @@
           <p:cNvPr id="14" name="">
             <a:extLst xmlns:a="http://schemas.openxmlformats.org/drawingml/2006/main">
               <a:ext uri="{FF2B5EF4-FFF2-40B4-BE49-F238E27FC236}">
-                <a16:creationId xmlns:a16="http://schemas.microsoft.com/office/drawing/2014/main" id="{666CAACA-8A3E-407F-A143-E07BA4AB0F9E}"/>
+                <a16:creationId xmlns:a16="http://schemas.microsoft.com/office/drawing/2014/main" id="{1ADF7EF8-9A42-4EB9-BEE0-F6678379A2E8}"/>
               </a:ext>
             </a:extLst>
           </p:cNvPr>
@@ -14296,7 +14589,7 @@
           <p:cNvPr id="15" name="">
             <a:extLst xmlns:a="http://schemas.openxmlformats.org/drawingml/2006/main">
               <a:ext uri="{FF2B5EF4-FFF2-40B4-BE49-F238E27FC236}">
-                <a16:creationId xmlns:a16="http://schemas.microsoft.com/office/drawing/2014/main" id="{1CD7D080-568B-4C13-85F9-472478750039}"/>
+                <a16:creationId xmlns:a16="http://schemas.microsoft.com/office/drawing/2014/main" id="{A5278E32-0EBE-449B-8D60-D53CADC3B849}"/>
               </a:ext>
             </a:extLst>
           </p:cNvPr>
@@ -14344,7 +14637,7 @@
     </p:spTree>
     <p:extLst>
       <p:ext uri="{BB962C8B-B14F-4D97-AF65-F5344CB8AC3E}">
-        <p14:creationId xmlns:p14="http://schemas.microsoft.com/office/powerpoint/2010/main" val="1515169029"/>
+        <p14:creationId xmlns:p14="http://schemas.microsoft.com/office/powerpoint/2010/main" val="940347978"/>
       </p:ext>
     </p:extLst>
   </p:cSld>

</xml_diff>